<commit_message>
Slide 10: GitHub and Slack dashboard screenshots with original placeholders
Co-Authored-By: Claude Opus 5.5 <noreply@anthropic.com>
</commit_message>
<xml_diff>
--- a/presentation/project.pptx
+++ b/presentation/project.pptx
@@ -3647,20 +3647,14 @@
       </p:sp>
       <p:sp>
         <p:nvSpPr>
-          <p:cNvPr id="3" name="Rectangle: Rounded Corners 2">
-            <a:extLst>
-              <a:ext uri="{FF2B5EF4-FFF2-40B4-BE49-F238E27FC236}">
-                <a16:creationId xmlns:a16="http://schemas.microsoft.com/office/drawing/2014/main" id="{19EC0781-3A3A-9980-E688-BC9A54D7EDBC}"/>
-              </a:ext>
-            </a:extLst>
-          </p:cNvPr>
+          <p:cNvPr id="3" name="Original placeholder 3"/>
           <p:cNvSpPr/>
           <p:nvPr/>
         </p:nvSpPr>
         <p:spPr>
           <a:xfrm>
-            <a:off x="609600" y="1397000"/>
-            <a:ext cx="5334000" cy="3683000"/>
+            <a:off x="609600" y="1193800"/>
+            <a:ext cx="4754880" cy="2161309"/>
           </a:xfrm>
           <a:prstGeom prst="roundRect">
             <a:avLst>
@@ -3700,140 +3694,82 @@
           <a:lstStyle/>
           <a:p>
             <a:pPr algn="ctr"/>
-            <a:endParaRPr lang="en-US"/>
-          </a:p>
-        </p:txBody>
-      </p:sp>
-      <p:sp>
-        <p:nvSpPr>
-          <p:cNvPr id="4" name="TextBox 3">
-            <a:extLst>
-              <a:ext uri="{FF2B5EF4-FFF2-40B4-BE49-F238E27FC236}">
-                <a16:creationId xmlns:a16="http://schemas.microsoft.com/office/drawing/2014/main" id="{41519355-F7EF-2400-4436-BCFE42217EDA}"/>
-              </a:ext>
-            </a:extLst>
-          </p:cNvPr>
-          <p:cNvSpPr txBox="1"/>
-          <p:nvPr/>
-        </p:nvSpPr>
-        <p:spPr>
-          <a:xfrm>
-            <a:off x="914400" y="1701800"/>
-            <a:ext cx="4724400" cy="431800"/>
+            <a:r>
+              <a:rPr lang="en-US" sz="2400" b="1">
+                <a:solidFill>
+                  <a:srgbClr val="1B2631"/>
+                </a:solidFill>
+                <a:latin typeface="Calibri" panose="020F0502020204030204" pitchFamily="34" charset="0"/>
+              </a:rPr>
+              <a:t>Original in GitHub</a:t>
+            </a:r>
+          </a:p>
+          <a:p>
+            <a:pPr algn="ctr">
+              <a:spcBef>
+                <a:spcPts val="600"/>
+              </a:spcBef>
+            </a:pPr>
+            <a:r>
+              <a:rPr lang="en-US" sz="1400">
+                <a:solidFill>
+                  <a:srgbClr val="5D6D7E"/>
+                </a:solidFill>
+                <a:latin typeface="Calibri" panose="020F0502020204030204" pitchFamily="34" charset="0"/>
+              </a:rPr>
+              <a:t>Screenshot placeholder</a:t>
+            </a:r>
+          </a:p>
+        </p:txBody>
+      </p:sp>
+      <p:pic>
+        <p:nvPicPr>
+          <p:cNvPr id="4" name="Dashboard screenshot 4" descr="Dashboard showing GitHub issue #7"/>
+          <p:cNvPicPr>
+            <a:picLocks noChangeAspect="1"/>
+          </p:cNvPicPr>
+          <p:nvPr/>
+        </p:nvPicPr>
+        <p:blipFill>
+          <a:blip r:embed="rId2"/>
+          <a:stretch>
+            <a:fillRect/>
+          </a:stretch>
+        </p:blipFill>
+        <p:spPr>
+          <a:xfrm>
+            <a:off x="6827520" y="1193800"/>
+            <a:ext cx="4754880" cy="2161309"/>
           </a:xfrm>
           <a:prstGeom prst="rect">
             <a:avLst/>
           </a:prstGeom>
-          <a:noFill/>
-        </p:spPr>
-        <p:txBody>
-          <a:bodyPr vert="horz" wrap="square" lIns="0" tIns="0" rIns="0" bIns="0" rtlCol="0">
-            <a:noAutofit/>
-          </a:bodyPr>
-          <a:lstStyle/>
-          <a:p>
-            <a:r>
-              <a:rPr lang="en-US" sz="2400" b="1">
-                <a:solidFill>
-                  <a:srgbClr val="1F7A8C"/>
-                </a:solidFill>
-                <a:latin typeface="Cambria" panose="02040503050406030204" pitchFamily="18" charset="0"/>
-              </a:rPr>
-              <a:t>GitHub</a:t>
-            </a:r>
-          </a:p>
-        </p:txBody>
-      </p:sp>
-      <p:sp>
-        <p:nvSpPr>
-          <p:cNvPr id="5" name="TextBox 4">
-            <a:extLst>
-              <a:ext uri="{FF2B5EF4-FFF2-40B4-BE49-F238E27FC236}">
-                <a16:creationId xmlns:a16="http://schemas.microsoft.com/office/drawing/2014/main" id="{A85F809C-E5B9-D30D-A03B-FFC92C8381DF}"/>
-              </a:ext>
-            </a:extLst>
-          </p:cNvPr>
-          <p:cNvSpPr txBox="1"/>
-          <p:nvPr/>
-        </p:nvSpPr>
-        <p:spPr>
-          <a:xfrm>
-            <a:off x="914400" y="2413000"/>
-            <a:ext cx="4724400" cy="2286000"/>
-          </a:xfrm>
-          <a:prstGeom prst="rect">
+          <a:ln w="12700">
+            <a:solidFill>
+              <a:srgbClr val="C8D0D6"/>
+            </a:solidFill>
+          </a:ln>
+        </p:spPr>
+      </p:pic>
+      <p:sp>
+        <p:nvSpPr>
+          <p:cNvPr id="5" name="Arrow 5"/>
+          <p:cNvSpPr/>
+          <p:nvPr/>
+        </p:nvSpPr>
+        <p:spPr>
+          <a:xfrm>
+            <a:off x="5867400" y="2109354"/>
+            <a:ext cx="457200" cy="330200"/>
+          </a:xfrm>
+          <a:prstGeom prst="ellipse">
             <a:avLst/>
           </a:prstGeom>
-          <a:noFill/>
-        </p:spPr>
-        <p:txBody>
-          <a:bodyPr vert="horz" wrap="square" lIns="0" tIns="0" rIns="0" bIns="0" rtlCol="0">
-            <a:noAutofit/>
-          </a:bodyPr>
-          <a:lstStyle/>
-          <a:p>
-            <a:r>
-              <a:rPr lang="en-US" sz="1700">
-                <a:solidFill>
-                  <a:srgbClr val="5D6D7E"/>
-                </a:solidFill>
-                <a:latin typeface="Calibri" panose="020F0502020204030204" pitchFamily="34" charset="0"/>
-              </a:rPr>
-              <a:t>[Screenshot: original vs. dashboard]</a:t>
-            </a:r>
-          </a:p>
-          <a:p>
-            <a:endParaRPr lang="en-US" sz="1700">
-              <a:solidFill>
-                <a:srgbClr val="5D6D7E"/>
-              </a:solidFill>
-              <a:latin typeface="Calibri" panose="020F0502020204030204" pitchFamily="34" charset="0"/>
-            </a:endParaRPr>
-          </a:p>
-          <a:p>
-            <a:r>
-              <a:rPr lang="en-US" sz="1700">
-                <a:solidFill>
-                  <a:srgbClr val="5D6D7E"/>
-                </a:solidFill>
-                <a:latin typeface="Calibri" panose="020F0502020204030204" pitchFamily="34" charset="0"/>
-              </a:rPr>
-              <a:t>[What was downloaded and how]</a:t>
-            </a:r>
-          </a:p>
-        </p:txBody>
-      </p:sp>
-      <p:sp>
-        <p:nvSpPr>
-          <p:cNvPr id="6" name="Rectangle: Rounded Corners 5">
-            <a:extLst>
-              <a:ext uri="{FF2B5EF4-FFF2-40B4-BE49-F238E27FC236}">
-                <a16:creationId xmlns:a16="http://schemas.microsoft.com/office/drawing/2014/main" id="{3C140A65-DF3D-886C-717D-9F53B2AA46F6}"/>
-              </a:ext>
-            </a:extLst>
-          </p:cNvPr>
-          <p:cNvSpPr/>
-          <p:nvPr/>
-        </p:nvSpPr>
-        <p:spPr>
-          <a:xfrm>
-            <a:off x="6248400" y="1397000"/>
-            <a:ext cx="5334000" cy="3683000"/>
-          </a:xfrm>
-          <a:prstGeom prst="roundRect">
-            <a:avLst>
-              <a:gd name="adj" fmla="val 8000"/>
-            </a:avLst>
-          </a:prstGeom>
           <a:solidFill>
-            <a:srgbClr val="FFFFFF"/>
+            <a:srgbClr val="F2A541"/>
           </a:solidFill>
-          <a:ln w="19050" cap="flat" cmpd="sng" algn="ctr">
-            <a:solidFill>
-              <a:srgbClr val="5D6D7E"/>
-            </a:solidFill>
-            <a:prstDash val="dash"/>
-            <a:miter lim="800000"/>
+          <a:ln>
+            <a:noFill/>
           </a:ln>
           <a:effectLst/>
         </p:spPr>
@@ -3858,26 +3794,28 @@
           <a:lstStyle/>
           <a:p>
             <a:pPr algn="ctr"/>
-            <a:endParaRPr lang="en-US"/>
-          </a:p>
-        </p:txBody>
-      </p:sp>
-      <p:sp>
-        <p:nvSpPr>
-          <p:cNvPr id="7" name="TextBox 6">
-            <a:extLst>
-              <a:ext uri="{FF2B5EF4-FFF2-40B4-BE49-F238E27FC236}">
-                <a16:creationId xmlns:a16="http://schemas.microsoft.com/office/drawing/2014/main" id="{825521AD-8114-9594-0277-82793F5D7011}"/>
-              </a:ext>
-            </a:extLst>
-          </p:cNvPr>
+            <a:r>
+              <a:rPr lang="en-US" sz="1600" b="1">
+                <a:solidFill>
+                  <a:srgbClr val="FFFFFF"/>
+                </a:solidFill>
+                <a:latin typeface="Calibri" panose="020F0502020204030204" pitchFamily="34" charset="0"/>
+              </a:rPr>
+              <a:t>→</a:t>
+            </a:r>
+          </a:p>
+        </p:txBody>
+      </p:sp>
+      <p:sp>
+        <p:nvSpPr>
+          <p:cNvPr id="6" name="Caption 6"/>
           <p:cNvSpPr txBox="1"/>
           <p:nvPr/>
         </p:nvSpPr>
         <p:spPr>
           <a:xfrm>
-            <a:off x="6553200" y="1701800"/>
-            <a:ext cx="4724400" cy="431800"/>
+            <a:off x="609600" y="3429000"/>
+            <a:ext cx="4754880" cy="279400"/>
           </a:xfrm>
           <a:prstGeom prst="rect">
             <a:avLst/>
@@ -3890,34 +3828,29 @@
           </a:bodyPr>
           <a:lstStyle/>
           <a:p>
-            <a:r>
-              <a:rPr lang="en-US" sz="2400" b="1">
-                <a:solidFill>
-                  <a:srgbClr val="1F7A8C"/>
-                </a:solidFill>
-                <a:latin typeface="Cambria" panose="02040503050406030204" pitchFamily="18" charset="0"/>
-              </a:rPr>
-              <a:t>Extra service: [name]</a:t>
-            </a:r>
-          </a:p>
-        </p:txBody>
-      </p:sp>
-      <p:sp>
-        <p:nvSpPr>
-          <p:cNvPr id="8" name="TextBox 7">
-            <a:extLst>
-              <a:ext uri="{FF2B5EF4-FFF2-40B4-BE49-F238E27FC236}">
-                <a16:creationId xmlns:a16="http://schemas.microsoft.com/office/drawing/2014/main" id="{E421CBC2-59B8-913D-3670-F191CE85A4FC}"/>
-              </a:ext>
-            </a:extLst>
-          </p:cNvPr>
+            <a:pPr algn="ctr"/>
+            <a:r>
+              <a:rPr lang="en-US" sz="1400" b="1">
+                <a:solidFill>
+                  <a:srgbClr val="5D6D7E"/>
+                </a:solidFill>
+                <a:latin typeface="Calibri" panose="020F0502020204030204" pitchFamily="34" charset="0"/>
+              </a:rPr>
+              <a:t>Issue #7 in GitHub</a:t>
+            </a:r>
+          </a:p>
+        </p:txBody>
+      </p:sp>
+      <p:sp>
+        <p:nvSpPr>
+          <p:cNvPr id="7" name="Caption 7"/>
           <p:cNvSpPr txBox="1"/>
           <p:nvPr/>
         </p:nvSpPr>
         <p:spPr>
           <a:xfrm>
-            <a:off x="6553200" y="2413000"/>
-            <a:ext cx="4724400" cy="2286000"/>
+            <a:off x="6827520" y="3429000"/>
+            <a:ext cx="4754880" cy="279400"/>
           </a:xfrm>
           <a:prstGeom prst="rect">
             <a:avLst/>
@@ -3930,53 +3863,190 @@
           </a:bodyPr>
           <a:lstStyle/>
           <a:p>
-            <a:r>
-              <a:rPr lang="en-US" sz="1700">
+            <a:pPr algn="ctr"/>
+            <a:r>
+              <a:rPr lang="en-US" sz="1400" b="1">
                 <a:solidFill>
                   <a:srgbClr val="5D6D7E"/>
                 </a:solidFill>
                 <a:latin typeface="Calibri" panose="020F0502020204030204" pitchFamily="34" charset="0"/>
               </a:rPr>
-              <a:t>[Screenshot: original vs. dashboard]</a:t>
-            </a:r>
-          </a:p>
-          <a:p>
-            <a:endParaRPr lang="en-US" sz="1700">
-              <a:solidFill>
-                <a:srgbClr val="5D6D7E"/>
-              </a:solidFill>
-              <a:latin typeface="Calibri" panose="020F0502020204030204" pitchFamily="34" charset="0"/>
-            </a:endParaRPr>
-          </a:p>
-          <a:p>
-            <a:r>
-              <a:rPr lang="en-US" sz="1700">
+              <a:t>Issue #7 opened in the dashboard</a:t>
+            </a:r>
+          </a:p>
+        </p:txBody>
+      </p:sp>
+      <p:sp>
+        <p:nvSpPr>
+          <p:cNvPr id="8" name="Original placeholder 8"/>
+          <p:cNvSpPr/>
+          <p:nvPr/>
+        </p:nvSpPr>
+        <p:spPr>
+          <a:xfrm>
+            <a:off x="609600" y="3860800"/>
+            <a:ext cx="4754880" cy="2161309"/>
+          </a:xfrm>
+          <a:prstGeom prst="roundRect">
+            <a:avLst>
+              <a:gd name="adj" fmla="val 8000"/>
+            </a:avLst>
+          </a:prstGeom>
+          <a:solidFill>
+            <a:srgbClr val="FFFFFF"/>
+          </a:solidFill>
+          <a:ln w="19050" cap="flat" cmpd="sng" algn="ctr">
+            <a:solidFill>
+              <a:srgbClr val="5D6D7E"/>
+            </a:solidFill>
+            <a:prstDash val="dash"/>
+            <a:miter lim="800000"/>
+          </a:ln>
+          <a:effectLst/>
+        </p:spPr>
+        <p:style>
+          <a:lnRef idx="2">
+            <a:schemeClr val="accent1">
+              <a:shade val="15000"/>
+            </a:schemeClr>
+          </a:lnRef>
+          <a:fillRef idx="1">
+            <a:schemeClr val="accent1"/>
+          </a:fillRef>
+          <a:effectRef idx="0">
+            <a:schemeClr val="accent1"/>
+          </a:effectRef>
+          <a:fontRef idx="minor">
+            <a:schemeClr val="lt1"/>
+          </a:fontRef>
+        </p:style>
+        <p:txBody>
+          <a:bodyPr rtlCol="0" anchor="ctr"/>
+          <a:lstStyle/>
+          <a:p>
+            <a:pPr algn="ctr"/>
+            <a:r>
+              <a:rPr lang="en-US" sz="2400" b="1">
+                <a:solidFill>
+                  <a:srgbClr val="1B2631"/>
+                </a:solidFill>
+                <a:latin typeface="Calibri" panose="020F0502020204030204" pitchFamily="34" charset="0"/>
+              </a:rPr>
+              <a:t>Original in Slack</a:t>
+            </a:r>
+          </a:p>
+          <a:p>
+            <a:pPr algn="ctr">
+              <a:spcBef>
+                <a:spcPts val="600"/>
+              </a:spcBef>
+            </a:pPr>
+            <a:r>
+              <a:rPr lang="en-US" sz="1400">
                 <a:solidFill>
                   <a:srgbClr val="5D6D7E"/>
                 </a:solidFill>
                 <a:latin typeface="Calibri" panose="020F0502020204030204" pitchFamily="34" charset="0"/>
               </a:rPr>
-              <a:t>[What was downloaded and how]</a:t>
-            </a:r>
-          </a:p>
-        </p:txBody>
-      </p:sp>
-      <p:sp>
-        <p:nvSpPr>
-          <p:cNvPr id="9" name="TextBox 8">
-            <a:extLst>
-              <a:ext uri="{FF2B5EF4-FFF2-40B4-BE49-F238E27FC236}">
-                <a16:creationId xmlns:a16="http://schemas.microsoft.com/office/drawing/2014/main" id="{DEAE1EEB-F65E-FC84-4E80-15030B47F3FF}"/>
-              </a:ext>
-            </a:extLst>
-          </p:cNvPr>
+              <a:t>Screenshot placeholder</a:t>
+            </a:r>
+          </a:p>
+        </p:txBody>
+      </p:sp>
+      <p:pic>
+        <p:nvPicPr>
+          <p:cNvPr id="9" name="Dashboard screenshot 9" descr="Dashboard showing the Slack channel #all-ai-assisted-yu for Oct 15, 2026"/>
+          <p:cNvPicPr>
+            <a:picLocks noChangeAspect="1"/>
+          </p:cNvPicPr>
+          <p:nvPr/>
+        </p:nvPicPr>
+        <p:blipFill>
+          <a:blip r:embed="rId3"/>
+          <a:stretch>
+            <a:fillRect/>
+          </a:stretch>
+        </p:blipFill>
+        <p:spPr>
+          <a:xfrm>
+            <a:off x="6827520" y="3860800"/>
+            <a:ext cx="4754880" cy="2161309"/>
+          </a:xfrm>
+          <a:prstGeom prst="rect">
+            <a:avLst/>
+          </a:prstGeom>
+          <a:ln w="12700">
+            <a:solidFill>
+              <a:srgbClr val="C8D0D6"/>
+            </a:solidFill>
+          </a:ln>
+        </p:spPr>
+      </p:pic>
+      <p:sp>
+        <p:nvSpPr>
+          <p:cNvPr id="10" name="Arrow 10"/>
+          <p:cNvSpPr/>
+          <p:nvPr/>
+        </p:nvSpPr>
+        <p:spPr>
+          <a:xfrm>
+            <a:off x="5867400" y="4776354"/>
+            <a:ext cx="457200" cy="330200"/>
+          </a:xfrm>
+          <a:prstGeom prst="ellipse">
+            <a:avLst/>
+          </a:prstGeom>
+          <a:solidFill>
+            <a:srgbClr val="F2A541"/>
+          </a:solidFill>
+          <a:ln>
+            <a:noFill/>
+          </a:ln>
+          <a:effectLst/>
+        </p:spPr>
+        <p:style>
+          <a:lnRef idx="2">
+            <a:schemeClr val="accent1">
+              <a:shade val="15000"/>
+            </a:schemeClr>
+          </a:lnRef>
+          <a:fillRef idx="1">
+            <a:schemeClr val="accent1"/>
+          </a:fillRef>
+          <a:effectRef idx="0">
+            <a:schemeClr val="accent1"/>
+          </a:effectRef>
+          <a:fontRef idx="minor">
+            <a:schemeClr val="lt1"/>
+          </a:fontRef>
+        </p:style>
+        <p:txBody>
+          <a:bodyPr rtlCol="0" anchor="ctr"/>
+          <a:lstStyle/>
+          <a:p>
+            <a:pPr algn="ctr"/>
+            <a:r>
+              <a:rPr lang="en-US" sz="1600" b="1">
+                <a:solidFill>
+                  <a:srgbClr val="FFFFFF"/>
+                </a:solidFill>
+                <a:latin typeface="Calibri" panose="020F0502020204030204" pitchFamily="34" charset="0"/>
+              </a:rPr>
+              <a:t>→</a:t>
+            </a:r>
+          </a:p>
+        </p:txBody>
+      </p:sp>
+      <p:sp>
+        <p:nvSpPr>
+          <p:cNvPr id="11" name="Caption 11"/>
           <p:cNvSpPr txBox="1"/>
           <p:nvPr/>
         </p:nvSpPr>
         <p:spPr>
           <a:xfrm>
-            <a:off x="609600" y="5334000"/>
-            <a:ext cx="10972800" cy="330200"/>
+            <a:off x="609600" y="6096000"/>
+            <a:ext cx="4754880" cy="279400"/>
           </a:xfrm>
           <a:prstGeom prst="rect">
             <a:avLst/>
@@ -3989,14 +4059,50 @@
           </a:bodyPr>
           <a:lstStyle/>
           <a:p>
-            <a:r>
-              <a:rPr lang="en-US" sz="1600">
+            <a:pPr algn="ctr"/>
+            <a:r>
+              <a:rPr lang="en-US" sz="1400" b="1">
                 <a:solidFill>
                   <a:srgbClr val="5D6D7E"/>
                 </a:solidFill>
                 <a:latin typeface="Calibri" panose="020F0502020204030204" pitchFamily="34" charset="0"/>
               </a:rPr>
-              <a:t>Placeholder: Lior to fill in</a:t>
+              <a:t>#all-ai-assisted-yu, Oct 15 in Slack</a:t>
+            </a:r>
+          </a:p>
+        </p:txBody>
+      </p:sp>
+      <p:sp>
+        <p:nvSpPr>
+          <p:cNvPr id="12" name="Caption 12"/>
+          <p:cNvSpPr txBox="1"/>
+          <p:nvPr/>
+        </p:nvSpPr>
+        <p:spPr>
+          <a:xfrm>
+            <a:off x="6827520" y="6096000"/>
+            <a:ext cx="4754880" cy="279400"/>
+          </a:xfrm>
+          <a:prstGeom prst="rect">
+            <a:avLst/>
+          </a:prstGeom>
+          <a:noFill/>
+        </p:spPr>
+        <p:txBody>
+          <a:bodyPr vert="horz" wrap="square" lIns="0" tIns="0" rIns="0" bIns="0" rtlCol="0">
+            <a:noAutofit/>
+          </a:bodyPr>
+          <a:lstStyle/>
+          <a:p>
+            <a:pPr algn="ctr"/>
+            <a:r>
+              <a:rPr lang="en-US" sz="1400" b="1">
+                <a:solidFill>
+                  <a:srgbClr val="5D6D7E"/>
+                </a:solidFill>
+                <a:latin typeface="Calibri" panose="020F0502020204030204" pitchFamily="34" charset="0"/>
+              </a:rPr>
+              <a:t>#all-ai-assisted-yu, Oct 15 opened in the dashboard</a:t>
             </a:r>
           </a:p>
         </p:txBody>

</xml_diff>

<commit_message>
Slide 11: fill in Lior Bongart's contributions (GitHub, Slack, dashboard)
Co-Authored-By: Claude Opus 5.5 <noreply@anthropic.com>
</commit_message>
<xml_diff>
--- a/presentation/project.pptx
+++ b/presentation/project.pptx
@@ -4399,7 +4399,7 @@
         <p:spPr>
           <a:xfrm>
             <a:off x="6248400" y="1981200"/>
-            <a:ext cx="5334000" cy="1524000"/>
+            <a:ext cx="5334000" cy="3302000"/>
           </a:xfrm>
           <a:prstGeom prst="rect">
             <a:avLst/>
@@ -4426,7 +4426,7 @@
                 </a:solidFill>
                 <a:latin typeface="Calibri" panose="020F0502020204030204" pitchFamily="34" charset="0"/>
               </a:rPr>
-              <a:t>GitHub: [TBD]</a:t>
+              <a:t>GitHub: MCP connection, issue export, download-github skill</a:t>
             </a:r>
           </a:p>
           <a:p>
@@ -4444,7 +4444,43 @@
                 </a:solidFill>
                 <a:latin typeface="Calibri" panose="020F0502020204030204" pitchFamily="34" charset="0"/>
               </a:rPr>
-              <a:t>Extra service: [TBD]</a:t>
+              <a:t>Slack (extra service): MCP connection, channel export, download-slack skill</a:t>
+            </a:r>
+          </a:p>
+          <a:p>
+            <a:pPr marL="228600" indent="-228600">
+              <a:spcAft>
+                <a:spcPts val="800"/>
+              </a:spcAft>
+              <a:buFont typeface="+mj-lt"/>
+              <a:buChar char="•"/>
+            </a:pPr>
+            <a:r>
+              <a:rPr lang="en-US" sz="1700">
+                <a:solidFill>
+                  <a:srgbClr val="FFFFFF"/>
+                </a:solidFill>
+                <a:latin typeface="Calibri" panose="020F0502020204030204" pitchFamily="34" charset="0"/>
+              </a:rPr>
+              <a:t>Slack added to .mcp.json</a:t>
+            </a:r>
+          </a:p>
+          <a:p>
+            <a:pPr marL="228600" indent="-228600">
+              <a:spcAft>
+                <a:spcPts val="800"/>
+              </a:spcAft>
+              <a:buFont typeface="+mj-lt"/>
+              <a:buChar char="•"/>
+            </a:pPr>
+            <a:r>
+              <a:rPr lang="en-US" sz="1700">
+                <a:solidFill>
+                  <a:srgbClr val="FFFFFF"/>
+                </a:solidFill>
+                <a:latin typeface="Calibri" panose="020F0502020204030204" pitchFamily="34" charset="0"/>
+              </a:rPr>
+              <a:t>Dashboard: GitHub and Slack integration</a:t>
             </a:r>
           </a:p>
         </p:txBody>

</xml_diff>

<commit_message>
Slide 10: GitHub and Slack original screenshots; slide 2: GitHub and Slack done
</commit_message>
<xml_diff>
--- a/presentation/project.pptx
+++ b/presentation/project.pptx
@@ -3645,31 +3645,83 @@
           </a:p>
         </p:txBody>
       </p:sp>
-      <p:sp>
-        <p:nvSpPr>
-          <p:cNvPr id="3" name="Original placeholder 3"/>
-          <p:cNvSpPr/>
-          <p:nvPr/>
-        </p:nvSpPr>
+      <p:pic>
+        <p:nvPicPr>
+          <p:cNvPr id="3" name="Original screenshot 3" descr="GitHub issue #7 on github.com"/>
+          <p:cNvPicPr>
+            <a:picLocks noChangeAspect="1"/>
+          </p:cNvPicPr>
+          <p:nvPr/>
+        </p:nvPicPr>
+        <p:blipFill>
+          <a:blip r:embed="rId4"/>
+          <a:stretch>
+            <a:fillRect/>
+          </a:stretch>
+        </p:blipFill>
         <p:spPr>
           <a:xfrm>
             <a:off x="609600" y="1193800"/>
             <a:ext cx="4754880" cy="2161309"/>
           </a:xfrm>
-          <a:prstGeom prst="roundRect">
-            <a:avLst>
-              <a:gd name="adj" fmla="val 8000"/>
-            </a:avLst>
+          <a:prstGeom prst="rect">
+            <a:avLst/>
+          </a:prstGeom>
+          <a:ln w="12700">
+            <a:solidFill>
+              <a:srgbClr val="C8D0D6"/>
+            </a:solidFill>
+          </a:ln>
+        </p:spPr>
+      </p:pic>
+      <p:pic>
+        <p:nvPicPr>
+          <p:cNvPr id="4" name="Dashboard screenshot 4" descr="Dashboard showing GitHub issue #7"/>
+          <p:cNvPicPr>
+            <a:picLocks noChangeAspect="1"/>
+          </p:cNvPicPr>
+          <p:nvPr/>
+        </p:nvPicPr>
+        <p:blipFill>
+          <a:blip r:embed="rId2"/>
+          <a:stretch>
+            <a:fillRect/>
+          </a:stretch>
+        </p:blipFill>
+        <p:spPr>
+          <a:xfrm>
+            <a:off x="6827520" y="1193800"/>
+            <a:ext cx="4754880" cy="2161309"/>
+          </a:xfrm>
+          <a:prstGeom prst="rect">
+            <a:avLst/>
+          </a:prstGeom>
+          <a:ln w="12700">
+            <a:solidFill>
+              <a:srgbClr val="C8D0D6"/>
+            </a:solidFill>
+          </a:ln>
+        </p:spPr>
+      </p:pic>
+      <p:sp>
+        <p:nvSpPr>
+          <p:cNvPr id="5" name="Arrow 5"/>
+          <p:cNvSpPr/>
+          <p:nvPr/>
+        </p:nvSpPr>
+        <p:spPr>
+          <a:xfrm>
+            <a:off x="5867400" y="2109354"/>
+            <a:ext cx="457200" cy="330200"/>
+          </a:xfrm>
+          <a:prstGeom prst="ellipse">
+            <a:avLst/>
           </a:prstGeom>
           <a:solidFill>
-            <a:srgbClr val="FFFFFF"/>
+            <a:srgbClr val="F2A541"/>
           </a:solidFill>
-          <a:ln w="19050" cap="flat" cmpd="sng" algn="ctr">
-            <a:solidFill>
-              <a:srgbClr val="5D6D7E"/>
-            </a:solidFill>
-            <a:prstDash val="dash"/>
-            <a:miter lim="800000"/>
+          <a:ln>
+            <a:noFill/>
           </a:ln>
           <a:effectLst/>
         </p:spPr>
@@ -3695,50 +3747,104 @@
           <a:p>
             <a:pPr algn="ctr"/>
             <a:r>
-              <a:rPr lang="en-US" sz="2400" b="1">
-                <a:solidFill>
-                  <a:srgbClr val="1B2631"/>
+              <a:rPr lang="en-US" sz="1600" b="1">
+                <a:solidFill>
+                  <a:srgbClr val="FFFFFF"/>
                 </a:solidFill>
                 <a:latin typeface="Calibri" panose="020F0502020204030204" pitchFamily="34" charset="0"/>
               </a:rPr>
-              <a:t>Original in GitHub</a:t>
-            </a:r>
-          </a:p>
-          <a:p>
-            <a:pPr algn="ctr">
-              <a:spcBef>
-                <a:spcPts val="600"/>
-              </a:spcBef>
-            </a:pPr>
-            <a:r>
-              <a:rPr lang="en-US" sz="1400">
+              <a:t>→</a:t>
+            </a:r>
+          </a:p>
+        </p:txBody>
+      </p:sp>
+      <p:sp>
+        <p:nvSpPr>
+          <p:cNvPr id="6" name="Caption 6"/>
+          <p:cNvSpPr txBox="1"/>
+          <p:nvPr/>
+        </p:nvSpPr>
+        <p:spPr>
+          <a:xfrm>
+            <a:off x="609600" y="3429000"/>
+            <a:ext cx="4754880" cy="279400"/>
+          </a:xfrm>
+          <a:prstGeom prst="rect">
+            <a:avLst/>
+          </a:prstGeom>
+          <a:noFill/>
+        </p:spPr>
+        <p:txBody>
+          <a:bodyPr vert="horz" wrap="square" lIns="0" tIns="0" rIns="0" bIns="0" rtlCol="0">
+            <a:noAutofit/>
+          </a:bodyPr>
+          <a:lstStyle/>
+          <a:p>
+            <a:pPr algn="ctr"/>
+            <a:r>
+              <a:rPr lang="en-US" sz="1400" b="1">
                 <a:solidFill>
                   <a:srgbClr val="5D6D7E"/>
                 </a:solidFill>
                 <a:latin typeface="Calibri" panose="020F0502020204030204" pitchFamily="34" charset="0"/>
               </a:rPr>
-              <a:t>Screenshot placeholder</a:t>
+              <a:t>Issue #7 in GitHub</a:t>
+            </a:r>
+          </a:p>
+        </p:txBody>
+      </p:sp>
+      <p:sp>
+        <p:nvSpPr>
+          <p:cNvPr id="7" name="Caption 7"/>
+          <p:cNvSpPr txBox="1"/>
+          <p:nvPr/>
+        </p:nvSpPr>
+        <p:spPr>
+          <a:xfrm>
+            <a:off x="6827520" y="3429000"/>
+            <a:ext cx="4754880" cy="279400"/>
+          </a:xfrm>
+          <a:prstGeom prst="rect">
+            <a:avLst/>
+          </a:prstGeom>
+          <a:noFill/>
+        </p:spPr>
+        <p:txBody>
+          <a:bodyPr vert="horz" wrap="square" lIns="0" tIns="0" rIns="0" bIns="0" rtlCol="0">
+            <a:noAutofit/>
+          </a:bodyPr>
+          <a:lstStyle/>
+          <a:p>
+            <a:pPr algn="ctr"/>
+            <a:r>
+              <a:rPr lang="en-US" sz="1400" b="1">
+                <a:solidFill>
+                  <a:srgbClr val="5D6D7E"/>
+                </a:solidFill>
+                <a:latin typeface="Calibri" panose="020F0502020204030204" pitchFamily="34" charset="0"/>
+              </a:rPr>
+              <a:t>Issue #7 opened in the dashboard</a:t>
             </a:r>
           </a:p>
         </p:txBody>
       </p:sp>
       <p:pic>
         <p:nvPicPr>
-          <p:cNvPr id="4" name="Dashboard screenshot 4" descr="Dashboard showing GitHub issue #7"/>
+          <p:cNvPr id="8" name="Original screenshot 8" descr="#all-ai-assisted-yu channel in Slack"/>
           <p:cNvPicPr>
             <a:picLocks noChangeAspect="1"/>
           </p:cNvPicPr>
           <p:nvPr/>
         </p:nvPicPr>
         <p:blipFill>
-          <a:blip r:embed="rId2"/>
+          <a:blip r:embed="rId5"/>
           <a:stretch>
             <a:fillRect/>
           </a:stretch>
         </p:blipFill>
         <p:spPr>
           <a:xfrm>
-            <a:off x="6827520" y="1193800"/>
+            <a:off x="609600" y="3860800"/>
             <a:ext cx="4754880" cy="2161309"/>
           </a:xfrm>
           <a:prstGeom prst="rect">
@@ -3751,208 +3857,6 @@
           </a:ln>
         </p:spPr>
       </p:pic>
-      <p:sp>
-        <p:nvSpPr>
-          <p:cNvPr id="5" name="Arrow 5"/>
-          <p:cNvSpPr/>
-          <p:nvPr/>
-        </p:nvSpPr>
-        <p:spPr>
-          <a:xfrm>
-            <a:off x="5867400" y="2109354"/>
-            <a:ext cx="457200" cy="330200"/>
-          </a:xfrm>
-          <a:prstGeom prst="ellipse">
-            <a:avLst/>
-          </a:prstGeom>
-          <a:solidFill>
-            <a:srgbClr val="F2A541"/>
-          </a:solidFill>
-          <a:ln>
-            <a:noFill/>
-          </a:ln>
-          <a:effectLst/>
-        </p:spPr>
-        <p:style>
-          <a:lnRef idx="2">
-            <a:schemeClr val="accent1">
-              <a:shade val="15000"/>
-            </a:schemeClr>
-          </a:lnRef>
-          <a:fillRef idx="1">
-            <a:schemeClr val="accent1"/>
-          </a:fillRef>
-          <a:effectRef idx="0">
-            <a:schemeClr val="accent1"/>
-          </a:effectRef>
-          <a:fontRef idx="minor">
-            <a:schemeClr val="lt1"/>
-          </a:fontRef>
-        </p:style>
-        <p:txBody>
-          <a:bodyPr rtlCol="0" anchor="ctr"/>
-          <a:lstStyle/>
-          <a:p>
-            <a:pPr algn="ctr"/>
-            <a:r>
-              <a:rPr lang="en-US" sz="1600" b="1">
-                <a:solidFill>
-                  <a:srgbClr val="FFFFFF"/>
-                </a:solidFill>
-                <a:latin typeface="Calibri" panose="020F0502020204030204" pitchFamily="34" charset="0"/>
-              </a:rPr>
-              <a:t>→</a:t>
-            </a:r>
-          </a:p>
-        </p:txBody>
-      </p:sp>
-      <p:sp>
-        <p:nvSpPr>
-          <p:cNvPr id="6" name="Caption 6"/>
-          <p:cNvSpPr txBox="1"/>
-          <p:nvPr/>
-        </p:nvSpPr>
-        <p:spPr>
-          <a:xfrm>
-            <a:off x="609600" y="3429000"/>
-            <a:ext cx="4754880" cy="279400"/>
-          </a:xfrm>
-          <a:prstGeom prst="rect">
-            <a:avLst/>
-          </a:prstGeom>
-          <a:noFill/>
-        </p:spPr>
-        <p:txBody>
-          <a:bodyPr vert="horz" wrap="square" lIns="0" tIns="0" rIns="0" bIns="0" rtlCol="0">
-            <a:noAutofit/>
-          </a:bodyPr>
-          <a:lstStyle/>
-          <a:p>
-            <a:pPr algn="ctr"/>
-            <a:r>
-              <a:rPr lang="en-US" sz="1400" b="1">
-                <a:solidFill>
-                  <a:srgbClr val="5D6D7E"/>
-                </a:solidFill>
-                <a:latin typeface="Calibri" panose="020F0502020204030204" pitchFamily="34" charset="0"/>
-              </a:rPr>
-              <a:t>Issue #7 in GitHub</a:t>
-            </a:r>
-          </a:p>
-        </p:txBody>
-      </p:sp>
-      <p:sp>
-        <p:nvSpPr>
-          <p:cNvPr id="7" name="Caption 7"/>
-          <p:cNvSpPr txBox="1"/>
-          <p:nvPr/>
-        </p:nvSpPr>
-        <p:spPr>
-          <a:xfrm>
-            <a:off x="6827520" y="3429000"/>
-            <a:ext cx="4754880" cy="279400"/>
-          </a:xfrm>
-          <a:prstGeom prst="rect">
-            <a:avLst/>
-          </a:prstGeom>
-          <a:noFill/>
-        </p:spPr>
-        <p:txBody>
-          <a:bodyPr vert="horz" wrap="square" lIns="0" tIns="0" rIns="0" bIns="0" rtlCol="0">
-            <a:noAutofit/>
-          </a:bodyPr>
-          <a:lstStyle/>
-          <a:p>
-            <a:pPr algn="ctr"/>
-            <a:r>
-              <a:rPr lang="en-US" sz="1400" b="1">
-                <a:solidFill>
-                  <a:srgbClr val="5D6D7E"/>
-                </a:solidFill>
-                <a:latin typeface="Calibri" panose="020F0502020204030204" pitchFamily="34" charset="0"/>
-              </a:rPr>
-              <a:t>Issue #7 opened in the dashboard</a:t>
-            </a:r>
-          </a:p>
-        </p:txBody>
-      </p:sp>
-      <p:sp>
-        <p:nvSpPr>
-          <p:cNvPr id="8" name="Original placeholder 8"/>
-          <p:cNvSpPr/>
-          <p:nvPr/>
-        </p:nvSpPr>
-        <p:spPr>
-          <a:xfrm>
-            <a:off x="609600" y="3860800"/>
-            <a:ext cx="4754880" cy="2161309"/>
-          </a:xfrm>
-          <a:prstGeom prst="roundRect">
-            <a:avLst>
-              <a:gd name="adj" fmla="val 8000"/>
-            </a:avLst>
-          </a:prstGeom>
-          <a:solidFill>
-            <a:srgbClr val="FFFFFF"/>
-          </a:solidFill>
-          <a:ln w="19050" cap="flat" cmpd="sng" algn="ctr">
-            <a:solidFill>
-              <a:srgbClr val="5D6D7E"/>
-            </a:solidFill>
-            <a:prstDash val="dash"/>
-            <a:miter lim="800000"/>
-          </a:ln>
-          <a:effectLst/>
-        </p:spPr>
-        <p:style>
-          <a:lnRef idx="2">
-            <a:schemeClr val="accent1">
-              <a:shade val="15000"/>
-            </a:schemeClr>
-          </a:lnRef>
-          <a:fillRef idx="1">
-            <a:schemeClr val="accent1"/>
-          </a:fillRef>
-          <a:effectRef idx="0">
-            <a:schemeClr val="accent1"/>
-          </a:effectRef>
-          <a:fontRef idx="minor">
-            <a:schemeClr val="lt1"/>
-          </a:fontRef>
-        </p:style>
-        <p:txBody>
-          <a:bodyPr rtlCol="0" anchor="ctr"/>
-          <a:lstStyle/>
-          <a:p>
-            <a:pPr algn="ctr"/>
-            <a:r>
-              <a:rPr lang="en-US" sz="2400" b="1">
-                <a:solidFill>
-                  <a:srgbClr val="1B2631"/>
-                </a:solidFill>
-                <a:latin typeface="Calibri" panose="020F0502020204030204" pitchFamily="34" charset="0"/>
-              </a:rPr>
-              <a:t>Original in Slack</a:t>
-            </a:r>
-          </a:p>
-          <a:p>
-            <a:pPr algn="ctr">
-              <a:spcBef>
-                <a:spcPts val="600"/>
-              </a:spcBef>
-            </a:pPr>
-            <a:r>
-              <a:rPr lang="en-US" sz="1400">
-                <a:solidFill>
-                  <a:srgbClr val="5D6D7E"/>
-                </a:solidFill>
-                <a:latin typeface="Calibri" panose="020F0502020204030204" pitchFamily="34" charset="0"/>
-              </a:rPr>
-              <a:t>Screenshot placeholder</a:t>
-            </a:r>
-          </a:p>
-        </p:txBody>
-      </p:sp>
       <p:pic>
         <p:nvPicPr>
           <p:cNvPr id="9" name="Dashboard screenshot 9" descr="Dashboard showing the Slack channel #all-ai-assisted-yu for Oct 15, 2026"/>
@@ -4714,7 +4618,7 @@
             <a:avLst/>
           </a:prstGeom>
           <a:solidFill>
-            <a:srgbClr val="F2A541"/>
+            <a:srgbClr val="2E8B57"/>
           </a:solidFill>
           <a:ln w="19050" cap="flat" cmpd="sng" algn="ctr">
             <a:noFill/>
@@ -4872,7 +4776,7 @@
             <a:avLst/>
           </a:prstGeom>
           <a:solidFill>
-            <a:srgbClr val="F2A541"/>
+            <a:srgbClr val="2E8B57"/>
           </a:solidFill>
           <a:ln w="19050" cap="flat" cmpd="sng" algn="ctr">
             <a:noFill/>
@@ -5030,7 +4934,7 @@
             <a:avLst/>
           </a:prstGeom>
           <a:solidFill>
-            <a:srgbClr val="F2A541"/>
+            <a:srgbClr val="2E8B57"/>
           </a:solidFill>
           <a:ln w="19050" cap="flat" cmpd="sng" algn="ctr">
             <a:noFill/>
@@ -5676,7 +5580,7 @@
             </a:avLst>
           </a:prstGeom>
           <a:solidFill>
-            <a:srgbClr val="F2A541"/>
+            <a:srgbClr val="2E8B57"/>
           </a:solidFill>
           <a:ln w="19050" cap="flat" cmpd="sng" algn="ctr">
             <a:noFill/>
@@ -5726,7 +5630,7 @@
                 </a:solidFill>
                 <a:latin typeface="Calibri" panose="020F0502020204030204" pitchFamily="34" charset="0"/>
               </a:rPr>
-              <a:t>In progress</a:t>
+              <a:t>Done</a:t>
             </a:r>
           </a:p>
         </p:txBody>
@@ -5836,7 +5740,7 @@
                 </a:solidFill>
                 <a:latin typeface="Calibri" panose="020F0502020204030204" pitchFamily="34" charset="0"/>
               </a:rPr>
-              <a:t>Lior's extra service</a:t>
+              <a:t>Slack</a:t>
             </a:r>
           </a:p>
         </p:txBody>
@@ -5864,7 +5768,7 @@
             </a:avLst>
           </a:prstGeom>
           <a:solidFill>
-            <a:srgbClr val="F2A541"/>
+            <a:srgbClr val="2E8B57"/>
           </a:solidFill>
           <a:ln w="19050" cap="flat" cmpd="sng" algn="ctr">
             <a:noFill/>
@@ -5914,7 +5818,7 @@
                 </a:solidFill>
                 <a:latin typeface="Calibri" panose="020F0502020204030204" pitchFamily="34" charset="0"/>
               </a:rPr>
-              <a:t>In progress</a:t>
+              <a:t>Done</a:t>
             </a:r>
           </a:p>
         </p:txBody>

</xml_diff>

<commit_message>
Split GitHub and Slack into their own original/dashboard slides
</commit_message>
<xml_diff>
--- a/presentation/project.pptx
+++ b/presentation/project.pptx
@@ -10,12 +10,13 @@
     <p:sldId id="258" r:id="rId4"/>
     <p:sldId id="259" r:id="rId5"/>
     <p:sldId id="260" r:id="rId6"/>
-    <p:sldId id="261" r:id="rId7"/>
-    <p:sldId id="262" r:id="rId8"/>
-    <p:sldId id="263" r:id="rId9"/>
-    <p:sldId id="264" r:id="rId10"/>
-    <p:sldId id="265" r:id="rId11"/>
-    <p:sldId id="266" r:id="rId12"/>
+    <p:sldId id="267" r:id="rId7"/>
+    <p:sldId id="268" r:id="rId8"/>
+    <p:sldId id="261" r:id="rId9"/>
+    <p:sldId id="262" r:id="rId10"/>
+    <p:sldId id="263" r:id="rId11"/>
+    <p:sldId id="264" r:id="rId12"/>
+    <p:sldId id="266" r:id="rId13"/>
   </p:sldIdLst>
   <p:sldSz cx="12192000" cy="6858000"/>
   <p:notesSz cx="6858000" cy="9144000"/>
@@ -264,7 +265,7 @@
           <a:p>
             <a:fld id="{60209F73-5D1D-424B-A313-03BE51FD0EFE}" type="datetimeFigureOut">
               <a:rPr lang="en-US" smtClean="0"/>
-              <a:t>14-Oct-26</a:t>
+              <a:t>10/15/2026</a:t>
             </a:fld>
             <a:endParaRPr lang="en-US"/>
           </a:p>
@@ -462,7 +463,7 @@
           <a:p>
             <a:fld id="{60209F73-5D1D-424B-A313-03BE51FD0EFE}" type="datetimeFigureOut">
               <a:rPr lang="en-US" smtClean="0"/>
-              <a:t>14-Oct-26</a:t>
+              <a:t>10/15/2026</a:t>
             </a:fld>
             <a:endParaRPr lang="en-US"/>
           </a:p>
@@ -670,7 +671,7 @@
           <a:p>
             <a:fld id="{60209F73-5D1D-424B-A313-03BE51FD0EFE}" type="datetimeFigureOut">
               <a:rPr lang="en-US" smtClean="0"/>
-              <a:t>14-Oct-26</a:t>
+              <a:t>10/15/2026</a:t>
             </a:fld>
             <a:endParaRPr lang="en-US"/>
           </a:p>
@@ -868,7 +869,7 @@
           <a:p>
             <a:fld id="{60209F73-5D1D-424B-A313-03BE51FD0EFE}" type="datetimeFigureOut">
               <a:rPr lang="en-US" smtClean="0"/>
-              <a:t>14-Oct-26</a:t>
+              <a:t>10/15/2026</a:t>
             </a:fld>
             <a:endParaRPr lang="en-US"/>
           </a:p>
@@ -1143,7 +1144,7 @@
           <a:p>
             <a:fld id="{60209F73-5D1D-424B-A313-03BE51FD0EFE}" type="datetimeFigureOut">
               <a:rPr lang="en-US" smtClean="0"/>
-              <a:t>14-Oct-26</a:t>
+              <a:t>10/15/2026</a:t>
             </a:fld>
             <a:endParaRPr lang="en-US"/>
           </a:p>
@@ -1408,7 +1409,7 @@
           <a:p>
             <a:fld id="{60209F73-5D1D-424B-A313-03BE51FD0EFE}" type="datetimeFigureOut">
               <a:rPr lang="en-US" smtClean="0"/>
-              <a:t>14-Oct-26</a:t>
+              <a:t>10/15/2026</a:t>
             </a:fld>
             <a:endParaRPr lang="en-US"/>
           </a:p>
@@ -1820,7 +1821,7 @@
           <a:p>
             <a:fld id="{60209F73-5D1D-424B-A313-03BE51FD0EFE}" type="datetimeFigureOut">
               <a:rPr lang="en-US" smtClean="0"/>
-              <a:t>14-Oct-26</a:t>
+              <a:t>10/15/2026</a:t>
             </a:fld>
             <a:endParaRPr lang="en-US"/>
           </a:p>
@@ -1961,7 +1962,7 @@
           <a:p>
             <a:fld id="{60209F73-5D1D-424B-A313-03BE51FD0EFE}" type="datetimeFigureOut">
               <a:rPr lang="en-US" smtClean="0"/>
-              <a:t>14-Oct-26</a:t>
+              <a:t>10/15/2026</a:t>
             </a:fld>
             <a:endParaRPr lang="en-US"/>
           </a:p>
@@ -2074,7 +2075,7 @@
           <a:p>
             <a:fld id="{60209F73-5D1D-424B-A313-03BE51FD0EFE}" type="datetimeFigureOut">
               <a:rPr lang="en-US" smtClean="0"/>
-              <a:t>14-Oct-26</a:t>
+              <a:t>10/15/2026</a:t>
             </a:fld>
             <a:endParaRPr lang="en-US"/>
           </a:p>
@@ -2385,7 +2386,7 @@
           <a:p>
             <a:fld id="{60209F73-5D1D-424B-A313-03BE51FD0EFE}" type="datetimeFigureOut">
               <a:rPr lang="en-US" smtClean="0"/>
-              <a:t>14-Oct-26</a:t>
+              <a:t>10/15/2026</a:t>
             </a:fld>
             <a:endParaRPr lang="en-US"/>
           </a:p>
@@ -2673,7 +2674,7 @@
           <a:p>
             <a:fld id="{60209F73-5D1D-424B-A313-03BE51FD0EFE}" type="datetimeFigureOut">
               <a:rPr lang="en-US" smtClean="0"/>
-              <a:t>14-Oct-26</a:t>
+              <a:t>10/15/2026</a:t>
             </a:fld>
             <a:endParaRPr lang="en-US"/>
           </a:p>
@@ -2914,7 +2915,7 @@
           <a:p>
             <a:fld id="{60209F73-5D1D-424B-A313-03BE51FD0EFE}" type="datetimeFigureOut">
               <a:rPr lang="en-US" smtClean="0"/>
-              <a:t>14-Oct-26</a:t>
+              <a:t>10/15/2026</a:t>
             </a:fld>
             <a:endParaRPr lang="en-US"/>
           </a:p>
@@ -3610,7 +3611,7 @@
           <p:cNvPr id="2" name="TextBox 1">
             <a:extLst>
               <a:ext uri="{FF2B5EF4-FFF2-40B4-BE49-F238E27FC236}">
-                <a16:creationId xmlns:a16="http://schemas.microsoft.com/office/drawing/2014/main" id="{E71DF6EE-0D7B-031E-9A86-7347311C2BA4}"/>
+                <a16:creationId xmlns:a16="http://schemas.microsoft.com/office/drawing/2014/main" id="{666A9E3C-F6FD-BD6F-1E19-356FA0A42824}"/>
               </a:ext>
             </a:extLst>
           </p:cNvPr>
@@ -3640,29 +3641,41 @@
                 </a:solidFill>
                 <a:latin typeface="Cambria" panose="02040503050406030204" pitchFamily="18" charset="0"/>
               </a:rPr>
-              <a:t>Lior's services</a:t>
+              <a:t>Dashboard: one search across all services</a:t>
             </a:r>
           </a:p>
         </p:txBody>
       </p:sp>
       <p:pic>
         <p:nvPicPr>
-          <p:cNvPr id="3" name="Original screenshot 3" descr="GitHub issue #7 on github.com"/>
+          <p:cNvPr id="4" name="Picture 3">
+            <a:extLst>
+              <a:ext uri="{FF2B5EF4-FFF2-40B4-BE49-F238E27FC236}">
+                <a16:creationId xmlns:a16="http://schemas.microsoft.com/office/drawing/2014/main" id="{CFE1EB2D-B6B9-9E89-14B3-5D32D0B25D34}"/>
+              </a:ext>
+            </a:extLst>
+          </p:cNvPr>
           <p:cNvPicPr>
             <a:picLocks noChangeAspect="1"/>
           </p:cNvPicPr>
           <p:nvPr/>
         </p:nvPicPr>
         <p:blipFill>
-          <a:blip r:embed="rId4"/>
+          <a:blip r:embed="rId2">
+            <a:extLst>
+              <a:ext uri="{28A0092B-C50C-407E-A947-70E740481C1C}">
+                <a14:useLocalDpi xmlns:a14="http://schemas.microsoft.com/office/drawing/2010/main" val="0"/>
+              </a:ext>
+            </a:extLst>
+          </a:blip>
           <a:stretch>
             <a:fillRect/>
           </a:stretch>
         </p:blipFill>
         <p:spPr>
           <a:xfrm>
-            <a:off x="609600" y="1193800"/>
-            <a:ext cx="4754880" cy="2161309"/>
+            <a:off x="609600" y="1362075"/>
+            <a:ext cx="6858000" cy="4286250"/>
           </a:xfrm>
           <a:prstGeom prst="rect">
             <a:avLst/>
@@ -3674,56 +3687,288 @@
           </a:ln>
         </p:spPr>
       </p:pic>
-      <p:pic>
-        <p:nvPicPr>
-          <p:cNvPr id="4" name="Dashboard screenshot 4" descr="Dashboard showing GitHub issue #7"/>
-          <p:cNvPicPr>
-            <a:picLocks noChangeAspect="1"/>
-          </p:cNvPicPr>
-          <p:nvPr/>
-        </p:nvPicPr>
-        <p:blipFill>
-          <a:blip r:embed="rId2"/>
-          <a:stretch>
-            <a:fillRect/>
-          </a:stretch>
-        </p:blipFill>
-        <p:spPr>
-          <a:xfrm>
-            <a:off x="6827520" y="1193800"/>
-            <a:ext cx="4754880" cy="2161309"/>
+      <p:sp>
+        <p:nvSpPr>
+          <p:cNvPr id="5" name="TextBox 4">
+            <a:extLst>
+              <a:ext uri="{FF2B5EF4-FFF2-40B4-BE49-F238E27FC236}">
+                <a16:creationId xmlns:a16="http://schemas.microsoft.com/office/drawing/2014/main" id="{5530984F-97C0-7A47-D876-7E901D833E83}"/>
+              </a:ext>
+            </a:extLst>
+          </p:cNvPr>
+          <p:cNvSpPr txBox="1"/>
+          <p:nvPr/>
+        </p:nvSpPr>
+        <p:spPr>
+          <a:xfrm>
+            <a:off x="7823200" y="1397000"/>
+            <a:ext cx="3759200" cy="4191000"/>
           </a:xfrm>
           <a:prstGeom prst="rect">
             <a:avLst/>
           </a:prstGeom>
-          <a:ln w="12700">
-            <a:solidFill>
-              <a:srgbClr val="C8D0D6"/>
-            </a:solidFill>
-          </a:ln>
-        </p:spPr>
-      </p:pic>
-      <p:sp>
-        <p:nvSpPr>
-          <p:cNvPr id="5" name="Arrow 5"/>
+          <a:noFill/>
+        </p:spPr>
+        <p:txBody>
+          <a:bodyPr vert="horz" wrap="square" lIns="0" tIns="0" rIns="0" bIns="0" rtlCol="0">
+            <a:noAutofit/>
+          </a:bodyPr>
+          <a:lstStyle/>
+          <a:p>
+            <a:pPr marL="228600" indent="-228600">
+              <a:spcAft>
+                <a:spcPts val="800"/>
+              </a:spcAft>
+              <a:buFont typeface="+mj-lt"/>
+              <a:buChar char="•"/>
+            </a:pPr>
+            <a:r>
+              <a:rPr lang="en-US" sz="1700">
+                <a:solidFill>
+                  <a:srgbClr val="1B2631"/>
+                </a:solidFill>
+                <a:latin typeface="Calibri" panose="020F0502020204030204" pitchFamily="34" charset="0"/>
+              </a:rPr>
+              <a:t>Searches all services at once, or one at a time</a:t>
+            </a:r>
+          </a:p>
+          <a:p>
+            <a:pPr marL="228600" indent="-228600">
+              <a:spcAft>
+                <a:spcPts val="800"/>
+              </a:spcAft>
+              <a:buFont typeface="+mj-lt"/>
+              <a:buChar char="•"/>
+            </a:pPr>
+            <a:r>
+              <a:rPr lang="en-US" sz="1700">
+                <a:solidFill>
+                  <a:srgbClr val="1B2631"/>
+                </a:solidFill>
+                <a:latin typeface="Calibri" panose="020F0502020204030204" pitchFamily="34" charset="0"/>
+              </a:rPr>
+              <a:t>Quotes for exact phrases, matches highlighted</a:t>
+            </a:r>
+          </a:p>
+          <a:p>
+            <a:pPr marL="228600" indent="-228600">
+              <a:spcAft>
+                <a:spcPts val="800"/>
+              </a:spcAft>
+              <a:buFont typeface="+mj-lt"/>
+              <a:buChar char="•"/>
+            </a:pPr>
+            <a:r>
+              <a:rPr lang="en-US" sz="1700">
+                <a:solidFill>
+                  <a:srgbClr val="1B2631"/>
+                </a:solidFill>
+                <a:latin typeface="Calibri" panose="020F0502020204030204" pitchFamily="34" charset="0"/>
+              </a:rPr>
+              <a:t>Opens the full item with its metadata</a:t>
+            </a:r>
+          </a:p>
+          <a:p>
+            <a:pPr marL="228600" indent="-228600">
+              <a:spcAft>
+                <a:spcPts val="800"/>
+              </a:spcAft>
+              <a:buFont typeface="+mj-lt"/>
+              <a:buChar char="•"/>
+            </a:pPr>
+            <a:r>
+              <a:rPr lang="en-US" sz="1700">
+                <a:solidFill>
+                  <a:srgbClr val="1B2631"/>
+                </a:solidFill>
+                <a:latin typeface="Calibri" panose="020F0502020204030204" pitchFamily="34" charset="0"/>
+              </a:rPr>
+              <a:t>Plain HTML, works offline: double-click index.html</a:t>
+            </a:r>
+          </a:p>
+          <a:p>
+            <a:pPr marL="228600" indent="-228600">
+              <a:spcAft>
+                <a:spcPts val="800"/>
+              </a:spcAft>
+              <a:buFont typeface="+mj-lt"/>
+              <a:buChar char="•"/>
+            </a:pPr>
+            <a:r>
+              <a:rPr lang="en-US" sz="1700">
+                <a:solidFill>
+                  <a:srgbClr val="1B2631"/>
+                </a:solidFill>
+                <a:latin typeface="Calibri" panose="020F0502020204030204" pitchFamily="34" charset="0"/>
+              </a:rPr>
+              <a:t>Rerun one script after each download</a:t>
+            </a:r>
+          </a:p>
+        </p:txBody>
+      </p:sp>
+      <p:sp>
+        <p:nvSpPr>
+          <p:cNvPr id="6" name="TextBox 5">
+            <a:extLst>
+              <a:ext uri="{FF2B5EF4-FFF2-40B4-BE49-F238E27FC236}">
+                <a16:creationId xmlns:a16="http://schemas.microsoft.com/office/drawing/2014/main" id="{0EA7E02B-1651-A356-6513-8B8D03B7FDD7}"/>
+              </a:ext>
+            </a:extLst>
+          </p:cNvPr>
+          <p:cNvSpPr txBox="1"/>
+          <p:nvPr/>
+        </p:nvSpPr>
+        <p:spPr>
+          <a:xfrm>
+            <a:off x="609600" y="5918200"/>
+            <a:ext cx="6858000" cy="279400"/>
+          </a:xfrm>
+          <a:prstGeom prst="rect">
+            <a:avLst/>
+          </a:prstGeom>
+          <a:noFill/>
+        </p:spPr>
+        <p:txBody>
+          <a:bodyPr vert="horz" wrap="square" lIns="0" tIns="0" rIns="0" bIns="0" rtlCol="0">
+            <a:noAutofit/>
+          </a:bodyPr>
+          <a:lstStyle/>
+          <a:p>
+            <a:pPr algn="ctr"/>
+            <a:r>
+              <a:rPr lang="en-US" sz="1400" b="1">
+                <a:solidFill>
+                  <a:srgbClr val="5D6D7E"/>
+                </a:solidFill>
+                <a:latin typeface="Calibri" panose="020F0502020204030204" pitchFamily="34" charset="0"/>
+              </a:rPr>
+              <a:t>“Joe Smith”: 21 results from all four services</a:t>
+            </a:r>
+          </a:p>
+        </p:txBody>
+      </p:sp>
+    </p:spTree>
+    <p:extLst>
+      <p:ext uri="{BB962C8B-B14F-4D97-AF65-F5344CB8AC3E}">
+        <p14:creationId xmlns:p14="http://schemas.microsoft.com/office/powerpoint/2010/main" val="2784576497"/>
+      </p:ext>
+    </p:extLst>
+  </p:cSld>
+  <p:clrMapOvr>
+    <a:masterClrMapping/>
+  </p:clrMapOvr>
+</p:sld>
+</file>
+
+<file path=ppt/slides/slide11.xml><?xml version="1.0" encoding="utf-8"?>
+<p:sld xmlns:a="http://schemas.openxmlformats.org/drawingml/2006/main" xmlns:r="http://schemas.openxmlformats.org/officeDocument/2006/relationships" xmlns:p="http://schemas.openxmlformats.org/presentationml/2006/main">
+  <p:cSld>
+    <p:bg>
+      <p:bgPr>
+        <a:solidFill>
+          <a:srgbClr val="FFFFFF"/>
+        </a:solidFill>
+        <a:effectLst/>
+      </p:bgPr>
+    </p:bg>
+    <p:spTree>
+      <p:nvGrpSpPr>
+        <p:cNvPr id="1" name=""/>
+        <p:cNvGrpSpPr/>
+        <p:nvPr/>
+      </p:nvGrpSpPr>
+      <p:grpSpPr>
+        <a:xfrm>
+          <a:off x="0" y="0"/>
+          <a:ext cx="0" cy="0"/>
+          <a:chOff x="0" y="0"/>
+          <a:chExt cx="0" cy="0"/>
+        </a:xfrm>
+      </p:grpSpPr>
+      <p:sp>
+        <p:nvSpPr>
+          <p:cNvPr id="2" name="TextBox 1">
+            <a:extLst>
+              <a:ext uri="{FF2B5EF4-FFF2-40B4-BE49-F238E27FC236}">
+                <a16:creationId xmlns:a16="http://schemas.microsoft.com/office/drawing/2014/main" id="{BDC932DD-D6B1-86C7-BEE4-6B498DE40353}"/>
+              </a:ext>
+            </a:extLst>
+          </p:cNvPr>
+          <p:cNvSpPr txBox="1"/>
+          <p:nvPr/>
+        </p:nvSpPr>
+        <p:spPr>
+          <a:xfrm>
+            <a:off x="609600" y="381000"/>
+            <a:ext cx="10972800" cy="635000"/>
+          </a:xfrm>
+          <a:prstGeom prst="rect">
+            <a:avLst/>
+          </a:prstGeom>
+          <a:noFill/>
+        </p:spPr>
+        <p:txBody>
+          <a:bodyPr vert="horz" wrap="square" lIns="0" tIns="0" rIns="0" bIns="0" rtlCol="0">
+            <a:noAutofit/>
+          </a:bodyPr>
+          <a:lstStyle/>
+          <a:p>
+            <a:r>
+              <a:rPr lang="en-US" sz="3600" b="1">
+                <a:solidFill>
+                  <a:srgbClr val="1B2631"/>
+                </a:solidFill>
+                <a:latin typeface="Cambria" panose="02040503050406030204" pitchFamily="18" charset="0"/>
+              </a:rPr>
+              <a:t>Gmail: tried, then waived</a:t>
+            </a:r>
+          </a:p>
+        </p:txBody>
+      </p:sp>
+      <p:sp>
+        <p:nvSpPr>
+          <p:cNvPr id="3" name="Rectangle: Rounded Corners 2">
+            <a:extLst>
+              <a:ext uri="{FF2B5EF4-FFF2-40B4-BE49-F238E27FC236}">
+                <a16:creationId xmlns:a16="http://schemas.microsoft.com/office/drawing/2014/main" id="{51D70701-CE3D-ED46-87D8-C45D364AEF16}"/>
+              </a:ext>
+            </a:extLst>
+          </p:cNvPr>
           <p:cNvSpPr/>
           <p:nvPr/>
         </p:nvSpPr>
         <p:spPr>
           <a:xfrm>
-            <a:off x="5867400" y="2109354"/>
-            <a:ext cx="457200" cy="330200"/>
-          </a:xfrm>
-          <a:prstGeom prst="ellipse">
-            <a:avLst/>
+            <a:off x="609600" y="1397000"/>
+            <a:ext cx="2540000" cy="1524000"/>
+          </a:xfrm>
+          <a:prstGeom prst="roundRect">
+            <a:avLst>
+              <a:gd name="adj" fmla="val 8000"/>
+            </a:avLst>
           </a:prstGeom>
           <a:solidFill>
-            <a:srgbClr val="F2A541"/>
+            <a:srgbClr val="ECF2F5"/>
           </a:solidFill>
-          <a:ln>
+          <a:ln w="19050" cap="flat" cmpd="sng" algn="ctr">
             <a:noFill/>
+            <a:prstDash val="solid"/>
+            <a:miter lim="800000"/>
           </a:ln>
           <a:effectLst/>
+          <a:extLst>
+            <a:ext uri="{91240B29-F687-4F45-9708-019B960494DF}">
+              <a14:hiddenLine xmlns:a14="http://schemas.microsoft.com/office/drawing/2010/main" w="19050" cap="flat" cmpd="sng" algn="ctr">
+                <a:solidFill>
+                  <a:schemeClr val="accent1">
+                    <a:shade val="15000"/>
+                  </a:schemeClr>
+                </a:solidFill>
+                <a:prstDash val="solid"/>
+                <a:miter lim="800000"/>
+              </a14:hiddenLine>
+            </a:ext>
+          </a:extLst>
         </p:spPr>
         <p:style>
           <a:lnRef idx="2">
@@ -3746,167 +3991,52 @@
           <a:lstStyle/>
           <a:p>
             <a:pPr algn="ctr"/>
-            <a:r>
-              <a:rPr lang="en-US" sz="1600" b="1">
-                <a:solidFill>
-                  <a:srgbClr val="FFFFFF"/>
-                </a:solidFill>
-                <a:latin typeface="Calibri" panose="020F0502020204030204" pitchFamily="34" charset="0"/>
-              </a:rPr>
-              <a:t>→</a:t>
-            </a:r>
-          </a:p>
-        </p:txBody>
-      </p:sp>
-      <p:sp>
-        <p:nvSpPr>
-          <p:cNvPr id="6" name="Caption 6"/>
-          <p:cNvSpPr txBox="1"/>
-          <p:nvPr/>
-        </p:nvSpPr>
-        <p:spPr>
-          <a:xfrm>
-            <a:off x="609600" y="3429000"/>
-            <a:ext cx="4754880" cy="279400"/>
-          </a:xfrm>
-          <a:prstGeom prst="rect">
-            <a:avLst/>
-          </a:prstGeom>
-          <a:noFill/>
-        </p:spPr>
-        <p:txBody>
-          <a:bodyPr vert="horz" wrap="square" lIns="0" tIns="0" rIns="0" bIns="0" rtlCol="0">
-            <a:noAutofit/>
-          </a:bodyPr>
-          <a:lstStyle/>
-          <a:p>
-            <a:pPr algn="ctr"/>
-            <a:r>
-              <a:rPr lang="en-US" sz="1400" b="1">
-                <a:solidFill>
-                  <a:srgbClr val="5D6D7E"/>
-                </a:solidFill>
-                <a:latin typeface="Calibri" panose="020F0502020204030204" pitchFamily="34" charset="0"/>
-              </a:rPr>
-              <a:t>Issue #7 in GitHub</a:t>
-            </a:r>
-          </a:p>
-        </p:txBody>
-      </p:sp>
-      <p:sp>
-        <p:nvSpPr>
-          <p:cNvPr id="7" name="Caption 7"/>
-          <p:cNvSpPr txBox="1"/>
-          <p:nvPr/>
-        </p:nvSpPr>
-        <p:spPr>
-          <a:xfrm>
-            <a:off x="6827520" y="3429000"/>
-            <a:ext cx="4754880" cy="279400"/>
-          </a:xfrm>
-          <a:prstGeom prst="rect">
-            <a:avLst/>
-          </a:prstGeom>
-          <a:noFill/>
-        </p:spPr>
-        <p:txBody>
-          <a:bodyPr vert="horz" wrap="square" lIns="0" tIns="0" rIns="0" bIns="0" rtlCol="0">
-            <a:noAutofit/>
-          </a:bodyPr>
-          <a:lstStyle/>
-          <a:p>
-            <a:pPr algn="ctr"/>
-            <a:r>
-              <a:rPr lang="en-US" sz="1400" b="1">
-                <a:solidFill>
-                  <a:srgbClr val="5D6D7E"/>
-                </a:solidFill>
-                <a:latin typeface="Calibri" panose="020F0502020204030204" pitchFamily="34" charset="0"/>
-              </a:rPr>
-              <a:t>Issue #7 opened in the dashboard</a:t>
-            </a:r>
-          </a:p>
-        </p:txBody>
-      </p:sp>
-      <p:pic>
-        <p:nvPicPr>
-          <p:cNvPr id="8" name="Original screenshot 8" descr="#all-ai-assisted-yu channel in Slack"/>
-          <p:cNvPicPr>
-            <a:picLocks noChangeAspect="1"/>
-          </p:cNvPicPr>
-          <p:nvPr/>
-        </p:nvPicPr>
-        <p:blipFill>
-          <a:blip r:embed="rId5"/>
-          <a:stretch>
-            <a:fillRect/>
-          </a:stretch>
-        </p:blipFill>
-        <p:spPr>
-          <a:xfrm>
-            <a:off x="609600" y="3860800"/>
-            <a:ext cx="4754880" cy="2161309"/>
-          </a:xfrm>
-          <a:prstGeom prst="rect">
-            <a:avLst/>
-          </a:prstGeom>
-          <a:ln w="12700">
-            <a:solidFill>
-              <a:srgbClr val="C8D0D6"/>
-            </a:solidFill>
-          </a:ln>
-        </p:spPr>
-      </p:pic>
-      <p:pic>
-        <p:nvPicPr>
-          <p:cNvPr id="9" name="Dashboard screenshot 9" descr="Dashboard showing the Slack channel #all-ai-assisted-yu for Oct 15, 2026"/>
-          <p:cNvPicPr>
-            <a:picLocks noChangeAspect="1"/>
-          </p:cNvPicPr>
-          <p:nvPr/>
-        </p:nvPicPr>
-        <p:blipFill>
-          <a:blip r:embed="rId3"/>
-          <a:stretch>
-            <a:fillRect/>
-          </a:stretch>
-        </p:blipFill>
-        <p:spPr>
-          <a:xfrm>
-            <a:off x="6827520" y="3860800"/>
-            <a:ext cx="4754880" cy="2161309"/>
-          </a:xfrm>
-          <a:prstGeom prst="rect">
-            <a:avLst/>
-          </a:prstGeom>
-          <a:ln w="12700">
-            <a:solidFill>
-              <a:srgbClr val="C8D0D6"/>
-            </a:solidFill>
-          </a:ln>
-        </p:spPr>
-      </p:pic>
-      <p:sp>
-        <p:nvSpPr>
-          <p:cNvPr id="10" name="Arrow 10"/>
+            <a:endParaRPr lang="en-US"/>
+          </a:p>
+        </p:txBody>
+      </p:sp>
+      <p:sp>
+        <p:nvSpPr>
+          <p:cNvPr id="4" name="Oval 3">
+            <a:extLst>
+              <a:ext uri="{FF2B5EF4-FFF2-40B4-BE49-F238E27FC236}">
+                <a16:creationId xmlns:a16="http://schemas.microsoft.com/office/drawing/2014/main" id="{8C726FA1-1FEA-EFD9-9A3B-A88033D87869}"/>
+              </a:ext>
+            </a:extLst>
+          </p:cNvPr>
           <p:cNvSpPr/>
           <p:nvPr/>
         </p:nvSpPr>
         <p:spPr>
           <a:xfrm>
-            <a:off x="5867400" y="4776354"/>
-            <a:ext cx="457200" cy="330200"/>
+            <a:off x="1574800" y="1574800"/>
+            <a:ext cx="609600" cy="609600"/>
           </a:xfrm>
           <a:prstGeom prst="ellipse">
             <a:avLst/>
           </a:prstGeom>
           <a:solidFill>
-            <a:srgbClr val="F2A541"/>
+            <a:srgbClr val="2E8B57"/>
           </a:solidFill>
-          <a:ln>
+          <a:ln w="19050" cap="flat" cmpd="sng" algn="ctr">
             <a:noFill/>
+            <a:prstDash val="solid"/>
+            <a:miter lim="800000"/>
           </a:ln>
           <a:effectLst/>
+          <a:extLst>
+            <a:ext uri="{91240B29-F687-4F45-9708-019B960494DF}">
+              <a14:hiddenLine xmlns:a14="http://schemas.microsoft.com/office/drawing/2010/main" w="19050" cap="flat" cmpd="sng" algn="ctr">
+                <a:solidFill>
+                  <a:schemeClr val="accent1">
+                    <a:shade val="15000"/>
+                  </a:schemeClr>
+                </a:solidFill>
+                <a:prstDash val="solid"/>
+                <a:miter lim="800000"/>
+              </a14:hiddenLine>
+            </a:ext>
+          </a:extLst>
         </p:spPr>
         <p:style>
           <a:lnRef idx="2">
@@ -3930,27 +4060,33 @@
           <a:p>
             <a:pPr algn="ctr"/>
             <a:r>
-              <a:rPr lang="en-US" sz="1600" b="1">
+              <a:rPr lang="en-US" sz="2200" b="1">
                 <a:solidFill>
                   <a:srgbClr val="FFFFFF"/>
                 </a:solidFill>
                 <a:latin typeface="Calibri" panose="020F0502020204030204" pitchFamily="34" charset="0"/>
               </a:rPr>
-              <a:t>→</a:t>
-            </a:r>
-          </a:p>
-        </p:txBody>
-      </p:sp>
-      <p:sp>
-        <p:nvSpPr>
-          <p:cNvPr id="11" name="Caption 11"/>
+              <a:t>✓</a:t>
+            </a:r>
+          </a:p>
+        </p:txBody>
+      </p:sp>
+      <p:sp>
+        <p:nvSpPr>
+          <p:cNvPr id="5" name="TextBox 4">
+            <a:extLst>
+              <a:ext uri="{FF2B5EF4-FFF2-40B4-BE49-F238E27FC236}">
+                <a16:creationId xmlns:a16="http://schemas.microsoft.com/office/drawing/2014/main" id="{3D90E953-EF96-8504-7447-471C4B6CF872}"/>
+              </a:ext>
+            </a:extLst>
+          </p:cNvPr>
           <p:cNvSpPr txBox="1"/>
           <p:nvPr/>
         </p:nvSpPr>
         <p:spPr>
           <a:xfrm>
-            <a:off x="609600" y="6096000"/>
-            <a:ext cx="4754880" cy="279400"/>
+            <a:off x="736600" y="2362200"/>
+            <a:ext cx="2286000" cy="355600"/>
           </a:xfrm>
           <a:prstGeom prst="rect">
             <a:avLst/>
@@ -3965,27 +4101,179 @@
           <a:p>
             <a:pPr algn="ctr"/>
             <a:r>
-              <a:rPr lang="en-US" sz="1400" b="1">
-                <a:solidFill>
-                  <a:srgbClr val="5D6D7E"/>
+              <a:rPr lang="en-US" b="1">
+                <a:solidFill>
+                  <a:srgbClr val="1B2631"/>
                 </a:solidFill>
                 <a:latin typeface="Calibri" panose="020F0502020204030204" pitchFamily="34" charset="0"/>
               </a:rPr>
-              <a:t>#all-ai-assisted-yu, Oct 15 in Slack</a:t>
-            </a:r>
-          </a:p>
-        </p:txBody>
-      </p:sp>
-      <p:sp>
-        <p:nvSpPr>
-          <p:cNvPr id="12" name="Caption 12"/>
+              <a:t>OAuth client</a:t>
+            </a:r>
+          </a:p>
+        </p:txBody>
+      </p:sp>
+      <p:sp>
+        <p:nvSpPr>
+          <p:cNvPr id="6" name="Rectangle: Rounded Corners 5">
+            <a:extLst>
+              <a:ext uri="{FF2B5EF4-FFF2-40B4-BE49-F238E27FC236}">
+                <a16:creationId xmlns:a16="http://schemas.microsoft.com/office/drawing/2014/main" id="{92E276A1-DA06-BDB4-703B-EB8EF532E373}"/>
+              </a:ext>
+            </a:extLst>
+          </p:cNvPr>
+          <p:cNvSpPr/>
+          <p:nvPr/>
+        </p:nvSpPr>
+        <p:spPr>
+          <a:xfrm>
+            <a:off x="3429000" y="1397000"/>
+            <a:ext cx="2540000" cy="1524000"/>
+          </a:xfrm>
+          <a:prstGeom prst="roundRect">
+            <a:avLst>
+              <a:gd name="adj" fmla="val 8000"/>
+            </a:avLst>
+          </a:prstGeom>
+          <a:solidFill>
+            <a:srgbClr val="ECF2F5"/>
+          </a:solidFill>
+          <a:ln w="19050" cap="flat" cmpd="sng" algn="ctr">
+            <a:noFill/>
+            <a:prstDash val="solid"/>
+            <a:miter lim="800000"/>
+          </a:ln>
+          <a:effectLst/>
+          <a:extLst>
+            <a:ext uri="{91240B29-F687-4F45-9708-019B960494DF}">
+              <a14:hiddenLine xmlns:a14="http://schemas.microsoft.com/office/drawing/2010/main" w="19050" cap="flat" cmpd="sng" algn="ctr">
+                <a:solidFill>
+                  <a:schemeClr val="accent1">
+                    <a:shade val="15000"/>
+                  </a:schemeClr>
+                </a:solidFill>
+                <a:prstDash val="solid"/>
+                <a:miter lim="800000"/>
+              </a14:hiddenLine>
+            </a:ext>
+          </a:extLst>
+        </p:spPr>
+        <p:style>
+          <a:lnRef idx="2">
+            <a:schemeClr val="accent1">
+              <a:shade val="15000"/>
+            </a:schemeClr>
+          </a:lnRef>
+          <a:fillRef idx="1">
+            <a:schemeClr val="accent1"/>
+          </a:fillRef>
+          <a:effectRef idx="0">
+            <a:schemeClr val="accent1"/>
+          </a:effectRef>
+          <a:fontRef idx="minor">
+            <a:schemeClr val="lt1"/>
+          </a:fontRef>
+        </p:style>
+        <p:txBody>
+          <a:bodyPr rtlCol="0" anchor="ctr"/>
+          <a:lstStyle/>
+          <a:p>
+            <a:pPr algn="ctr"/>
+            <a:endParaRPr lang="en-US"/>
+          </a:p>
+        </p:txBody>
+      </p:sp>
+      <p:sp>
+        <p:nvSpPr>
+          <p:cNvPr id="7" name="Oval 6">
+            <a:extLst>
+              <a:ext uri="{FF2B5EF4-FFF2-40B4-BE49-F238E27FC236}">
+                <a16:creationId xmlns:a16="http://schemas.microsoft.com/office/drawing/2014/main" id="{AC00B5F5-79B3-65EF-45DF-C309D659470A}"/>
+              </a:ext>
+            </a:extLst>
+          </p:cNvPr>
+          <p:cNvSpPr/>
+          <p:nvPr/>
+        </p:nvSpPr>
+        <p:spPr>
+          <a:xfrm>
+            <a:off x="4394200" y="1574800"/>
+            <a:ext cx="609600" cy="609600"/>
+          </a:xfrm>
+          <a:prstGeom prst="ellipse">
+            <a:avLst/>
+          </a:prstGeom>
+          <a:solidFill>
+            <a:srgbClr val="2E8B57"/>
+          </a:solidFill>
+          <a:ln w="19050" cap="flat" cmpd="sng" algn="ctr">
+            <a:noFill/>
+            <a:prstDash val="solid"/>
+            <a:miter lim="800000"/>
+          </a:ln>
+          <a:effectLst/>
+          <a:extLst>
+            <a:ext uri="{91240B29-F687-4F45-9708-019B960494DF}">
+              <a14:hiddenLine xmlns:a14="http://schemas.microsoft.com/office/drawing/2010/main" w="19050" cap="flat" cmpd="sng" algn="ctr">
+                <a:solidFill>
+                  <a:schemeClr val="accent1">
+                    <a:shade val="15000"/>
+                  </a:schemeClr>
+                </a:solidFill>
+                <a:prstDash val="solid"/>
+                <a:miter lim="800000"/>
+              </a14:hiddenLine>
+            </a:ext>
+          </a:extLst>
+        </p:spPr>
+        <p:style>
+          <a:lnRef idx="2">
+            <a:schemeClr val="accent1">
+              <a:shade val="15000"/>
+            </a:schemeClr>
+          </a:lnRef>
+          <a:fillRef idx="1">
+            <a:schemeClr val="accent1"/>
+          </a:fillRef>
+          <a:effectRef idx="0">
+            <a:schemeClr val="accent1"/>
+          </a:effectRef>
+          <a:fontRef idx="minor">
+            <a:schemeClr val="lt1"/>
+          </a:fontRef>
+        </p:style>
+        <p:txBody>
+          <a:bodyPr rtlCol="0" anchor="ctr"/>
+          <a:lstStyle/>
+          <a:p>
+            <a:pPr algn="ctr"/>
+            <a:r>
+              <a:rPr lang="en-US" sz="2200" b="1">
+                <a:solidFill>
+                  <a:srgbClr val="FFFFFF"/>
+                </a:solidFill>
+                <a:latin typeface="Calibri" panose="020F0502020204030204" pitchFamily="34" charset="0"/>
+              </a:rPr>
+              <a:t>✓</a:t>
+            </a:r>
+          </a:p>
+        </p:txBody>
+      </p:sp>
+      <p:sp>
+        <p:nvSpPr>
+          <p:cNvPr id="8" name="TextBox 7">
+            <a:extLst>
+              <a:ext uri="{FF2B5EF4-FFF2-40B4-BE49-F238E27FC236}">
+                <a16:creationId xmlns:a16="http://schemas.microsoft.com/office/drawing/2014/main" id="{D4C8662B-8BF2-F973-7AA9-AFCC189E43F5}"/>
+              </a:ext>
+            </a:extLst>
+          </p:cNvPr>
           <p:cNvSpPr txBox="1"/>
           <p:nvPr/>
         </p:nvSpPr>
         <p:spPr>
           <a:xfrm>
-            <a:off x="6827520" y="6096000"/>
-            <a:ext cx="4754880" cy="279400"/>
+            <a:off x="3556000" y="2362200"/>
+            <a:ext cx="2286000" cy="355600"/>
           </a:xfrm>
           <a:prstGeom prst="rect">
             <a:avLst/>
@@ -4000,13 +4288,577 @@
           <a:p>
             <a:pPr algn="ctr"/>
             <a:r>
-              <a:rPr lang="en-US" sz="1400" b="1">
-                <a:solidFill>
-                  <a:srgbClr val="5D6D7E"/>
+              <a:rPr lang="en-US" b="1">
+                <a:solidFill>
+                  <a:srgbClr val="1B2631"/>
                 </a:solidFill>
                 <a:latin typeface="Calibri" panose="020F0502020204030204" pitchFamily="34" charset="0"/>
               </a:rPr>
-              <a:t>#all-ai-assisted-yu, Oct 15 opened in the dashboard</a:t>
+              <a:t>Consent screen</a:t>
+            </a:r>
+          </a:p>
+        </p:txBody>
+      </p:sp>
+      <p:sp>
+        <p:nvSpPr>
+          <p:cNvPr id="9" name="Rectangle: Rounded Corners 8">
+            <a:extLst>
+              <a:ext uri="{FF2B5EF4-FFF2-40B4-BE49-F238E27FC236}">
+                <a16:creationId xmlns:a16="http://schemas.microsoft.com/office/drawing/2014/main" id="{D57594C1-8F72-4691-9212-72D6402225E5}"/>
+              </a:ext>
+            </a:extLst>
+          </p:cNvPr>
+          <p:cNvSpPr/>
+          <p:nvPr/>
+        </p:nvSpPr>
+        <p:spPr>
+          <a:xfrm>
+            <a:off x="6248400" y="1397000"/>
+            <a:ext cx="2540000" cy="1524000"/>
+          </a:xfrm>
+          <a:prstGeom prst="roundRect">
+            <a:avLst>
+              <a:gd name="adj" fmla="val 8000"/>
+            </a:avLst>
+          </a:prstGeom>
+          <a:solidFill>
+            <a:srgbClr val="ECF2F5"/>
+          </a:solidFill>
+          <a:ln w="19050" cap="flat" cmpd="sng" algn="ctr">
+            <a:noFill/>
+            <a:prstDash val="solid"/>
+            <a:miter lim="800000"/>
+          </a:ln>
+          <a:effectLst/>
+          <a:extLst>
+            <a:ext uri="{91240B29-F687-4F45-9708-019B960494DF}">
+              <a14:hiddenLine xmlns:a14="http://schemas.microsoft.com/office/drawing/2010/main" w="19050" cap="flat" cmpd="sng" algn="ctr">
+                <a:solidFill>
+                  <a:schemeClr val="accent1">
+                    <a:shade val="15000"/>
+                  </a:schemeClr>
+                </a:solidFill>
+                <a:prstDash val="solid"/>
+                <a:miter lim="800000"/>
+              </a14:hiddenLine>
+            </a:ext>
+          </a:extLst>
+        </p:spPr>
+        <p:style>
+          <a:lnRef idx="2">
+            <a:schemeClr val="accent1">
+              <a:shade val="15000"/>
+            </a:schemeClr>
+          </a:lnRef>
+          <a:fillRef idx="1">
+            <a:schemeClr val="accent1"/>
+          </a:fillRef>
+          <a:effectRef idx="0">
+            <a:schemeClr val="accent1"/>
+          </a:effectRef>
+          <a:fontRef idx="minor">
+            <a:schemeClr val="lt1"/>
+          </a:fontRef>
+        </p:style>
+        <p:txBody>
+          <a:bodyPr rtlCol="0" anchor="ctr"/>
+          <a:lstStyle/>
+          <a:p>
+            <a:pPr algn="ctr"/>
+            <a:endParaRPr lang="en-US"/>
+          </a:p>
+        </p:txBody>
+      </p:sp>
+      <p:sp>
+        <p:nvSpPr>
+          <p:cNvPr id="10" name="Oval 9">
+            <a:extLst>
+              <a:ext uri="{FF2B5EF4-FFF2-40B4-BE49-F238E27FC236}">
+                <a16:creationId xmlns:a16="http://schemas.microsoft.com/office/drawing/2014/main" id="{1F6AC73F-DB4D-5D85-5DFF-7EC95F6A6548}"/>
+              </a:ext>
+            </a:extLst>
+          </p:cNvPr>
+          <p:cNvSpPr/>
+          <p:nvPr/>
+        </p:nvSpPr>
+        <p:spPr>
+          <a:xfrm>
+            <a:off x="7213600" y="1574800"/>
+            <a:ext cx="609600" cy="609600"/>
+          </a:xfrm>
+          <a:prstGeom prst="ellipse">
+            <a:avLst/>
+          </a:prstGeom>
+          <a:solidFill>
+            <a:srgbClr val="2E8B57"/>
+          </a:solidFill>
+          <a:ln w="19050" cap="flat" cmpd="sng" algn="ctr">
+            <a:noFill/>
+            <a:prstDash val="solid"/>
+            <a:miter lim="800000"/>
+          </a:ln>
+          <a:effectLst/>
+          <a:extLst>
+            <a:ext uri="{91240B29-F687-4F45-9708-019B960494DF}">
+              <a14:hiddenLine xmlns:a14="http://schemas.microsoft.com/office/drawing/2010/main" w="19050" cap="flat" cmpd="sng" algn="ctr">
+                <a:solidFill>
+                  <a:schemeClr val="accent1">
+                    <a:shade val="15000"/>
+                  </a:schemeClr>
+                </a:solidFill>
+                <a:prstDash val="solid"/>
+                <a:miter lim="800000"/>
+              </a14:hiddenLine>
+            </a:ext>
+          </a:extLst>
+        </p:spPr>
+        <p:style>
+          <a:lnRef idx="2">
+            <a:schemeClr val="accent1">
+              <a:shade val="15000"/>
+            </a:schemeClr>
+          </a:lnRef>
+          <a:fillRef idx="1">
+            <a:schemeClr val="accent1"/>
+          </a:fillRef>
+          <a:effectRef idx="0">
+            <a:schemeClr val="accent1"/>
+          </a:effectRef>
+          <a:fontRef idx="minor">
+            <a:schemeClr val="lt1"/>
+          </a:fontRef>
+        </p:style>
+        <p:txBody>
+          <a:bodyPr rtlCol="0" anchor="ctr"/>
+          <a:lstStyle/>
+          <a:p>
+            <a:pPr algn="ctr"/>
+            <a:r>
+              <a:rPr lang="en-US" sz="2200" b="1">
+                <a:solidFill>
+                  <a:srgbClr val="FFFFFF"/>
+                </a:solidFill>
+                <a:latin typeface="Calibri" panose="020F0502020204030204" pitchFamily="34" charset="0"/>
+              </a:rPr>
+              <a:t>✓</a:t>
+            </a:r>
+          </a:p>
+        </p:txBody>
+      </p:sp>
+      <p:sp>
+        <p:nvSpPr>
+          <p:cNvPr id="11" name="TextBox 10">
+            <a:extLst>
+              <a:ext uri="{FF2B5EF4-FFF2-40B4-BE49-F238E27FC236}">
+                <a16:creationId xmlns:a16="http://schemas.microsoft.com/office/drawing/2014/main" id="{62AED7F1-EAAC-D65E-B1DF-1FE8F06412AC}"/>
+              </a:ext>
+            </a:extLst>
+          </p:cNvPr>
+          <p:cNvSpPr txBox="1"/>
+          <p:nvPr/>
+        </p:nvSpPr>
+        <p:spPr>
+          <a:xfrm>
+            <a:off x="6375400" y="2362200"/>
+            <a:ext cx="2286000" cy="355600"/>
+          </a:xfrm>
+          <a:prstGeom prst="rect">
+            <a:avLst/>
+          </a:prstGeom>
+          <a:noFill/>
+        </p:spPr>
+        <p:txBody>
+          <a:bodyPr vert="horz" wrap="square" lIns="0" tIns="0" rIns="0" bIns="0" rtlCol="0">
+            <a:noAutofit/>
+          </a:bodyPr>
+          <a:lstStyle/>
+          <a:p>
+            <a:pPr algn="ctr"/>
+            <a:r>
+              <a:rPr lang="en-US" b="1">
+                <a:solidFill>
+                  <a:srgbClr val="1B2631"/>
+                </a:solidFill>
+                <a:latin typeface="Calibri" panose="020F0502020204030204" pitchFamily="34" charset="0"/>
+              </a:rPr>
+              <a:t>Sign-in</a:t>
+            </a:r>
+          </a:p>
+        </p:txBody>
+      </p:sp>
+      <p:sp>
+        <p:nvSpPr>
+          <p:cNvPr id="12" name="Rectangle: Rounded Corners 11">
+            <a:extLst>
+              <a:ext uri="{FF2B5EF4-FFF2-40B4-BE49-F238E27FC236}">
+                <a16:creationId xmlns:a16="http://schemas.microsoft.com/office/drawing/2014/main" id="{B73BD71F-206F-8665-D401-FB61E1D2C710}"/>
+              </a:ext>
+            </a:extLst>
+          </p:cNvPr>
+          <p:cNvSpPr/>
+          <p:nvPr/>
+        </p:nvSpPr>
+        <p:spPr>
+          <a:xfrm>
+            <a:off x="9067800" y="1397000"/>
+            <a:ext cx="2540000" cy="1524000"/>
+          </a:xfrm>
+          <a:prstGeom prst="roundRect">
+            <a:avLst>
+              <a:gd name="adj" fmla="val 8000"/>
+            </a:avLst>
+          </a:prstGeom>
+          <a:solidFill>
+            <a:srgbClr val="ECF2F5"/>
+          </a:solidFill>
+          <a:ln w="19050" cap="flat" cmpd="sng" algn="ctr">
+            <a:noFill/>
+            <a:prstDash val="solid"/>
+            <a:miter lim="800000"/>
+          </a:ln>
+          <a:effectLst/>
+          <a:extLst>
+            <a:ext uri="{91240B29-F687-4F45-9708-019B960494DF}">
+              <a14:hiddenLine xmlns:a14="http://schemas.microsoft.com/office/drawing/2010/main" w="19050" cap="flat" cmpd="sng" algn="ctr">
+                <a:solidFill>
+                  <a:schemeClr val="accent1">
+                    <a:shade val="15000"/>
+                  </a:schemeClr>
+                </a:solidFill>
+                <a:prstDash val="solid"/>
+                <a:miter lim="800000"/>
+              </a14:hiddenLine>
+            </a:ext>
+          </a:extLst>
+        </p:spPr>
+        <p:style>
+          <a:lnRef idx="2">
+            <a:schemeClr val="accent1">
+              <a:shade val="15000"/>
+            </a:schemeClr>
+          </a:lnRef>
+          <a:fillRef idx="1">
+            <a:schemeClr val="accent1"/>
+          </a:fillRef>
+          <a:effectRef idx="0">
+            <a:schemeClr val="accent1"/>
+          </a:effectRef>
+          <a:fontRef idx="minor">
+            <a:schemeClr val="lt1"/>
+          </a:fontRef>
+        </p:style>
+        <p:txBody>
+          <a:bodyPr rtlCol="0" anchor="ctr"/>
+          <a:lstStyle/>
+          <a:p>
+            <a:pPr algn="ctr"/>
+            <a:endParaRPr lang="en-US"/>
+          </a:p>
+        </p:txBody>
+      </p:sp>
+      <p:sp>
+        <p:nvSpPr>
+          <p:cNvPr id="13" name="Oval 12">
+            <a:extLst>
+              <a:ext uri="{FF2B5EF4-FFF2-40B4-BE49-F238E27FC236}">
+                <a16:creationId xmlns:a16="http://schemas.microsoft.com/office/drawing/2014/main" id="{BDEDEE59-A47F-2EAC-8B29-FF70C3C7CBAC}"/>
+              </a:ext>
+            </a:extLst>
+          </p:cNvPr>
+          <p:cNvSpPr/>
+          <p:nvPr/>
+        </p:nvSpPr>
+        <p:spPr>
+          <a:xfrm>
+            <a:off x="10033000" y="1574800"/>
+            <a:ext cx="609600" cy="609600"/>
+          </a:xfrm>
+          <a:prstGeom prst="ellipse">
+            <a:avLst/>
+          </a:prstGeom>
+          <a:solidFill>
+            <a:srgbClr val="C0392B"/>
+          </a:solidFill>
+          <a:ln w="19050" cap="flat" cmpd="sng" algn="ctr">
+            <a:noFill/>
+            <a:prstDash val="solid"/>
+            <a:miter lim="800000"/>
+          </a:ln>
+          <a:effectLst/>
+          <a:extLst>
+            <a:ext uri="{91240B29-F687-4F45-9708-019B960494DF}">
+              <a14:hiddenLine xmlns:a14="http://schemas.microsoft.com/office/drawing/2010/main" w="19050" cap="flat" cmpd="sng" algn="ctr">
+                <a:solidFill>
+                  <a:schemeClr val="accent1">
+                    <a:shade val="15000"/>
+                  </a:schemeClr>
+                </a:solidFill>
+                <a:prstDash val="solid"/>
+                <a:miter lim="800000"/>
+              </a14:hiddenLine>
+            </a:ext>
+          </a:extLst>
+        </p:spPr>
+        <p:style>
+          <a:lnRef idx="2">
+            <a:schemeClr val="accent1">
+              <a:shade val="15000"/>
+            </a:schemeClr>
+          </a:lnRef>
+          <a:fillRef idx="1">
+            <a:schemeClr val="accent1"/>
+          </a:fillRef>
+          <a:effectRef idx="0">
+            <a:schemeClr val="accent1"/>
+          </a:effectRef>
+          <a:fontRef idx="minor">
+            <a:schemeClr val="lt1"/>
+          </a:fontRef>
+        </p:style>
+        <p:txBody>
+          <a:bodyPr rtlCol="0" anchor="ctr"/>
+          <a:lstStyle/>
+          <a:p>
+            <a:pPr algn="ctr"/>
+            <a:r>
+              <a:rPr lang="en-US" sz="2200" b="1">
+                <a:solidFill>
+                  <a:srgbClr val="FFFFFF"/>
+                </a:solidFill>
+                <a:latin typeface="Calibri" panose="020F0502020204030204" pitchFamily="34" charset="0"/>
+              </a:rPr>
+              <a:t>✗</a:t>
+            </a:r>
+          </a:p>
+        </p:txBody>
+      </p:sp>
+      <p:sp>
+        <p:nvSpPr>
+          <p:cNvPr id="14" name="TextBox 13">
+            <a:extLst>
+              <a:ext uri="{FF2B5EF4-FFF2-40B4-BE49-F238E27FC236}">
+                <a16:creationId xmlns:a16="http://schemas.microsoft.com/office/drawing/2014/main" id="{B4EC3A6B-CC0A-C0E0-30D0-6AEDCC4489C3}"/>
+              </a:ext>
+            </a:extLst>
+          </p:cNvPr>
+          <p:cNvSpPr txBox="1"/>
+          <p:nvPr/>
+        </p:nvSpPr>
+        <p:spPr>
+          <a:xfrm>
+            <a:off x="9194800" y="2362200"/>
+            <a:ext cx="2286000" cy="355600"/>
+          </a:xfrm>
+          <a:prstGeom prst="rect">
+            <a:avLst/>
+          </a:prstGeom>
+          <a:noFill/>
+        </p:spPr>
+        <p:txBody>
+          <a:bodyPr vert="horz" wrap="square" lIns="0" tIns="0" rIns="0" bIns="0" rtlCol="0">
+            <a:noAutofit/>
+          </a:bodyPr>
+          <a:lstStyle/>
+          <a:p>
+            <a:pPr algn="ctr"/>
+            <a:r>
+              <a:rPr lang="en-US" b="1">
+                <a:solidFill>
+                  <a:srgbClr val="1B2631"/>
+                </a:solidFill>
+                <a:latin typeface="Calibri" panose="020F0502020204030204" pitchFamily="34" charset="0"/>
+              </a:rPr>
+              <a:t>Tool calls</a:t>
+            </a:r>
+          </a:p>
+        </p:txBody>
+      </p:sp>
+      <p:sp>
+        <p:nvSpPr>
+          <p:cNvPr id="15" name="TextBox 14">
+            <a:extLst>
+              <a:ext uri="{FF2B5EF4-FFF2-40B4-BE49-F238E27FC236}">
+                <a16:creationId xmlns:a16="http://schemas.microsoft.com/office/drawing/2014/main" id="{6717D2FB-85A7-25E0-87CD-A33DE2D335B2}"/>
+              </a:ext>
+            </a:extLst>
+          </p:cNvPr>
+          <p:cNvSpPr txBox="1"/>
+          <p:nvPr/>
+        </p:nvSpPr>
+        <p:spPr>
+          <a:xfrm>
+            <a:off x="609600" y="3302000"/>
+            <a:ext cx="10972800" cy="330200"/>
+          </a:xfrm>
+          <a:prstGeom prst="rect">
+            <a:avLst/>
+          </a:prstGeom>
+          <a:noFill/>
+        </p:spPr>
+        <p:txBody>
+          <a:bodyPr vert="horz" wrap="square" lIns="0" tIns="0" rIns="0" bIns="0" rtlCol="0">
+            <a:noAutofit/>
+          </a:bodyPr>
+          <a:lstStyle/>
+          <a:p>
+            <a:r>
+              <a:rPr lang="en-US">
+                <a:solidFill>
+                  <a:srgbClr val="1B2631"/>
+                </a:solidFill>
+                <a:latin typeface="Calibri" panose="020F0502020204030204" pitchFamily="34" charset="0"/>
+              </a:rPr>
+              <a:t>We used Google's official Gmail MCP server.</a:t>
+            </a:r>
+          </a:p>
+        </p:txBody>
+      </p:sp>
+      <p:sp>
+        <p:nvSpPr>
+          <p:cNvPr id="16" name="TextBox 15">
+            <a:extLst>
+              <a:ext uri="{FF2B5EF4-FFF2-40B4-BE49-F238E27FC236}">
+                <a16:creationId xmlns:a16="http://schemas.microsoft.com/office/drawing/2014/main" id="{1368B154-0B5E-D749-A3B2-80C71B0F507D}"/>
+              </a:ext>
+            </a:extLst>
+          </p:cNvPr>
+          <p:cNvSpPr txBox="1"/>
+          <p:nvPr/>
+        </p:nvSpPr>
+        <p:spPr>
+          <a:xfrm>
+            <a:off x="609600" y="3708400"/>
+            <a:ext cx="10972800" cy="711200"/>
+          </a:xfrm>
+          <a:prstGeom prst="rect">
+            <a:avLst/>
+          </a:prstGeom>
+          <a:noFill/>
+        </p:spPr>
+        <p:txBody>
+          <a:bodyPr vert="horz" wrap="square" lIns="0" tIns="0" rIns="0" bIns="0" rtlCol="0">
+            <a:noAutofit/>
+          </a:bodyPr>
+          <a:lstStyle/>
+          <a:p>
+            <a:r>
+              <a:rPr lang="en-US">
+                <a:solidFill>
+                  <a:srgbClr val="1B2631"/>
+                </a:solidFill>
+                <a:latin typeface="Calibri" panose="020F0502020204030204" pitchFamily="34" charset="0"/>
+              </a:rPr>
+              <a:t>Every tool call was rejected: the Google Cloud project must be in the Workspace Developer Preview Program.</a:t>
+            </a:r>
+          </a:p>
+        </p:txBody>
+      </p:sp>
+      <p:sp>
+        <p:nvSpPr>
+          <p:cNvPr id="17" name="Rectangle: Rounded Corners 16">
+            <a:extLst>
+              <a:ext uri="{FF2B5EF4-FFF2-40B4-BE49-F238E27FC236}">
+                <a16:creationId xmlns:a16="http://schemas.microsoft.com/office/drawing/2014/main" id="{3EEA04D7-467A-ADF8-C66A-21AE3DA554AB}"/>
+              </a:ext>
+            </a:extLst>
+          </p:cNvPr>
+          <p:cNvSpPr/>
+          <p:nvPr/>
+        </p:nvSpPr>
+        <p:spPr>
+          <a:xfrm>
+            <a:off x="609600" y="4699000"/>
+            <a:ext cx="10972800" cy="812800"/>
+          </a:xfrm>
+          <a:prstGeom prst="roundRect">
+            <a:avLst>
+              <a:gd name="adj" fmla="val 8000"/>
+            </a:avLst>
+          </a:prstGeom>
+          <a:solidFill>
+            <a:srgbClr val="0F2A3A"/>
+          </a:solidFill>
+          <a:ln w="19050" cap="flat" cmpd="sng" algn="ctr">
+            <a:noFill/>
+            <a:prstDash val="solid"/>
+            <a:miter lim="800000"/>
+          </a:ln>
+          <a:effectLst/>
+          <a:extLst>
+            <a:ext uri="{91240B29-F687-4F45-9708-019B960494DF}">
+              <a14:hiddenLine xmlns:a14="http://schemas.microsoft.com/office/drawing/2010/main" w="19050" cap="flat" cmpd="sng" algn="ctr">
+                <a:solidFill>
+                  <a:schemeClr val="accent1">
+                    <a:shade val="15000"/>
+                  </a:schemeClr>
+                </a:solidFill>
+                <a:prstDash val="solid"/>
+                <a:miter lim="800000"/>
+              </a14:hiddenLine>
+            </a:ext>
+          </a:extLst>
+        </p:spPr>
+        <p:style>
+          <a:lnRef idx="2">
+            <a:schemeClr val="accent1">
+              <a:shade val="15000"/>
+            </a:schemeClr>
+          </a:lnRef>
+          <a:fillRef idx="1">
+            <a:schemeClr val="accent1"/>
+          </a:fillRef>
+          <a:effectRef idx="0">
+            <a:schemeClr val="accent1"/>
+          </a:effectRef>
+          <a:fontRef idx="minor">
+            <a:schemeClr val="lt1"/>
+          </a:fontRef>
+        </p:style>
+        <p:txBody>
+          <a:bodyPr rtlCol="0" anchor="ctr"/>
+          <a:lstStyle/>
+          <a:p>
+            <a:pPr algn="ctr"/>
+            <a:endParaRPr lang="en-US"/>
+          </a:p>
+        </p:txBody>
+      </p:sp>
+      <p:sp>
+        <p:nvSpPr>
+          <p:cNvPr id="18" name="TextBox 17">
+            <a:extLst>
+              <a:ext uri="{FF2B5EF4-FFF2-40B4-BE49-F238E27FC236}">
+                <a16:creationId xmlns:a16="http://schemas.microsoft.com/office/drawing/2014/main" id="{D0396520-4F9F-3742-A712-63040A537A21}"/>
+              </a:ext>
+            </a:extLst>
+          </p:cNvPr>
+          <p:cNvSpPr txBox="1"/>
+          <p:nvPr/>
+        </p:nvSpPr>
+        <p:spPr>
+          <a:xfrm>
+            <a:off x="914400" y="4953000"/>
+            <a:ext cx="10414000" cy="355600"/>
+          </a:xfrm>
+          <a:prstGeom prst="rect">
+            <a:avLst/>
+          </a:prstGeom>
+          <a:noFill/>
+        </p:spPr>
+        <p:txBody>
+          <a:bodyPr vert="horz" wrap="square" lIns="0" tIns="0" rIns="0" bIns="0" rtlCol="0">
+            <a:noAutofit/>
+          </a:bodyPr>
+          <a:lstStyle/>
+          <a:p>
+            <a:r>
+              <a:rPr lang="en-US" sz="2000" b="1">
+                <a:solidFill>
+                  <a:srgbClr val="FFFFFF"/>
+                </a:solidFill>
+                <a:latin typeface="Calibri" panose="020F0502020204030204" pitchFamily="34" charset="0"/>
+              </a:rPr>
+              <a:t>The instructor waived Gmail, so we removed it from .mcp.json.</a:t>
             </a:r>
           </a:p>
         </p:txBody>
@@ -4014,7 +4866,7 @@
     </p:spTree>
     <p:extLst>
       <p:ext uri="{BB962C8B-B14F-4D97-AF65-F5344CB8AC3E}">
-        <p14:creationId xmlns:p14="http://schemas.microsoft.com/office/powerpoint/2010/main" val="3959444471"/>
+        <p14:creationId xmlns:p14="http://schemas.microsoft.com/office/powerpoint/2010/main" val="2418284707"/>
       </p:ext>
     </p:extLst>
   </p:cSld>
@@ -4024,7 +4876,7 @@
 </p:sld>
 </file>
 
-<file path=ppt/slides/slide11.xml><?xml version="1.0" encoding="utf-8"?>
+<file path=ppt/slides/slide12.xml><?xml version="1.0" encoding="utf-8"?>
 <p:sld xmlns:a="http://schemas.openxmlformats.org/drawingml/2006/main" xmlns:r="http://schemas.openxmlformats.org/officeDocument/2006/relationships" xmlns:p="http://schemas.openxmlformats.org/presentationml/2006/main">
   <p:cSld>
     <p:bg>
@@ -7765,7 +8617,7 @@
           <p:cNvPr id="2" name="TextBox 1">
             <a:extLst>
               <a:ext uri="{FF2B5EF4-FFF2-40B4-BE49-F238E27FC236}">
-                <a16:creationId xmlns:a16="http://schemas.microsoft.com/office/drawing/2014/main" id="{3551A8B1-E95A-4E3C-71AA-31A527E0D49C}"/>
+                <a16:creationId xmlns:a16="http://schemas.microsoft.com/office/drawing/2014/main" id="{56203EDF-67A8-5508-AA90-DCDDA0D7F857}"/>
               </a:ext>
             </a:extLst>
           </p:cNvPr>
@@ -7795,17 +8647,99 @@
                 </a:solidFill>
                 <a:latin typeface="Cambria" panose="02040503050406030204" pitchFamily="18" charset="0"/>
               </a:rPr>
-              <a:t>One storage format for every service</a:t>
-            </a:r>
-          </a:p>
-        </p:txBody>
-      </p:sp>
-      <p:sp>
-        <p:nvSpPr>
-          <p:cNvPr id="3" name="Rectangle: Rounded Corners 2">
-            <a:extLst>
-              <a:ext uri="{FF2B5EF4-FFF2-40B4-BE49-F238E27FC236}">
-                <a16:creationId xmlns:a16="http://schemas.microsoft.com/office/drawing/2014/main" id="{521CE9F6-CF2E-0AE9-402B-4BB420593063}"/>
+              <a:t>GitHub: original issue and local copy</a:t>
+            </a:r>
+          </a:p>
+        </p:txBody>
+      </p:sp>
+      <p:sp>
+        <p:nvSpPr>
+          <p:cNvPr id="7" name="TextBox 6">
+            <a:extLst>
+              <a:ext uri="{FF2B5EF4-FFF2-40B4-BE49-F238E27FC236}">
+                <a16:creationId xmlns:a16="http://schemas.microsoft.com/office/drawing/2014/main" id="{AEF56CD8-FA1B-63A2-ED73-294DF9052E6A}"/>
+              </a:ext>
+            </a:extLst>
+          </p:cNvPr>
+          <p:cNvSpPr txBox="1"/>
+          <p:nvPr/>
+        </p:nvSpPr>
+        <p:spPr>
+          <a:xfrm>
+            <a:off x="457200" y="5867400"/>
+            <a:ext cx="5486400" cy="279400"/>
+          </a:xfrm>
+          <a:prstGeom prst="rect">
+            <a:avLst/>
+          </a:prstGeom>
+          <a:noFill/>
+        </p:spPr>
+        <p:txBody>
+          <a:bodyPr vert="horz" wrap="square" lIns="0" tIns="0" rIns="0" bIns="0" rtlCol="0">
+            <a:noAutofit/>
+          </a:bodyPr>
+          <a:lstStyle/>
+          <a:p>
+            <a:pPr algn="ctr"/>
+            <a:r>
+              <a:rPr lang="en-US" sz="1400" b="1">
+                <a:solidFill>
+                  <a:srgbClr val="5D6D7E"/>
+                </a:solidFill>
+                <a:latin typeface="Calibri" panose="020F0502020204030204" pitchFamily="34" charset="0"/>
+              </a:rPr>
+              <a:t>Issue #7 in GitHub</a:t>
+            </a:r>
+          </a:p>
+        </p:txBody>
+      </p:sp>
+      <p:sp>
+        <p:nvSpPr>
+          <p:cNvPr id="8" name="TextBox 7">
+            <a:extLst>
+              <a:ext uri="{FF2B5EF4-FFF2-40B4-BE49-F238E27FC236}">
+                <a16:creationId xmlns:a16="http://schemas.microsoft.com/office/drawing/2014/main" id="{34DFFE93-2DE7-6F86-3062-AA05CD9355DF}"/>
+              </a:ext>
+            </a:extLst>
+          </p:cNvPr>
+          <p:cNvSpPr txBox="1"/>
+          <p:nvPr/>
+        </p:nvSpPr>
+        <p:spPr>
+          <a:xfrm>
+            <a:off x="6248400" y="5867400"/>
+            <a:ext cx="5486400" cy="279400"/>
+          </a:xfrm>
+          <a:prstGeom prst="rect">
+            <a:avLst/>
+          </a:prstGeom>
+          <a:noFill/>
+        </p:spPr>
+        <p:txBody>
+          <a:bodyPr vert="horz" wrap="square" lIns="0" tIns="0" rIns="0" bIns="0" rtlCol="0">
+            <a:noAutofit/>
+          </a:bodyPr>
+          <a:lstStyle/>
+          <a:p>
+            <a:pPr algn="ctr"/>
+            <a:r>
+              <a:rPr lang="en-US" sz="1400" b="1">
+                <a:solidFill>
+                  <a:srgbClr val="5D6D7E"/>
+                </a:solidFill>
+                <a:latin typeface="Calibri" panose="020F0502020204030204" pitchFamily="34" charset="0"/>
+              </a:rPr>
+              <a:t>Issue #7 opened in the dashboard</a:t>
+            </a:r>
+          </a:p>
+        </p:txBody>
+      </p:sp>
+      <p:sp>
+        <p:nvSpPr>
+          <p:cNvPr id="9" name="Oval 8">
+            <a:extLst>
+              <a:ext uri="{FF2B5EF4-FFF2-40B4-BE49-F238E27FC236}">
+                <a16:creationId xmlns:a16="http://schemas.microsoft.com/office/drawing/2014/main" id="{D2C93273-C0DB-416B-0A2F-F4145DE8E85A}"/>
               </a:ext>
             </a:extLst>
           </p:cNvPr>
@@ -7814,16 +8748,14 @@
         </p:nvSpPr>
         <p:spPr>
           <a:xfrm>
-            <a:off x="609600" y="1270000"/>
-            <a:ext cx="5207000" cy="4064000"/>
-          </a:xfrm>
-          <a:prstGeom prst="roundRect">
-            <a:avLst>
-              <a:gd name="adj" fmla="val 8000"/>
-            </a:avLst>
+            <a:off x="5867400" y="3200400"/>
+            <a:ext cx="457200" cy="330200"/>
+          </a:xfrm>
+          <a:prstGeom prst="ellipse">
+            <a:avLst/>
           </a:prstGeom>
           <a:solidFill>
-            <a:srgbClr val="0F2A3A"/>
+            <a:srgbClr val="F2A541"/>
           </a:solidFill>
           <a:ln w="19050" cap="flat" cmpd="sng" algn="ctr">
             <a:noFill/>
@@ -7866,525 +8798,104 @@
           <a:lstStyle/>
           <a:p>
             <a:pPr algn="ctr"/>
-            <a:endParaRPr lang="en-US"/>
-          </a:p>
-        </p:txBody>
-      </p:sp>
-      <p:sp>
-        <p:nvSpPr>
-          <p:cNvPr id="4" name="TextBox 3">
-            <a:extLst>
-              <a:ext uri="{FF2B5EF4-FFF2-40B4-BE49-F238E27FC236}">
-                <a16:creationId xmlns:a16="http://schemas.microsoft.com/office/drawing/2014/main" id="{E875462C-477F-E473-7635-171DB7863206}"/>
-              </a:ext>
-            </a:extLst>
-          </p:cNvPr>
-          <p:cNvSpPr txBox="1"/>
-          <p:nvPr/>
-        </p:nvSpPr>
-        <p:spPr>
-          <a:xfrm>
-            <a:off x="838200" y="1498600"/>
-            <a:ext cx="4826000" cy="3810000"/>
+            <a:r>
+              <a:rPr lang="en-US" sz="1600" b="1">
+                <a:solidFill>
+                  <a:srgbClr val="FFFFFF"/>
+                </a:solidFill>
+                <a:latin typeface="Calibri" panose="020F0502020204030204" pitchFamily="34" charset="0"/>
+              </a:rPr>
+              <a:t>→</a:t>
+            </a:r>
+          </a:p>
+        </p:txBody>
+      </p:sp>
+      <p:pic>
+        <p:nvPicPr>
+          <p:cNvPr id="5" name="Picture 3">
+            <a:extLst>
+              <a:ext uri="{FF2B5EF4-FFF2-40B4-BE49-F238E27FC236}">
+                <a16:creationId xmlns:a16="http://schemas.microsoft.com/office/drawing/2014/main" id="{C7868939-279A-2245-E905-98A2672BEC36}"/>
+              </a:ext>
+            </a:extLst>
+          </p:cNvPr>
+          <p:cNvPicPr>
+            <a:picLocks/>
+          </p:cNvPicPr>
+          <p:nvPr/>
+        </p:nvPicPr>
+        <p:blipFill>
+          <a:blip r:embed="rId2">
+            <a:extLst>
+              <a:ext uri="{28A0092B-C50C-407E-A947-70E740481C1C}">
+                <a14:useLocalDpi xmlns:a14="http://schemas.microsoft.com/office/drawing/2010/main" val="0"/>
+              </a:ext>
+            </a:extLst>
+          </a:blip>
+          <a:stretch>
+            <a:fillRect/>
+          </a:stretch>
+        </p:blipFill>
+        <p:spPr>
+          <a:xfrm>
+            <a:off x="457200" y="2042052"/>
+            <a:ext cx="5486400" cy="2646896"/>
           </a:xfrm>
           <a:prstGeom prst="rect">
             <a:avLst/>
           </a:prstGeom>
-          <a:noFill/>
-        </p:spPr>
-        <p:txBody>
-          <a:bodyPr vert="horz" wrap="square" lIns="0" tIns="0" rIns="0" bIns="0" rtlCol="0">
-            <a:noAutofit/>
-          </a:bodyPr>
-          <a:lstStyle/>
-          <a:p>
-            <a:r>
-              <a:rPr lang="en-US" sz="1300">
-                <a:solidFill>
-                  <a:srgbClr val="FFFFFF"/>
-                </a:solidFill>
-                <a:latin typeface="Courier New" panose="02070309020205020404" pitchFamily="49" charset="0"/>
-              </a:rPr>
-              <a:t>dataExports/</a:t>
-            </a:r>
-          </a:p>
-          <a:p>
-            <a:r>
-              <a:rPr lang="en-US" sz="1300">
-                <a:solidFill>
-                  <a:srgbClr val="FFFFFF"/>
-                </a:solidFill>
-                <a:latin typeface="Courier New" panose="02070309020205020404" pitchFamily="49" charset="0"/>
-              </a:rPr>
-              <a:t>  notion/</a:t>
-            </a:r>
-          </a:p>
-          <a:p>
-            <a:r>
-              <a:rPr lang="en-US" sz="1300">
-                <a:solidFill>
-                  <a:srgbClr val="FFFFFF"/>
-                </a:solidFill>
-                <a:latin typeface="Courier New" panose="02070309020205020404" pitchFamily="49" charset="0"/>
-              </a:rPr>
-              <a:t>    index.json</a:t>
-            </a:r>
-          </a:p>
-          <a:p>
-            <a:r>
-              <a:rPr lang="en-US" sz="1300">
-                <a:solidFill>
-                  <a:srgbClr val="FFFFFF"/>
-                </a:solidFill>
-                <a:latin typeface="Courier New" panose="02070309020205020404" pitchFamily="49" charset="0"/>
-              </a:rPr>
-              <a:t>    2026-10-13_project-falcon-…_88f5398c/</a:t>
-            </a:r>
-          </a:p>
-          <a:p>
-            <a:r>
-              <a:rPr lang="en-US" sz="1300">
-                <a:solidFill>
-                  <a:srgbClr val="FFFFFF"/>
-                </a:solidFill>
-                <a:latin typeface="Courier New" panose="02070309020205020404" pitchFamily="49" charset="0"/>
-              </a:rPr>
-              <a:t>      content.md</a:t>
-            </a:r>
-          </a:p>
-          <a:p>
-            <a:r>
-              <a:rPr lang="en-US" sz="1300">
-                <a:solidFill>
-                  <a:srgbClr val="FFFFFF"/>
-                </a:solidFill>
-                <a:latin typeface="Courier New" panose="02070309020205020404" pitchFamily="49" charset="0"/>
-              </a:rPr>
-              <a:t>      metadata.json</a:t>
-            </a:r>
-          </a:p>
-          <a:p>
-            <a:r>
-              <a:rPr lang="en-US" sz="1300">
-                <a:solidFill>
-                  <a:srgbClr val="FFFFFF"/>
-                </a:solidFill>
-                <a:latin typeface="Courier New" panose="02070309020205020404" pitchFamily="49" charset="0"/>
-              </a:rPr>
-              <a:t>  jira/</a:t>
-            </a:r>
-          </a:p>
-          <a:p>
-            <a:r>
-              <a:rPr lang="en-US" sz="1300">
-                <a:solidFill>
-                  <a:srgbClr val="FFFFFF"/>
-                </a:solidFill>
-                <a:latin typeface="Courier New" panose="02070309020205020404" pitchFamily="49" charset="0"/>
-              </a:rPr>
-              <a:t>    index.json</a:t>
-            </a:r>
-          </a:p>
-          <a:p>
-            <a:r>
-              <a:rPr lang="en-US" sz="1300">
-                <a:solidFill>
-                  <a:srgbClr val="FFFFFF"/>
-                </a:solidFill>
-                <a:latin typeface="Courier New" panose="02070309020205020404" pitchFamily="49" charset="0"/>
-              </a:rPr>
-              <a:t>    2026-10-14_falcon-12_write-readme-…_10031/</a:t>
-            </a:r>
-          </a:p>
-          <a:p>
-            <a:r>
-              <a:rPr lang="en-US" sz="1300">
-                <a:solidFill>
-                  <a:srgbClr val="FFFFFF"/>
-                </a:solidFill>
-                <a:latin typeface="Courier New" panose="02070309020205020404" pitchFamily="49" charset="0"/>
-              </a:rPr>
-              <a:t>      content.md</a:t>
-            </a:r>
-          </a:p>
-          <a:p>
-            <a:r>
-              <a:rPr lang="en-US" sz="1300">
-                <a:solidFill>
-                  <a:srgbClr val="FFFFFF"/>
-                </a:solidFill>
-                <a:latin typeface="Courier New" panose="02070309020205020404" pitchFamily="49" charset="0"/>
-              </a:rPr>
-              <a:t>      metadata.json</a:t>
-            </a:r>
-          </a:p>
-        </p:txBody>
-      </p:sp>
-      <p:sp>
-        <p:nvSpPr>
-          <p:cNvPr id="5" name="Rectangle: Rounded Corners 4">
-            <a:extLst>
-              <a:ext uri="{FF2B5EF4-FFF2-40B4-BE49-F238E27FC236}">
-                <a16:creationId xmlns:a16="http://schemas.microsoft.com/office/drawing/2014/main" id="{5CD2382F-184F-96EC-DDD4-8579CD62EF57}"/>
-              </a:ext>
-            </a:extLst>
-          </p:cNvPr>
-          <p:cNvSpPr/>
-          <p:nvPr/>
-        </p:nvSpPr>
-        <p:spPr>
-          <a:xfrm>
-            <a:off x="6121400" y="1270000"/>
-            <a:ext cx="5461000" cy="2540000"/>
-          </a:xfrm>
-          <a:prstGeom prst="roundRect">
-            <a:avLst>
-              <a:gd name="adj" fmla="val 8000"/>
-            </a:avLst>
-          </a:prstGeom>
-          <a:solidFill>
-            <a:srgbClr val="ECF2F5"/>
-          </a:solidFill>
-          <a:ln w="19050" cap="flat" cmpd="sng" algn="ctr">
-            <a:noFill/>
-            <a:prstDash val="solid"/>
-            <a:miter lim="800000"/>
+          <a:ln w="12700">
+            <a:solidFill>
+              <a:srgbClr val="C8D0D6"/>
+            </a:solidFill>
           </a:ln>
-          <a:effectLst/>
-          <a:extLst>
-            <a:ext uri="{91240B29-F687-4F45-9708-019B960494DF}">
-              <a14:hiddenLine xmlns:a14="http://schemas.microsoft.com/office/drawing/2010/main" w="19050" cap="flat" cmpd="sng" algn="ctr">
-                <a:solidFill>
-                  <a:schemeClr val="accent1">
-                    <a:shade val="15000"/>
-                  </a:schemeClr>
-                </a:solidFill>
-                <a:prstDash val="solid"/>
-                <a:miter lim="800000"/>
-              </a14:hiddenLine>
-            </a:ext>
-          </a:extLst>
-        </p:spPr>
-        <p:style>
-          <a:lnRef idx="2">
-            <a:schemeClr val="accent1">
-              <a:shade val="15000"/>
-            </a:schemeClr>
-          </a:lnRef>
-          <a:fillRef idx="1">
-            <a:schemeClr val="accent1"/>
-          </a:fillRef>
-          <a:effectRef idx="0">
-            <a:schemeClr val="accent1"/>
-          </a:effectRef>
-          <a:fontRef idx="minor">
-            <a:schemeClr val="lt1"/>
-          </a:fontRef>
-        </p:style>
-        <p:txBody>
-          <a:bodyPr rtlCol="0" anchor="ctr"/>
-          <a:lstStyle/>
-          <a:p>
-            <a:pPr algn="ctr"/>
-            <a:endParaRPr lang="en-US"/>
-          </a:p>
-        </p:txBody>
-      </p:sp>
-      <p:sp>
-        <p:nvSpPr>
-          <p:cNvPr id="6" name="TextBox 5">
-            <a:extLst>
-              <a:ext uri="{FF2B5EF4-FFF2-40B4-BE49-F238E27FC236}">
-                <a16:creationId xmlns:a16="http://schemas.microsoft.com/office/drawing/2014/main" id="{05BBDAAD-6F58-A42A-5264-F0EC6493B90A}"/>
-              </a:ext>
-            </a:extLst>
-          </p:cNvPr>
-          <p:cNvSpPr txBox="1"/>
-          <p:nvPr/>
-        </p:nvSpPr>
-        <p:spPr>
-          <a:xfrm>
-            <a:off x="6350000" y="1473200"/>
-            <a:ext cx="5080000" cy="2540000"/>
+        </p:spPr>
+      </p:pic>
+      <p:pic>
+        <p:nvPicPr>
+          <p:cNvPr id="11" name="Picture 5">
+            <a:extLst>
+              <a:ext uri="{FF2B5EF4-FFF2-40B4-BE49-F238E27FC236}">
+                <a16:creationId xmlns:a16="http://schemas.microsoft.com/office/drawing/2014/main" id="{5BAC7C99-AFEC-52D0-E5F3-751EE7627F2C}"/>
+              </a:ext>
+            </a:extLst>
+          </p:cNvPr>
+          <p:cNvPicPr>
+            <a:picLocks/>
+          </p:cNvPicPr>
+          <p:nvPr/>
+        </p:nvPicPr>
+        <p:blipFill>
+          <a:blip r:embed="rId3">
+            <a:extLst>
+              <a:ext uri="{28A0092B-C50C-407E-A947-70E740481C1C}">
+                <a14:useLocalDpi xmlns:a14="http://schemas.microsoft.com/office/drawing/2010/main" val="0"/>
+              </a:ext>
+            </a:extLst>
+          </a:blip>
+          <a:stretch>
+            <a:fillRect/>
+          </a:stretch>
+        </p:blipFill>
+        <p:spPr>
+          <a:xfrm>
+            <a:off x="6248400" y="2118591"/>
+            <a:ext cx="5486400" cy="2493818"/>
           </a:xfrm>
           <a:prstGeom prst="rect">
             <a:avLst/>
           </a:prstGeom>
-          <a:noFill/>
-        </p:spPr>
-        <p:txBody>
-          <a:bodyPr vert="horz" wrap="square" lIns="0" tIns="0" rIns="0" bIns="0" rtlCol="0">
-            <a:noAutofit/>
-          </a:bodyPr>
-          <a:lstStyle/>
-          <a:p>
-            <a:r>
-              <a:rPr lang="en-US" sz="1300">
-                <a:solidFill>
-                  <a:srgbClr val="1B2631"/>
-                </a:solidFill>
-                <a:latin typeface="Courier New" panose="02070309020205020404" pitchFamily="49" charset="0"/>
-              </a:rPr>
-              <a:t>{</a:t>
-            </a:r>
-          </a:p>
-          <a:p>
-            <a:r>
-              <a:rPr lang="en-US" sz="1300">
-                <a:solidFill>
-                  <a:srgbClr val="1B2631"/>
-                </a:solidFill>
-                <a:latin typeface="Courier New" panose="02070309020205020404" pitchFamily="49" charset="0"/>
-              </a:rPr>
-              <a:t>  "service": "jira",</a:t>
-            </a:r>
-          </a:p>
-          <a:p>
-            <a:r>
-              <a:rPr lang="en-US" sz="1300">
-                <a:solidFill>
-                  <a:srgbClr val="1B2631"/>
-                </a:solidFill>
-                <a:latin typeface="Courier New" panose="02070309020205020404" pitchFamily="49" charset="0"/>
-              </a:rPr>
-              <a:t>  "id": "10031",</a:t>
-            </a:r>
-          </a:p>
-          <a:p>
-            <a:r>
-              <a:rPr lang="en-US" sz="1300">
-                <a:solidFill>
-                  <a:srgbClr val="1B2631"/>
-                </a:solidFill>
-                <a:latin typeface="Courier New" panose="02070309020205020404" pitchFamily="49" charset="0"/>
-              </a:rPr>
-              <a:t>  "key": "FALCON-12",</a:t>
-            </a:r>
-          </a:p>
-          <a:p>
-            <a:r>
-              <a:rPr lang="en-US" sz="1300">
-                <a:solidFill>
-                  <a:srgbClr val="1B2631"/>
-                </a:solidFill>
-                <a:latin typeface="Courier New" panose="02070309020205020404" pitchFamily="49" charset="0"/>
-              </a:rPr>
-              <a:t>  "title": "Write README instructions…",</a:t>
-            </a:r>
-          </a:p>
-          <a:p>
-            <a:r>
-              <a:rPr lang="en-US" sz="1300">
-                <a:solidFill>
-                  <a:srgbClr val="1B2631"/>
-                </a:solidFill>
-                <a:latin typeface="Courier New" panose="02070309020205020404" pitchFamily="49" charset="0"/>
-              </a:rPr>
-              <a:t>  "created_time": "2026-10-14T01:39:18Z",</a:t>
-            </a:r>
-          </a:p>
-          <a:p>
-            <a:r>
-              <a:rPr lang="en-US" sz="1300">
-                <a:solidFill>
-                  <a:srgbClr val="1B2631"/>
-                </a:solidFill>
-                <a:latin typeface="Courier New" panose="02070309020205020404" pitchFamily="49" charset="0"/>
-              </a:rPr>
-              <a:t>  "downloaded_at": "2026-10-14T01:41:47Z",</a:t>
-            </a:r>
-          </a:p>
-          <a:p>
-            <a:r>
-              <a:rPr lang="en-US" sz="1300">
-                <a:solidFill>
-                  <a:srgbClr val="1B2631"/>
-                </a:solidFill>
-                <a:latin typeface="Courier New" panose="02070309020205020404" pitchFamily="49" charset="0"/>
-              </a:rPr>
-              <a:t>  "download_request": { "tool": … }</a:t>
-            </a:r>
-          </a:p>
-          <a:p>
-            <a:r>
-              <a:rPr lang="en-US" sz="1300">
-                <a:solidFill>
-                  <a:srgbClr val="1B2631"/>
-                </a:solidFill>
-                <a:latin typeface="Courier New" panose="02070309020205020404" pitchFamily="49" charset="0"/>
-              </a:rPr>
-              <a:t>}</a:t>
-            </a:r>
-          </a:p>
-        </p:txBody>
-      </p:sp>
-      <p:sp>
-        <p:nvSpPr>
-          <p:cNvPr id="7" name="TextBox 6">
-            <a:extLst>
-              <a:ext uri="{FF2B5EF4-FFF2-40B4-BE49-F238E27FC236}">
-                <a16:creationId xmlns:a16="http://schemas.microsoft.com/office/drawing/2014/main" id="{1F53CBB6-E605-DAE0-6BEF-D188F3A855EF}"/>
-              </a:ext>
-            </a:extLst>
-          </p:cNvPr>
-          <p:cNvSpPr txBox="1"/>
-          <p:nvPr/>
-        </p:nvSpPr>
-        <p:spPr>
-          <a:xfrm>
-            <a:off x="6121400" y="4318000"/>
-            <a:ext cx="5461000" cy="1270000"/>
-          </a:xfrm>
-          <a:prstGeom prst="rect">
-            <a:avLst/>
-          </a:prstGeom>
-          <a:noFill/>
-        </p:spPr>
-        <p:txBody>
-          <a:bodyPr vert="horz" wrap="square" lIns="0" tIns="0" rIns="0" bIns="0" rtlCol="0">
-            <a:noAutofit/>
-          </a:bodyPr>
-          <a:lstStyle/>
-          <a:p>
-            <a:pPr marL="228600" indent="-228600">
-              <a:spcAft>
-                <a:spcPts val="800"/>
-              </a:spcAft>
-              <a:buFont typeface="+mj-lt"/>
-              <a:buChar char="•"/>
-            </a:pPr>
-            <a:r>
-              <a:rPr lang="en-US" sz="1500">
-                <a:solidFill>
-                  <a:srgbClr val="1B2631"/>
-                </a:solidFill>
-                <a:latin typeface="Calibri" panose="020F0502020204030204" pitchFamily="34" charset="0"/>
-              </a:rPr>
-              <a:t>One folder per item: content.md + metadata.json</a:t>
-            </a:r>
-          </a:p>
-          <a:p>
-            <a:pPr marL="228600" indent="-228600">
-              <a:spcAft>
-                <a:spcPts val="800"/>
-              </a:spcAft>
-              <a:buFont typeface="+mj-lt"/>
-              <a:buChar char="•"/>
-            </a:pPr>
-            <a:r>
-              <a:rPr lang="en-US" sz="1500">
-                <a:solidFill>
-                  <a:srgbClr val="1B2631"/>
-                </a:solidFill>
-                <a:latin typeface="Calibri" panose="020F0502020204030204" pitchFamily="34" charset="0"/>
-              </a:rPr>
-              <a:t>index.json lists every item per service</a:t>
-            </a:r>
-          </a:p>
-          <a:p>
-            <a:pPr marL="228600" indent="-228600">
-              <a:spcAft>
-                <a:spcPts val="800"/>
-              </a:spcAft>
-              <a:buFont typeface="+mj-lt"/>
-              <a:buChar char="•"/>
-            </a:pPr>
-            <a:r>
-              <a:rPr lang="en-US" sz="1500">
-                <a:solidFill>
-                  <a:srgbClr val="1B2631"/>
-                </a:solidFill>
-                <a:latin typeface="Calibri" panose="020F0502020204030204" pitchFamily="34" charset="0"/>
-              </a:rPr>
-              <a:t>The item ID is the identity, so re-downloads update instead of duplicating</a:t>
-            </a:r>
-          </a:p>
-        </p:txBody>
-      </p:sp>
-      <p:sp>
-        <p:nvSpPr>
-          <p:cNvPr id="8" name="TextBox 7">
-            <a:extLst>
-              <a:ext uri="{FF2B5EF4-FFF2-40B4-BE49-F238E27FC236}">
-                <a16:creationId xmlns:a16="http://schemas.microsoft.com/office/drawing/2014/main" id="{D9B68717-3F1D-C6A7-ED2C-F102588C936C}"/>
-              </a:ext>
-            </a:extLst>
-          </p:cNvPr>
-          <p:cNvSpPr txBox="1"/>
-          <p:nvPr/>
-        </p:nvSpPr>
-        <p:spPr>
-          <a:xfrm>
-            <a:off x="609600" y="5486400"/>
-            <a:ext cx="5207000" cy="279400"/>
-          </a:xfrm>
-          <a:prstGeom prst="rect">
-            <a:avLst/>
-          </a:prstGeom>
-          <a:noFill/>
-        </p:spPr>
-        <p:txBody>
-          <a:bodyPr vert="horz" wrap="square" lIns="0" tIns="0" rIns="0" bIns="0" rtlCol="0">
-            <a:noAutofit/>
-          </a:bodyPr>
-          <a:lstStyle/>
-          <a:p>
-            <a:r>
-              <a:rPr lang="en-US" sz="1400">
-                <a:solidFill>
-                  <a:srgbClr val="5D6D7E"/>
-                </a:solidFill>
-                <a:latin typeface="Calibri" panose="020F0502020204030204" pitchFamily="34" charset="0"/>
-              </a:rPr>
-              <a:t>Folder layout (full spec: localStorageFormats.md)</a:t>
-            </a:r>
-          </a:p>
-        </p:txBody>
-      </p:sp>
-      <p:sp>
-        <p:nvSpPr>
-          <p:cNvPr id="9" name="TextBox 8">
-            <a:extLst>
-              <a:ext uri="{FF2B5EF4-FFF2-40B4-BE49-F238E27FC236}">
-                <a16:creationId xmlns:a16="http://schemas.microsoft.com/office/drawing/2014/main" id="{DFA17614-E1EF-9A8B-8ED4-FC0D07BC0436}"/>
-              </a:ext>
-            </a:extLst>
-          </p:cNvPr>
-          <p:cNvSpPr txBox="1"/>
-          <p:nvPr/>
-        </p:nvSpPr>
-        <p:spPr>
-          <a:xfrm>
-            <a:off x="6121400" y="3911600"/>
-            <a:ext cx="5461000" cy="279400"/>
-          </a:xfrm>
-          <a:prstGeom prst="rect">
-            <a:avLst/>
-          </a:prstGeom>
-          <a:noFill/>
-        </p:spPr>
-        <p:txBody>
-          <a:bodyPr vert="horz" wrap="square" lIns="0" tIns="0" rIns="0" bIns="0" rtlCol="0">
-            <a:noAutofit/>
-          </a:bodyPr>
-          <a:lstStyle/>
-          <a:p>
-            <a:r>
-              <a:rPr lang="en-US" sz="1400">
-                <a:solidFill>
-                  <a:srgbClr val="5D6D7E"/>
-                </a:solidFill>
-                <a:latin typeface="Calibri" panose="020F0502020204030204" pitchFamily="34" charset="0"/>
-              </a:rPr>
-              <a:t>metadata.json (shortened)</a:t>
-            </a:r>
-          </a:p>
-        </p:txBody>
-      </p:sp>
+          <a:ln w="12700">
+            <a:solidFill>
+              <a:srgbClr val="C8D0D6"/>
+            </a:solidFill>
+          </a:ln>
+        </p:spPr>
+      </p:pic>
     </p:spTree>
     <p:extLst>
       <p:ext uri="{BB962C8B-B14F-4D97-AF65-F5344CB8AC3E}">
-        <p14:creationId xmlns:p14="http://schemas.microsoft.com/office/powerpoint/2010/main" val="387521825"/>
+        <p14:creationId xmlns:p14="http://schemas.microsoft.com/office/powerpoint/2010/main" val="1246806359"/>
       </p:ext>
     </p:extLst>
   </p:cSld>
@@ -8424,7 +8935,7 @@
           <p:cNvPr id="2" name="TextBox 1">
             <a:extLst>
               <a:ext uri="{FF2B5EF4-FFF2-40B4-BE49-F238E27FC236}">
-                <a16:creationId xmlns:a16="http://schemas.microsoft.com/office/drawing/2014/main" id="{28EF36EC-2A3C-BFA6-54CD-88C6037BF26C}"/>
+                <a16:creationId xmlns:a16="http://schemas.microsoft.com/office/drawing/2014/main" id="{56203EDF-67A8-5508-AA90-DCDDA0D7F857}"/>
               </a:ext>
             </a:extLst>
           </p:cNvPr>
@@ -8454,17 +8965,99 @@
                 </a:solidFill>
                 <a:latin typeface="Cambria" panose="02040503050406030204" pitchFamily="18" charset="0"/>
               </a:rPr>
-              <a:t>Skills for repeatable downloads</a:t>
-            </a:r>
-          </a:p>
-        </p:txBody>
-      </p:sp>
-      <p:sp>
-        <p:nvSpPr>
-          <p:cNvPr id="3" name="Rectangle: Rounded Corners 2">
-            <a:extLst>
-              <a:ext uri="{FF2B5EF4-FFF2-40B4-BE49-F238E27FC236}">
-                <a16:creationId xmlns:a16="http://schemas.microsoft.com/office/drawing/2014/main" id="{7F54901D-5594-55AC-680D-2E347AC3FFA8}"/>
+              <a:t>Slack: original channel and local copy</a:t>
+            </a:r>
+          </a:p>
+        </p:txBody>
+      </p:sp>
+      <p:sp>
+        <p:nvSpPr>
+          <p:cNvPr id="7" name="TextBox 6">
+            <a:extLst>
+              <a:ext uri="{FF2B5EF4-FFF2-40B4-BE49-F238E27FC236}">
+                <a16:creationId xmlns:a16="http://schemas.microsoft.com/office/drawing/2014/main" id="{AEF56CD8-FA1B-63A2-ED73-294DF9052E6A}"/>
+              </a:ext>
+            </a:extLst>
+          </p:cNvPr>
+          <p:cNvSpPr txBox="1"/>
+          <p:nvPr/>
+        </p:nvSpPr>
+        <p:spPr>
+          <a:xfrm>
+            <a:off x="457200" y="5867400"/>
+            <a:ext cx="5486400" cy="279400"/>
+          </a:xfrm>
+          <a:prstGeom prst="rect">
+            <a:avLst/>
+          </a:prstGeom>
+          <a:noFill/>
+        </p:spPr>
+        <p:txBody>
+          <a:bodyPr vert="horz" wrap="square" lIns="0" tIns="0" rIns="0" bIns="0" rtlCol="0">
+            <a:noAutofit/>
+          </a:bodyPr>
+          <a:lstStyle/>
+          <a:p>
+            <a:pPr algn="ctr"/>
+            <a:r>
+              <a:rPr lang="en-US" sz="1400" b="1">
+                <a:solidFill>
+                  <a:srgbClr val="5D6D7E"/>
+                </a:solidFill>
+                <a:latin typeface="Calibri" panose="020F0502020204030204" pitchFamily="34" charset="0"/>
+              </a:rPr>
+              <a:t>#all-ai-assisted-yu, Oct 15 in Slack</a:t>
+            </a:r>
+          </a:p>
+        </p:txBody>
+      </p:sp>
+      <p:sp>
+        <p:nvSpPr>
+          <p:cNvPr id="8" name="TextBox 7">
+            <a:extLst>
+              <a:ext uri="{FF2B5EF4-FFF2-40B4-BE49-F238E27FC236}">
+                <a16:creationId xmlns:a16="http://schemas.microsoft.com/office/drawing/2014/main" id="{34DFFE93-2DE7-6F86-3062-AA05CD9355DF}"/>
+              </a:ext>
+            </a:extLst>
+          </p:cNvPr>
+          <p:cNvSpPr txBox="1"/>
+          <p:nvPr/>
+        </p:nvSpPr>
+        <p:spPr>
+          <a:xfrm>
+            <a:off x="6248400" y="5867400"/>
+            <a:ext cx="5486400" cy="279400"/>
+          </a:xfrm>
+          <a:prstGeom prst="rect">
+            <a:avLst/>
+          </a:prstGeom>
+          <a:noFill/>
+        </p:spPr>
+        <p:txBody>
+          <a:bodyPr vert="horz" wrap="square" lIns="0" tIns="0" rIns="0" bIns="0" rtlCol="0">
+            <a:noAutofit/>
+          </a:bodyPr>
+          <a:lstStyle/>
+          <a:p>
+            <a:pPr algn="ctr"/>
+            <a:r>
+              <a:rPr lang="en-US" sz="1400" b="1">
+                <a:solidFill>
+                  <a:srgbClr val="5D6D7E"/>
+                </a:solidFill>
+                <a:latin typeface="Calibri" panose="020F0502020204030204" pitchFamily="34" charset="0"/>
+              </a:rPr>
+              <a:t>#all-ai-assisted-yu, Oct 15 opened in the dashboard</a:t>
+            </a:r>
+          </a:p>
+        </p:txBody>
+      </p:sp>
+      <p:sp>
+        <p:nvSpPr>
+          <p:cNvPr id="9" name="Oval 8">
+            <a:extLst>
+              <a:ext uri="{FF2B5EF4-FFF2-40B4-BE49-F238E27FC236}">
+                <a16:creationId xmlns:a16="http://schemas.microsoft.com/office/drawing/2014/main" id="{D2C93273-C0DB-416B-0A2F-F4145DE8E85A}"/>
               </a:ext>
             </a:extLst>
           </p:cNvPr>
@@ -8473,16 +9066,14 @@
         </p:nvSpPr>
         <p:spPr>
           <a:xfrm>
-            <a:off x="609600" y="1270000"/>
-            <a:ext cx="5334000" cy="2413000"/>
-          </a:xfrm>
-          <a:prstGeom prst="roundRect">
-            <a:avLst>
-              <a:gd name="adj" fmla="val 8000"/>
-            </a:avLst>
+            <a:off x="5867400" y="3200400"/>
+            <a:ext cx="457200" cy="330200"/>
+          </a:xfrm>
+          <a:prstGeom prst="ellipse">
+            <a:avLst/>
           </a:prstGeom>
           <a:solidFill>
-            <a:srgbClr val="ECF2F5"/>
+            <a:srgbClr val="F2A541"/>
           </a:solidFill>
           <a:ln w="19050" cap="flat" cmpd="sng" algn="ctr">
             <a:noFill/>
@@ -8525,554 +9116,104 @@
           <a:lstStyle/>
           <a:p>
             <a:pPr algn="ctr"/>
-            <a:endParaRPr lang="en-US"/>
-          </a:p>
-        </p:txBody>
-      </p:sp>
-      <p:sp>
-        <p:nvSpPr>
-          <p:cNvPr id="4" name="TextBox 3">
-            <a:extLst>
-              <a:ext uri="{FF2B5EF4-FFF2-40B4-BE49-F238E27FC236}">
-                <a16:creationId xmlns:a16="http://schemas.microsoft.com/office/drawing/2014/main" id="{D43D956B-39F1-FCB0-9A39-29E9D393E65B}"/>
-              </a:ext>
-            </a:extLst>
-          </p:cNvPr>
-          <p:cNvSpPr txBox="1"/>
-          <p:nvPr/>
-        </p:nvSpPr>
-        <p:spPr>
-          <a:xfrm>
-            <a:off x="863600" y="1524000"/>
-            <a:ext cx="4826000" cy="431800"/>
+            <a:r>
+              <a:rPr lang="en-US" sz="1600" b="1">
+                <a:solidFill>
+                  <a:srgbClr val="FFFFFF"/>
+                </a:solidFill>
+                <a:latin typeface="Calibri" panose="020F0502020204030204" pitchFamily="34" charset="0"/>
+              </a:rPr>
+              <a:t>→</a:t>
+            </a:r>
+          </a:p>
+        </p:txBody>
+      </p:sp>
+      <p:pic>
+        <p:nvPicPr>
+          <p:cNvPr id="5" name="Picture 3">
+            <a:extLst>
+              <a:ext uri="{FF2B5EF4-FFF2-40B4-BE49-F238E27FC236}">
+                <a16:creationId xmlns:a16="http://schemas.microsoft.com/office/drawing/2014/main" id="{32A1295F-0022-DBFE-CDDD-88781A9CB11A}"/>
+              </a:ext>
+            </a:extLst>
+          </p:cNvPr>
+          <p:cNvPicPr>
+            <a:picLocks/>
+          </p:cNvPicPr>
+          <p:nvPr/>
+        </p:nvPicPr>
+        <p:blipFill>
+          <a:blip r:embed="rId2">
+            <a:extLst>
+              <a:ext uri="{28A0092B-C50C-407E-A947-70E740481C1C}">
+                <a14:useLocalDpi xmlns:a14="http://schemas.microsoft.com/office/drawing/2010/main" val="0"/>
+              </a:ext>
+            </a:extLst>
+          </a:blip>
+          <a:stretch>
+            <a:fillRect/>
+          </a:stretch>
+        </p:blipFill>
+        <p:spPr>
+          <a:xfrm>
+            <a:off x="457200" y="2187580"/>
+            <a:ext cx="5486400" cy="2355840"/>
           </a:xfrm>
           <a:prstGeom prst="rect">
             <a:avLst/>
           </a:prstGeom>
-          <a:noFill/>
-        </p:spPr>
-        <p:txBody>
-          <a:bodyPr vert="horz" wrap="square" lIns="0" tIns="0" rIns="0" bIns="0" rtlCol="0">
-            <a:noAutofit/>
-          </a:bodyPr>
-          <a:lstStyle/>
-          <a:p>
-            <a:r>
-              <a:rPr lang="en-US" sz="2400" b="1">
-                <a:solidFill>
-                  <a:srgbClr val="1F7A8C"/>
-                </a:solidFill>
-                <a:latin typeface="Courier New" panose="02070309020205020404" pitchFamily="49" charset="0"/>
-              </a:rPr>
-              <a:t>download-notion</a:t>
-            </a:r>
-          </a:p>
-        </p:txBody>
-      </p:sp>
-      <p:sp>
-        <p:nvSpPr>
-          <p:cNvPr id="5" name="TextBox 4">
-            <a:extLst>
-              <a:ext uri="{FF2B5EF4-FFF2-40B4-BE49-F238E27FC236}">
-                <a16:creationId xmlns:a16="http://schemas.microsoft.com/office/drawing/2014/main" id="{0423C0F4-C280-CCFC-AE2A-4F390180042E}"/>
-              </a:ext>
-            </a:extLst>
-          </p:cNvPr>
-          <p:cNvSpPr txBox="1"/>
-          <p:nvPr/>
-        </p:nvSpPr>
-        <p:spPr>
-          <a:xfrm>
-            <a:off x="863600" y="2108200"/>
-            <a:ext cx="4826000" cy="330200"/>
+          <a:ln w="12700">
+            <a:solidFill>
+              <a:srgbClr val="C8D0D6"/>
+            </a:solidFill>
+          </a:ln>
+        </p:spPr>
+      </p:pic>
+      <p:pic>
+        <p:nvPicPr>
+          <p:cNvPr id="11" name="Picture 5">
+            <a:extLst>
+              <a:ext uri="{FF2B5EF4-FFF2-40B4-BE49-F238E27FC236}">
+                <a16:creationId xmlns:a16="http://schemas.microsoft.com/office/drawing/2014/main" id="{2958E9A7-3F41-C116-C895-CFE0BBBA00E4}"/>
+              </a:ext>
+            </a:extLst>
+          </p:cNvPr>
+          <p:cNvPicPr>
+            <a:picLocks/>
+          </p:cNvPicPr>
+          <p:nvPr/>
+        </p:nvPicPr>
+        <p:blipFill>
+          <a:blip r:embed="rId3">
+            <a:extLst>
+              <a:ext uri="{28A0092B-C50C-407E-A947-70E740481C1C}">
+                <a14:useLocalDpi xmlns:a14="http://schemas.microsoft.com/office/drawing/2010/main" val="0"/>
+              </a:ext>
+            </a:extLst>
+          </a:blip>
+          <a:stretch>
+            <a:fillRect/>
+          </a:stretch>
+        </p:blipFill>
+        <p:spPr>
+          <a:xfrm>
+            <a:off x="6248400" y="2118591"/>
+            <a:ext cx="5486400" cy="2493818"/>
           </a:xfrm>
           <a:prstGeom prst="rect">
             <a:avLst/>
           </a:prstGeom>
-          <a:noFill/>
-        </p:spPr>
-        <p:txBody>
-          <a:bodyPr vert="horz" wrap="square" lIns="0" tIns="0" rIns="0" bIns="0" rtlCol="0">
-            <a:noAutofit/>
-          </a:bodyPr>
-          <a:lstStyle/>
-          <a:p>
-            <a:r>
-              <a:rPr lang="en-US" sz="1700">
-                <a:solidFill>
-                  <a:srgbClr val="1B2631"/>
-                </a:solidFill>
-                <a:latin typeface="Calibri" panose="020F0502020204030204" pitchFamily="34" charset="0"/>
-              </a:rPr>
-              <a:t>Saves Notion pages to dataExports/notion/</a:t>
-            </a:r>
-          </a:p>
-        </p:txBody>
-      </p:sp>
-      <p:sp>
-        <p:nvSpPr>
-          <p:cNvPr id="6" name="TextBox 5">
-            <a:extLst>
-              <a:ext uri="{FF2B5EF4-FFF2-40B4-BE49-F238E27FC236}">
-                <a16:creationId xmlns:a16="http://schemas.microsoft.com/office/drawing/2014/main" id="{D9C2A5EF-D036-E762-83FA-EC264EAF1BC6}"/>
-              </a:ext>
-            </a:extLst>
-          </p:cNvPr>
-          <p:cNvSpPr txBox="1"/>
-          <p:nvPr/>
-        </p:nvSpPr>
-        <p:spPr>
-          <a:xfrm>
-            <a:off x="863600" y="2667000"/>
-            <a:ext cx="4826000" cy="279400"/>
-          </a:xfrm>
-          <a:prstGeom prst="rect">
-            <a:avLst/>
-          </a:prstGeom>
-          <a:noFill/>
-        </p:spPr>
-        <p:txBody>
-          <a:bodyPr vert="horz" wrap="square" lIns="0" tIns="0" rIns="0" bIns="0" rtlCol="0">
-            <a:noAutofit/>
-          </a:bodyPr>
-          <a:lstStyle/>
-          <a:p>
-            <a:r>
-              <a:rPr lang="en-US" sz="1400">
-                <a:solidFill>
-                  <a:srgbClr val="5D6D7E"/>
-                </a:solidFill>
-                <a:latin typeface="Calibri" panose="020F0502020204030204" pitchFamily="34" charset="0"/>
-              </a:rPr>
-              <a:t>Example request:</a:t>
-            </a:r>
-          </a:p>
-        </p:txBody>
-      </p:sp>
-      <p:sp>
-        <p:nvSpPr>
-          <p:cNvPr id="7" name="TextBox 6">
-            <a:extLst>
-              <a:ext uri="{FF2B5EF4-FFF2-40B4-BE49-F238E27FC236}">
-                <a16:creationId xmlns:a16="http://schemas.microsoft.com/office/drawing/2014/main" id="{1BD78DD0-40A2-5117-8221-E897F1C9AA9B}"/>
-              </a:ext>
-            </a:extLst>
-          </p:cNvPr>
-          <p:cNvSpPr txBox="1"/>
-          <p:nvPr/>
-        </p:nvSpPr>
-        <p:spPr>
-          <a:xfrm>
-            <a:off x="863600" y="2971800"/>
-            <a:ext cx="4826000" cy="330200"/>
-          </a:xfrm>
-          <a:prstGeom prst="rect">
-            <a:avLst/>
-          </a:prstGeom>
-          <a:noFill/>
-        </p:spPr>
-        <p:txBody>
-          <a:bodyPr vert="horz" wrap="square" lIns="0" tIns="0" rIns="0" bIns="0" rtlCol="0">
-            <a:noAutofit/>
-          </a:bodyPr>
-          <a:lstStyle/>
-          <a:p>
-            <a:r>
-              <a:rPr lang="en-US" sz="1700">
-                <a:solidFill>
-                  <a:srgbClr val="1B2631"/>
-                </a:solidFill>
-                <a:latin typeface="Calibri" panose="020F0502020204030204" pitchFamily="34" charset="0"/>
-              </a:rPr>
-              <a:t>“Download the pages under Test Data”</a:t>
-            </a:r>
-          </a:p>
-        </p:txBody>
-      </p:sp>
-      <p:sp>
-        <p:nvSpPr>
-          <p:cNvPr id="8" name="Rectangle: Rounded Corners 7">
-            <a:extLst>
-              <a:ext uri="{FF2B5EF4-FFF2-40B4-BE49-F238E27FC236}">
-                <a16:creationId xmlns:a16="http://schemas.microsoft.com/office/drawing/2014/main" id="{3C300C7B-39B4-C103-F9A6-3101869C31FB}"/>
-              </a:ext>
-            </a:extLst>
-          </p:cNvPr>
-          <p:cNvSpPr/>
-          <p:nvPr/>
-        </p:nvSpPr>
-        <p:spPr>
-          <a:xfrm>
-            <a:off x="6248400" y="1270000"/>
-            <a:ext cx="5334000" cy="2413000"/>
-          </a:xfrm>
-          <a:prstGeom prst="roundRect">
-            <a:avLst>
-              <a:gd name="adj" fmla="val 8000"/>
-            </a:avLst>
-          </a:prstGeom>
-          <a:solidFill>
-            <a:srgbClr val="ECF2F5"/>
-          </a:solidFill>
-          <a:ln w="19050" cap="flat" cmpd="sng" algn="ctr">
-            <a:noFill/>
-            <a:prstDash val="solid"/>
-            <a:miter lim="800000"/>
+          <a:ln w="12700">
+            <a:solidFill>
+              <a:srgbClr val="C8D0D6"/>
+            </a:solidFill>
           </a:ln>
-          <a:effectLst/>
-          <a:extLst>
-            <a:ext uri="{91240B29-F687-4F45-9708-019B960494DF}">
-              <a14:hiddenLine xmlns:a14="http://schemas.microsoft.com/office/drawing/2010/main" w="19050" cap="flat" cmpd="sng" algn="ctr">
-                <a:solidFill>
-                  <a:schemeClr val="accent1">
-                    <a:shade val="15000"/>
-                  </a:schemeClr>
-                </a:solidFill>
-                <a:prstDash val="solid"/>
-                <a:miter lim="800000"/>
-              </a14:hiddenLine>
-            </a:ext>
-          </a:extLst>
-        </p:spPr>
-        <p:style>
-          <a:lnRef idx="2">
-            <a:schemeClr val="accent1">
-              <a:shade val="15000"/>
-            </a:schemeClr>
-          </a:lnRef>
-          <a:fillRef idx="1">
-            <a:schemeClr val="accent1"/>
-          </a:fillRef>
-          <a:effectRef idx="0">
-            <a:schemeClr val="accent1"/>
-          </a:effectRef>
-          <a:fontRef idx="minor">
-            <a:schemeClr val="lt1"/>
-          </a:fontRef>
-        </p:style>
-        <p:txBody>
-          <a:bodyPr rtlCol="0" anchor="ctr"/>
-          <a:lstStyle/>
-          <a:p>
-            <a:pPr algn="ctr"/>
-            <a:endParaRPr lang="en-US"/>
-          </a:p>
-        </p:txBody>
-      </p:sp>
-      <p:sp>
-        <p:nvSpPr>
-          <p:cNvPr id="9" name="TextBox 8">
-            <a:extLst>
-              <a:ext uri="{FF2B5EF4-FFF2-40B4-BE49-F238E27FC236}">
-                <a16:creationId xmlns:a16="http://schemas.microsoft.com/office/drawing/2014/main" id="{91AC5FEA-4142-92E7-B984-7E275770E81C}"/>
-              </a:ext>
-            </a:extLst>
-          </p:cNvPr>
-          <p:cNvSpPr txBox="1"/>
-          <p:nvPr/>
-        </p:nvSpPr>
-        <p:spPr>
-          <a:xfrm>
-            <a:off x="6502400" y="1524000"/>
-            <a:ext cx="4826000" cy="431800"/>
-          </a:xfrm>
-          <a:prstGeom prst="rect">
-            <a:avLst/>
-          </a:prstGeom>
-          <a:noFill/>
-        </p:spPr>
-        <p:txBody>
-          <a:bodyPr vert="horz" wrap="square" lIns="0" tIns="0" rIns="0" bIns="0" rtlCol="0">
-            <a:noAutofit/>
-          </a:bodyPr>
-          <a:lstStyle/>
-          <a:p>
-            <a:r>
-              <a:rPr lang="en-US" sz="2400" b="1">
-                <a:solidFill>
-                  <a:srgbClr val="1F7A8C"/>
-                </a:solidFill>
-                <a:latin typeface="Courier New" panose="02070309020205020404" pitchFamily="49" charset="0"/>
-              </a:rPr>
-              <a:t>download-jira</a:t>
-            </a:r>
-          </a:p>
-        </p:txBody>
-      </p:sp>
-      <p:sp>
-        <p:nvSpPr>
-          <p:cNvPr id="10" name="TextBox 9">
-            <a:extLst>
-              <a:ext uri="{FF2B5EF4-FFF2-40B4-BE49-F238E27FC236}">
-                <a16:creationId xmlns:a16="http://schemas.microsoft.com/office/drawing/2014/main" id="{5EEDB97F-42F9-BE18-0EDA-B67E8DB64904}"/>
-              </a:ext>
-            </a:extLst>
-          </p:cNvPr>
-          <p:cNvSpPr txBox="1"/>
-          <p:nvPr/>
-        </p:nvSpPr>
-        <p:spPr>
-          <a:xfrm>
-            <a:off x="6502400" y="2108200"/>
-            <a:ext cx="4826000" cy="330200"/>
-          </a:xfrm>
-          <a:prstGeom prst="rect">
-            <a:avLst/>
-          </a:prstGeom>
-          <a:noFill/>
-        </p:spPr>
-        <p:txBody>
-          <a:bodyPr vert="horz" wrap="square" lIns="0" tIns="0" rIns="0" bIns="0" rtlCol="0">
-            <a:noAutofit/>
-          </a:bodyPr>
-          <a:lstStyle/>
-          <a:p>
-            <a:r>
-              <a:rPr lang="en-US" sz="1700">
-                <a:solidFill>
-                  <a:srgbClr val="1B2631"/>
-                </a:solidFill>
-                <a:latin typeface="Calibri" panose="020F0502020204030204" pitchFamily="34" charset="0"/>
-              </a:rPr>
-              <a:t>Saves Jira issues to dataExports/jira/</a:t>
-            </a:r>
-          </a:p>
-        </p:txBody>
-      </p:sp>
-      <p:sp>
-        <p:nvSpPr>
-          <p:cNvPr id="11" name="TextBox 10">
-            <a:extLst>
-              <a:ext uri="{FF2B5EF4-FFF2-40B4-BE49-F238E27FC236}">
-                <a16:creationId xmlns:a16="http://schemas.microsoft.com/office/drawing/2014/main" id="{71630340-9EA2-5518-8B20-B630BA49DA29}"/>
-              </a:ext>
-            </a:extLst>
-          </p:cNvPr>
-          <p:cNvSpPr txBox="1"/>
-          <p:nvPr/>
-        </p:nvSpPr>
-        <p:spPr>
-          <a:xfrm>
-            <a:off x="6502400" y="2667000"/>
-            <a:ext cx="4826000" cy="279400"/>
-          </a:xfrm>
-          <a:prstGeom prst="rect">
-            <a:avLst/>
-          </a:prstGeom>
-          <a:noFill/>
-        </p:spPr>
-        <p:txBody>
-          <a:bodyPr vert="horz" wrap="square" lIns="0" tIns="0" rIns="0" bIns="0" rtlCol="0">
-            <a:noAutofit/>
-          </a:bodyPr>
-          <a:lstStyle/>
-          <a:p>
-            <a:r>
-              <a:rPr lang="en-US" sz="1400">
-                <a:solidFill>
-                  <a:srgbClr val="5D6D7E"/>
-                </a:solidFill>
-                <a:latin typeface="Calibri" panose="020F0502020204030204" pitchFamily="34" charset="0"/>
-              </a:rPr>
-              <a:t>Example request:</a:t>
-            </a:r>
-          </a:p>
-        </p:txBody>
-      </p:sp>
-      <p:sp>
-        <p:nvSpPr>
-          <p:cNvPr id="12" name="TextBox 11">
-            <a:extLst>
-              <a:ext uri="{FF2B5EF4-FFF2-40B4-BE49-F238E27FC236}">
-                <a16:creationId xmlns:a16="http://schemas.microsoft.com/office/drawing/2014/main" id="{4FD7EDC7-A855-9599-D6AB-A710E45F58AD}"/>
-              </a:ext>
-            </a:extLst>
-          </p:cNvPr>
-          <p:cNvSpPr txBox="1"/>
-          <p:nvPr/>
-        </p:nvSpPr>
-        <p:spPr>
-          <a:xfrm>
-            <a:off x="6502400" y="2971800"/>
-            <a:ext cx="4826000" cy="330200"/>
-          </a:xfrm>
-          <a:prstGeom prst="rect">
-            <a:avLst/>
-          </a:prstGeom>
-          <a:noFill/>
-        </p:spPr>
-        <p:txBody>
-          <a:bodyPr vert="horz" wrap="square" lIns="0" tIns="0" rIns="0" bIns="0" rtlCol="0">
-            <a:noAutofit/>
-          </a:bodyPr>
-          <a:lstStyle/>
-          <a:p>
-            <a:r>
-              <a:rPr lang="en-US" sz="1700">
-                <a:solidFill>
-                  <a:srgbClr val="1B2631"/>
-                </a:solidFill>
-                <a:latin typeface="Calibri" panose="020F0502020204030204" pitchFamily="34" charset="0"/>
-              </a:rPr>
-              <a:t>“Download all FALCON issues”</a:t>
-            </a:r>
-          </a:p>
-        </p:txBody>
-      </p:sp>
-      <p:sp>
-        <p:nvSpPr>
-          <p:cNvPr id="13" name="Rectangle: Rounded Corners 12">
-            <a:extLst>
-              <a:ext uri="{FF2B5EF4-FFF2-40B4-BE49-F238E27FC236}">
-                <a16:creationId xmlns:a16="http://schemas.microsoft.com/office/drawing/2014/main" id="{6A215696-3684-E65E-D749-A78C498B3383}"/>
-              </a:ext>
-            </a:extLst>
-          </p:cNvPr>
-          <p:cNvSpPr/>
-          <p:nvPr/>
-        </p:nvSpPr>
-        <p:spPr>
-          <a:xfrm>
-            <a:off x="609600" y="4013200"/>
-            <a:ext cx="10972800" cy="1397000"/>
-          </a:xfrm>
-          <a:prstGeom prst="roundRect">
-            <a:avLst>
-              <a:gd name="adj" fmla="val 8000"/>
-            </a:avLst>
-          </a:prstGeom>
-          <a:solidFill>
-            <a:srgbClr val="0F2A3A"/>
-          </a:solidFill>
-          <a:ln w="19050" cap="flat" cmpd="sng" algn="ctr">
-            <a:noFill/>
-            <a:prstDash val="solid"/>
-            <a:miter lim="800000"/>
-          </a:ln>
-          <a:effectLst/>
-          <a:extLst>
-            <a:ext uri="{91240B29-F687-4F45-9708-019B960494DF}">
-              <a14:hiddenLine xmlns:a14="http://schemas.microsoft.com/office/drawing/2010/main" w="19050" cap="flat" cmpd="sng" algn="ctr">
-                <a:solidFill>
-                  <a:schemeClr val="accent1">
-                    <a:shade val="15000"/>
-                  </a:schemeClr>
-                </a:solidFill>
-                <a:prstDash val="solid"/>
-                <a:miter lim="800000"/>
-              </a14:hiddenLine>
-            </a:ext>
-          </a:extLst>
-        </p:spPr>
-        <p:style>
-          <a:lnRef idx="2">
-            <a:schemeClr val="accent1">
-              <a:shade val="15000"/>
-            </a:schemeClr>
-          </a:lnRef>
-          <a:fillRef idx="1">
-            <a:schemeClr val="accent1"/>
-          </a:fillRef>
-          <a:effectRef idx="0">
-            <a:schemeClr val="accent1"/>
-          </a:effectRef>
-          <a:fontRef idx="minor">
-            <a:schemeClr val="lt1"/>
-          </a:fontRef>
-        </p:style>
-        <p:txBody>
-          <a:bodyPr rtlCol="0" anchor="ctr"/>
-          <a:lstStyle/>
-          <a:p>
-            <a:pPr algn="ctr"/>
-            <a:endParaRPr lang="en-US"/>
-          </a:p>
-        </p:txBody>
-      </p:sp>
-      <p:sp>
-        <p:nvSpPr>
-          <p:cNvPr id="14" name="TextBox 13">
-            <a:extLst>
-              <a:ext uri="{FF2B5EF4-FFF2-40B4-BE49-F238E27FC236}">
-                <a16:creationId xmlns:a16="http://schemas.microsoft.com/office/drawing/2014/main" id="{0C07E787-EA8C-886D-3C8C-46118E7ADC03}"/>
-              </a:ext>
-            </a:extLst>
-          </p:cNvPr>
-          <p:cNvSpPr txBox="1"/>
-          <p:nvPr/>
-        </p:nvSpPr>
-        <p:spPr>
-          <a:xfrm>
-            <a:off x="914400" y="4241800"/>
-            <a:ext cx="10414000" cy="381000"/>
-          </a:xfrm>
-          <a:prstGeom prst="rect">
-            <a:avLst/>
-          </a:prstGeom>
-          <a:noFill/>
-        </p:spPr>
-        <p:txBody>
-          <a:bodyPr vert="horz" wrap="square" lIns="0" tIns="0" rIns="0" bIns="0" rtlCol="0">
-            <a:noAutofit/>
-          </a:bodyPr>
-          <a:lstStyle/>
-          <a:p>
-            <a:r>
-              <a:rPr lang="en-US" sz="2200" b="1">
-                <a:solidFill>
-                  <a:srgbClr val="F2A541"/>
-                </a:solidFill>
-                <a:latin typeface="Cambria" panose="02040503050406030204" pitchFamily="18" charset="0"/>
-              </a:rPr>
-              <a:t>Tested in a fresh conversation</a:t>
-            </a:r>
-          </a:p>
-        </p:txBody>
-      </p:sp>
-      <p:sp>
-        <p:nvSpPr>
-          <p:cNvPr id="15" name="TextBox 14">
-            <a:extLst>
-              <a:ext uri="{FF2B5EF4-FFF2-40B4-BE49-F238E27FC236}">
-                <a16:creationId xmlns:a16="http://schemas.microsoft.com/office/drawing/2014/main" id="{027C7CB3-5ACD-BB9C-4AF0-AB2226132AAD}"/>
-              </a:ext>
-            </a:extLst>
-          </p:cNvPr>
-          <p:cNvSpPr txBox="1"/>
-          <p:nvPr/>
-        </p:nvSpPr>
-        <p:spPr>
-          <a:xfrm>
-            <a:off x="914400" y="4724400"/>
-            <a:ext cx="10414000" cy="558800"/>
-          </a:xfrm>
-          <a:prstGeom prst="rect">
-            <a:avLst/>
-          </a:prstGeom>
-          <a:noFill/>
-        </p:spPr>
-        <p:txBody>
-          <a:bodyPr vert="horz" wrap="square" lIns="0" tIns="0" rIns="0" bIns="0" rtlCol="0">
-            <a:noAutofit/>
-          </a:bodyPr>
-          <a:lstStyle/>
-          <a:p>
-            <a:r>
-              <a:rPr lang="en-US" sz="1700">
-                <a:solidFill>
-                  <a:srgbClr val="FFFFFF"/>
-                </a:solidFill>
-                <a:latin typeface="Calibri" panose="020F0502020204030204" pitchFamily="34" charset="0"/>
-              </a:rPr>
-              <a:t>With no earlier context, each skill downloaded 3 new items in the right format and rebuilt index.json.</a:t>
-            </a:r>
-          </a:p>
-        </p:txBody>
-      </p:sp>
+        </p:spPr>
+      </p:pic>
     </p:spTree>
     <p:extLst>
       <p:ext uri="{BB962C8B-B14F-4D97-AF65-F5344CB8AC3E}">
-        <p14:creationId xmlns:p14="http://schemas.microsoft.com/office/powerpoint/2010/main" val="3455007977"/>
+        <p14:creationId xmlns:p14="http://schemas.microsoft.com/office/powerpoint/2010/main" val="2240579239"/>
       </p:ext>
     </p:extLst>
   </p:cSld>
@@ -9112,7 +9253,7 @@
           <p:cNvPr id="2" name="TextBox 1">
             <a:extLst>
               <a:ext uri="{FF2B5EF4-FFF2-40B4-BE49-F238E27FC236}">
-                <a16:creationId xmlns:a16="http://schemas.microsoft.com/office/drawing/2014/main" id="{666A9E3C-F6FD-BD6F-1E19-356FA0A42824}"/>
+                <a16:creationId xmlns:a16="http://schemas.microsoft.com/office/drawing/2014/main" id="{3551A8B1-E95A-4E3C-71AA-31A527E0D49C}"/>
               </a:ext>
             </a:extLst>
           </p:cNvPr>
@@ -9142,58 +9283,307 @@
                 </a:solidFill>
                 <a:latin typeface="Cambria" panose="02040503050406030204" pitchFamily="18" charset="0"/>
               </a:rPr>
-              <a:t>Dashboard: one search across all services</a:t>
-            </a:r>
-          </a:p>
-        </p:txBody>
-      </p:sp>
-      <p:pic>
-        <p:nvPicPr>
-          <p:cNvPr id="4" name="Picture 3">
-            <a:extLst>
-              <a:ext uri="{FF2B5EF4-FFF2-40B4-BE49-F238E27FC236}">
-                <a16:creationId xmlns:a16="http://schemas.microsoft.com/office/drawing/2014/main" id="{CFE1EB2D-B6B9-9E89-14B3-5D32D0B25D34}"/>
-              </a:ext>
-            </a:extLst>
-          </p:cNvPr>
-          <p:cNvPicPr>
-            <a:picLocks noChangeAspect="1"/>
-          </p:cNvPicPr>
-          <p:nvPr/>
-        </p:nvPicPr>
-        <p:blipFill>
-          <a:blip r:embed="rId2">
-            <a:extLst>
-              <a:ext uri="{28A0092B-C50C-407E-A947-70E740481C1C}">
-                <a14:useLocalDpi xmlns:a14="http://schemas.microsoft.com/office/drawing/2010/main" val="0"/>
-              </a:ext>
-            </a:extLst>
-          </a:blip>
-          <a:stretch>
-            <a:fillRect/>
-          </a:stretch>
-        </p:blipFill>
-        <p:spPr>
-          <a:xfrm>
-            <a:off x="609600" y="1362075"/>
-            <a:ext cx="6858000" cy="4286250"/>
+              <a:t>One storage format for every service</a:t>
+            </a:r>
+          </a:p>
+        </p:txBody>
+      </p:sp>
+      <p:sp>
+        <p:nvSpPr>
+          <p:cNvPr id="3" name="Rectangle: Rounded Corners 2">
+            <a:extLst>
+              <a:ext uri="{FF2B5EF4-FFF2-40B4-BE49-F238E27FC236}">
+                <a16:creationId xmlns:a16="http://schemas.microsoft.com/office/drawing/2014/main" id="{521CE9F6-CF2E-0AE9-402B-4BB420593063}"/>
+              </a:ext>
+            </a:extLst>
+          </p:cNvPr>
+          <p:cNvSpPr/>
+          <p:nvPr/>
+        </p:nvSpPr>
+        <p:spPr>
+          <a:xfrm>
+            <a:off x="609600" y="1270000"/>
+            <a:ext cx="5207000" cy="4064000"/>
+          </a:xfrm>
+          <a:prstGeom prst="roundRect">
+            <a:avLst>
+              <a:gd name="adj" fmla="val 8000"/>
+            </a:avLst>
+          </a:prstGeom>
+          <a:solidFill>
+            <a:srgbClr val="0F2A3A"/>
+          </a:solidFill>
+          <a:ln w="19050" cap="flat" cmpd="sng" algn="ctr">
+            <a:noFill/>
+            <a:prstDash val="solid"/>
+            <a:miter lim="800000"/>
+          </a:ln>
+          <a:effectLst/>
+          <a:extLst>
+            <a:ext uri="{91240B29-F687-4F45-9708-019B960494DF}">
+              <a14:hiddenLine xmlns:a14="http://schemas.microsoft.com/office/drawing/2010/main" w="19050" cap="flat" cmpd="sng" algn="ctr">
+                <a:solidFill>
+                  <a:schemeClr val="accent1">
+                    <a:shade val="15000"/>
+                  </a:schemeClr>
+                </a:solidFill>
+                <a:prstDash val="solid"/>
+                <a:miter lim="800000"/>
+              </a14:hiddenLine>
+            </a:ext>
+          </a:extLst>
+        </p:spPr>
+        <p:style>
+          <a:lnRef idx="2">
+            <a:schemeClr val="accent1">
+              <a:shade val="15000"/>
+            </a:schemeClr>
+          </a:lnRef>
+          <a:fillRef idx="1">
+            <a:schemeClr val="accent1"/>
+          </a:fillRef>
+          <a:effectRef idx="0">
+            <a:schemeClr val="accent1"/>
+          </a:effectRef>
+          <a:fontRef idx="minor">
+            <a:schemeClr val="lt1"/>
+          </a:fontRef>
+        </p:style>
+        <p:txBody>
+          <a:bodyPr rtlCol="0" anchor="ctr"/>
+          <a:lstStyle/>
+          <a:p>
+            <a:pPr algn="ctr"/>
+            <a:endParaRPr lang="en-US"/>
+          </a:p>
+        </p:txBody>
+      </p:sp>
+      <p:sp>
+        <p:nvSpPr>
+          <p:cNvPr id="4" name="TextBox 3">
+            <a:extLst>
+              <a:ext uri="{FF2B5EF4-FFF2-40B4-BE49-F238E27FC236}">
+                <a16:creationId xmlns:a16="http://schemas.microsoft.com/office/drawing/2014/main" id="{E875462C-477F-E473-7635-171DB7863206}"/>
+              </a:ext>
+            </a:extLst>
+          </p:cNvPr>
+          <p:cNvSpPr txBox="1"/>
+          <p:nvPr/>
+        </p:nvSpPr>
+        <p:spPr>
+          <a:xfrm>
+            <a:off x="838200" y="1498600"/>
+            <a:ext cx="4826000" cy="3810000"/>
           </a:xfrm>
           <a:prstGeom prst="rect">
             <a:avLst/>
           </a:prstGeom>
-          <a:ln w="12700">
-            <a:solidFill>
-              <a:srgbClr val="C8D0D6"/>
-            </a:solidFill>
+          <a:noFill/>
+        </p:spPr>
+        <p:txBody>
+          <a:bodyPr vert="horz" wrap="square" lIns="0" tIns="0" rIns="0" bIns="0" rtlCol="0">
+            <a:noAutofit/>
+          </a:bodyPr>
+          <a:lstStyle/>
+          <a:p>
+            <a:r>
+              <a:rPr lang="en-US" sz="1300">
+                <a:solidFill>
+                  <a:srgbClr val="FFFFFF"/>
+                </a:solidFill>
+                <a:latin typeface="Courier New" panose="02070309020205020404" pitchFamily="49" charset="0"/>
+              </a:rPr>
+              <a:t>dataExports/</a:t>
+            </a:r>
+          </a:p>
+          <a:p>
+            <a:r>
+              <a:rPr lang="en-US" sz="1300">
+                <a:solidFill>
+                  <a:srgbClr val="FFFFFF"/>
+                </a:solidFill>
+                <a:latin typeface="Courier New" panose="02070309020205020404" pitchFamily="49" charset="0"/>
+              </a:rPr>
+              <a:t>  notion/</a:t>
+            </a:r>
+          </a:p>
+          <a:p>
+            <a:r>
+              <a:rPr lang="en-US" sz="1300">
+                <a:solidFill>
+                  <a:srgbClr val="FFFFFF"/>
+                </a:solidFill>
+                <a:latin typeface="Courier New" panose="02070309020205020404" pitchFamily="49" charset="0"/>
+              </a:rPr>
+              <a:t>    index.json</a:t>
+            </a:r>
+          </a:p>
+          <a:p>
+            <a:r>
+              <a:rPr lang="en-US" sz="1300">
+                <a:solidFill>
+                  <a:srgbClr val="FFFFFF"/>
+                </a:solidFill>
+                <a:latin typeface="Courier New" panose="02070309020205020404" pitchFamily="49" charset="0"/>
+              </a:rPr>
+              <a:t>    2026-10-13_project-falcon-…_88f5398c/</a:t>
+            </a:r>
+          </a:p>
+          <a:p>
+            <a:r>
+              <a:rPr lang="en-US" sz="1300">
+                <a:solidFill>
+                  <a:srgbClr val="FFFFFF"/>
+                </a:solidFill>
+                <a:latin typeface="Courier New" panose="02070309020205020404" pitchFamily="49" charset="0"/>
+              </a:rPr>
+              <a:t>      content.md</a:t>
+            </a:r>
+          </a:p>
+          <a:p>
+            <a:r>
+              <a:rPr lang="en-US" sz="1300">
+                <a:solidFill>
+                  <a:srgbClr val="FFFFFF"/>
+                </a:solidFill>
+                <a:latin typeface="Courier New" panose="02070309020205020404" pitchFamily="49" charset="0"/>
+              </a:rPr>
+              <a:t>      metadata.json</a:t>
+            </a:r>
+          </a:p>
+          <a:p>
+            <a:r>
+              <a:rPr lang="en-US" sz="1300">
+                <a:solidFill>
+                  <a:srgbClr val="FFFFFF"/>
+                </a:solidFill>
+                <a:latin typeface="Courier New" panose="02070309020205020404" pitchFamily="49" charset="0"/>
+              </a:rPr>
+              <a:t>  jira/</a:t>
+            </a:r>
+          </a:p>
+          <a:p>
+            <a:r>
+              <a:rPr lang="en-US" sz="1300">
+                <a:solidFill>
+                  <a:srgbClr val="FFFFFF"/>
+                </a:solidFill>
+                <a:latin typeface="Courier New" panose="02070309020205020404" pitchFamily="49" charset="0"/>
+              </a:rPr>
+              <a:t>    index.json</a:t>
+            </a:r>
+          </a:p>
+          <a:p>
+            <a:r>
+              <a:rPr lang="en-US" sz="1300">
+                <a:solidFill>
+                  <a:srgbClr val="FFFFFF"/>
+                </a:solidFill>
+                <a:latin typeface="Courier New" panose="02070309020205020404" pitchFamily="49" charset="0"/>
+              </a:rPr>
+              <a:t>    2026-10-14_falcon-12_write-readme-…_10031/</a:t>
+            </a:r>
+          </a:p>
+          <a:p>
+            <a:r>
+              <a:rPr lang="en-US" sz="1300">
+                <a:solidFill>
+                  <a:srgbClr val="FFFFFF"/>
+                </a:solidFill>
+                <a:latin typeface="Courier New" panose="02070309020205020404" pitchFamily="49" charset="0"/>
+              </a:rPr>
+              <a:t>      content.md</a:t>
+            </a:r>
+          </a:p>
+          <a:p>
+            <a:r>
+              <a:rPr lang="en-US" sz="1300">
+                <a:solidFill>
+                  <a:srgbClr val="FFFFFF"/>
+                </a:solidFill>
+                <a:latin typeface="Courier New" panose="02070309020205020404" pitchFamily="49" charset="0"/>
+              </a:rPr>
+              <a:t>      metadata.json</a:t>
+            </a:r>
+          </a:p>
+        </p:txBody>
+      </p:sp>
+      <p:sp>
+        <p:nvSpPr>
+          <p:cNvPr id="5" name="Rectangle: Rounded Corners 4">
+            <a:extLst>
+              <a:ext uri="{FF2B5EF4-FFF2-40B4-BE49-F238E27FC236}">
+                <a16:creationId xmlns:a16="http://schemas.microsoft.com/office/drawing/2014/main" id="{5CD2382F-184F-96EC-DDD4-8579CD62EF57}"/>
+              </a:ext>
+            </a:extLst>
+          </p:cNvPr>
+          <p:cNvSpPr/>
+          <p:nvPr/>
+        </p:nvSpPr>
+        <p:spPr>
+          <a:xfrm>
+            <a:off x="6121400" y="1270000"/>
+            <a:ext cx="5461000" cy="2540000"/>
+          </a:xfrm>
+          <a:prstGeom prst="roundRect">
+            <a:avLst>
+              <a:gd name="adj" fmla="val 8000"/>
+            </a:avLst>
+          </a:prstGeom>
+          <a:solidFill>
+            <a:srgbClr val="ECF2F5"/>
+          </a:solidFill>
+          <a:ln w="19050" cap="flat" cmpd="sng" algn="ctr">
+            <a:noFill/>
+            <a:prstDash val="solid"/>
+            <a:miter lim="800000"/>
           </a:ln>
-        </p:spPr>
-      </p:pic>
-      <p:sp>
-        <p:nvSpPr>
-          <p:cNvPr id="5" name="TextBox 4">
-            <a:extLst>
-              <a:ext uri="{FF2B5EF4-FFF2-40B4-BE49-F238E27FC236}">
-                <a16:creationId xmlns:a16="http://schemas.microsoft.com/office/drawing/2014/main" id="{5530984F-97C0-7A47-D876-7E901D833E83}"/>
+          <a:effectLst/>
+          <a:extLst>
+            <a:ext uri="{91240B29-F687-4F45-9708-019B960494DF}">
+              <a14:hiddenLine xmlns:a14="http://schemas.microsoft.com/office/drawing/2010/main" w="19050" cap="flat" cmpd="sng" algn="ctr">
+                <a:solidFill>
+                  <a:schemeClr val="accent1">
+                    <a:shade val="15000"/>
+                  </a:schemeClr>
+                </a:solidFill>
+                <a:prstDash val="solid"/>
+                <a:miter lim="800000"/>
+              </a14:hiddenLine>
+            </a:ext>
+          </a:extLst>
+        </p:spPr>
+        <p:style>
+          <a:lnRef idx="2">
+            <a:schemeClr val="accent1">
+              <a:shade val="15000"/>
+            </a:schemeClr>
+          </a:lnRef>
+          <a:fillRef idx="1">
+            <a:schemeClr val="accent1"/>
+          </a:fillRef>
+          <a:effectRef idx="0">
+            <a:schemeClr val="accent1"/>
+          </a:effectRef>
+          <a:fontRef idx="minor">
+            <a:schemeClr val="lt1"/>
+          </a:fontRef>
+        </p:style>
+        <p:txBody>
+          <a:bodyPr rtlCol="0" anchor="ctr"/>
+          <a:lstStyle/>
+          <a:p>
+            <a:pPr algn="ctr"/>
+            <a:endParaRPr lang="en-US"/>
+          </a:p>
+        </p:txBody>
+      </p:sp>
+      <p:sp>
+        <p:nvSpPr>
+          <p:cNvPr id="6" name="TextBox 5">
+            <a:extLst>
+              <a:ext uri="{FF2B5EF4-FFF2-40B4-BE49-F238E27FC236}">
+                <a16:creationId xmlns:a16="http://schemas.microsoft.com/office/drawing/2014/main" id="{05BBDAAD-6F58-A42A-5264-F0EC6493B90A}"/>
               </a:ext>
             </a:extLst>
           </p:cNvPr>
@@ -9202,8 +9592,136 @@
         </p:nvSpPr>
         <p:spPr>
           <a:xfrm>
-            <a:off x="7823200" y="1397000"/>
-            <a:ext cx="3759200" cy="4191000"/>
+            <a:off x="6350000" y="1473200"/>
+            <a:ext cx="5080000" cy="2540000"/>
+          </a:xfrm>
+          <a:prstGeom prst="rect">
+            <a:avLst/>
+          </a:prstGeom>
+          <a:noFill/>
+        </p:spPr>
+        <p:txBody>
+          <a:bodyPr vert="horz" wrap="square" lIns="0" tIns="0" rIns="0" bIns="0" rtlCol="0">
+            <a:noAutofit/>
+          </a:bodyPr>
+          <a:lstStyle/>
+          <a:p>
+            <a:r>
+              <a:rPr lang="en-US" sz="1300">
+                <a:solidFill>
+                  <a:srgbClr val="1B2631"/>
+                </a:solidFill>
+                <a:latin typeface="Courier New" panose="02070309020205020404" pitchFamily="49" charset="0"/>
+              </a:rPr>
+              <a:t>{</a:t>
+            </a:r>
+          </a:p>
+          <a:p>
+            <a:r>
+              <a:rPr lang="en-US" sz="1300">
+                <a:solidFill>
+                  <a:srgbClr val="1B2631"/>
+                </a:solidFill>
+                <a:latin typeface="Courier New" panose="02070309020205020404" pitchFamily="49" charset="0"/>
+              </a:rPr>
+              <a:t>  "service": "jira",</a:t>
+            </a:r>
+          </a:p>
+          <a:p>
+            <a:r>
+              <a:rPr lang="en-US" sz="1300">
+                <a:solidFill>
+                  <a:srgbClr val="1B2631"/>
+                </a:solidFill>
+                <a:latin typeface="Courier New" panose="02070309020205020404" pitchFamily="49" charset="0"/>
+              </a:rPr>
+              <a:t>  "id": "10031",</a:t>
+            </a:r>
+          </a:p>
+          <a:p>
+            <a:r>
+              <a:rPr lang="en-US" sz="1300">
+                <a:solidFill>
+                  <a:srgbClr val="1B2631"/>
+                </a:solidFill>
+                <a:latin typeface="Courier New" panose="02070309020205020404" pitchFamily="49" charset="0"/>
+              </a:rPr>
+              <a:t>  "key": "FALCON-12",</a:t>
+            </a:r>
+          </a:p>
+          <a:p>
+            <a:r>
+              <a:rPr lang="en-US" sz="1300">
+                <a:solidFill>
+                  <a:srgbClr val="1B2631"/>
+                </a:solidFill>
+                <a:latin typeface="Courier New" panose="02070309020205020404" pitchFamily="49" charset="0"/>
+              </a:rPr>
+              <a:t>  "title": "Write README instructions…",</a:t>
+            </a:r>
+          </a:p>
+          <a:p>
+            <a:r>
+              <a:rPr lang="en-US" sz="1300">
+                <a:solidFill>
+                  <a:srgbClr val="1B2631"/>
+                </a:solidFill>
+                <a:latin typeface="Courier New" panose="02070309020205020404" pitchFamily="49" charset="0"/>
+              </a:rPr>
+              <a:t>  "created_time": "2026-10-14T01:39:18Z",</a:t>
+            </a:r>
+          </a:p>
+          <a:p>
+            <a:r>
+              <a:rPr lang="en-US" sz="1300">
+                <a:solidFill>
+                  <a:srgbClr val="1B2631"/>
+                </a:solidFill>
+                <a:latin typeface="Courier New" panose="02070309020205020404" pitchFamily="49" charset="0"/>
+              </a:rPr>
+              <a:t>  "downloaded_at": "2026-10-14T01:41:47Z",</a:t>
+            </a:r>
+          </a:p>
+          <a:p>
+            <a:r>
+              <a:rPr lang="en-US" sz="1300">
+                <a:solidFill>
+                  <a:srgbClr val="1B2631"/>
+                </a:solidFill>
+                <a:latin typeface="Courier New" panose="02070309020205020404" pitchFamily="49" charset="0"/>
+              </a:rPr>
+              <a:t>  "download_request": { "tool": … }</a:t>
+            </a:r>
+          </a:p>
+          <a:p>
+            <a:r>
+              <a:rPr lang="en-US" sz="1300">
+                <a:solidFill>
+                  <a:srgbClr val="1B2631"/>
+                </a:solidFill>
+                <a:latin typeface="Courier New" panose="02070309020205020404" pitchFamily="49" charset="0"/>
+              </a:rPr>
+              <a:t>}</a:t>
+            </a:r>
+          </a:p>
+        </p:txBody>
+      </p:sp>
+      <p:sp>
+        <p:nvSpPr>
+          <p:cNvPr id="7" name="TextBox 6">
+            <a:extLst>
+              <a:ext uri="{FF2B5EF4-FFF2-40B4-BE49-F238E27FC236}">
+                <a16:creationId xmlns:a16="http://schemas.microsoft.com/office/drawing/2014/main" id="{1F53CBB6-E605-DAE0-6BEF-D188F3A855EF}"/>
+              </a:ext>
+            </a:extLst>
+          </p:cNvPr>
+          <p:cNvSpPr txBox="1"/>
+          <p:nvPr/>
+        </p:nvSpPr>
+        <p:spPr>
+          <a:xfrm>
+            <a:off x="6121400" y="4318000"/>
+            <a:ext cx="5461000" cy="1270000"/>
           </a:xfrm>
           <a:prstGeom prst="rect">
             <a:avLst/>
@@ -9224,13 +9742,13 @@
               <a:buChar char="•"/>
             </a:pPr>
             <a:r>
-              <a:rPr lang="en-US" sz="1700">
+              <a:rPr lang="en-US" sz="1500">
                 <a:solidFill>
                   <a:srgbClr val="1B2631"/>
                 </a:solidFill>
                 <a:latin typeface="Calibri" panose="020F0502020204030204" pitchFamily="34" charset="0"/>
               </a:rPr>
-              <a:t>Searches all services at once, or one at a time</a:t>
+              <a:t>One folder per item: content.md + metadata.json</a:t>
             </a:r>
           </a:p>
           <a:p>
@@ -9242,13 +9760,13 @@
               <a:buChar char="•"/>
             </a:pPr>
             <a:r>
-              <a:rPr lang="en-US" sz="1700">
+              <a:rPr lang="en-US" sz="1500">
                 <a:solidFill>
                   <a:srgbClr val="1B2631"/>
                 </a:solidFill>
                 <a:latin typeface="Calibri" panose="020F0502020204030204" pitchFamily="34" charset="0"/>
               </a:rPr>
-              <a:t>Quotes for exact phrases, matches highlighted</a:t>
+              <a:t>index.json lists every item per service</a:t>
             </a:r>
           </a:p>
           <a:p>
@@ -9260,59 +9778,23 @@
               <a:buChar char="•"/>
             </a:pPr>
             <a:r>
-              <a:rPr lang="en-US" sz="1700">
+              <a:rPr lang="en-US" sz="1500">
                 <a:solidFill>
                   <a:srgbClr val="1B2631"/>
                 </a:solidFill>
                 <a:latin typeface="Calibri" panose="020F0502020204030204" pitchFamily="34" charset="0"/>
               </a:rPr>
-              <a:t>Opens the full item with its metadata</a:t>
-            </a:r>
-          </a:p>
-          <a:p>
-            <a:pPr marL="228600" indent="-228600">
-              <a:spcAft>
-                <a:spcPts val="800"/>
-              </a:spcAft>
-              <a:buFont typeface="+mj-lt"/>
-              <a:buChar char="•"/>
-            </a:pPr>
-            <a:r>
-              <a:rPr lang="en-US" sz="1700">
-                <a:solidFill>
-                  <a:srgbClr val="1B2631"/>
-                </a:solidFill>
-                <a:latin typeface="Calibri" panose="020F0502020204030204" pitchFamily="34" charset="0"/>
-              </a:rPr>
-              <a:t>Plain HTML, works offline: double-click index.html</a:t>
-            </a:r>
-          </a:p>
-          <a:p>
-            <a:pPr marL="228600" indent="-228600">
-              <a:spcAft>
-                <a:spcPts val="800"/>
-              </a:spcAft>
-              <a:buFont typeface="+mj-lt"/>
-              <a:buChar char="•"/>
-            </a:pPr>
-            <a:r>
-              <a:rPr lang="en-US" sz="1700">
-                <a:solidFill>
-                  <a:srgbClr val="1B2631"/>
-                </a:solidFill>
-                <a:latin typeface="Calibri" panose="020F0502020204030204" pitchFamily="34" charset="0"/>
-              </a:rPr>
-              <a:t>Rerun one script after each download</a:t>
-            </a:r>
-          </a:p>
-        </p:txBody>
-      </p:sp>
-      <p:sp>
-        <p:nvSpPr>
-          <p:cNvPr id="6" name="TextBox 5">
-            <a:extLst>
-              <a:ext uri="{FF2B5EF4-FFF2-40B4-BE49-F238E27FC236}">
-                <a16:creationId xmlns:a16="http://schemas.microsoft.com/office/drawing/2014/main" id="{0EA7E02B-1651-A356-6513-8B8D03B7FDD7}"/>
+              <a:t>The item ID is the identity, so re-downloads update instead of duplicating</a:t>
+            </a:r>
+          </a:p>
+        </p:txBody>
+      </p:sp>
+      <p:sp>
+        <p:nvSpPr>
+          <p:cNvPr id="8" name="TextBox 7">
+            <a:extLst>
+              <a:ext uri="{FF2B5EF4-FFF2-40B4-BE49-F238E27FC236}">
+                <a16:creationId xmlns:a16="http://schemas.microsoft.com/office/drawing/2014/main" id="{D9B68717-3F1D-C6A7-ED2C-F102588C936C}"/>
               </a:ext>
             </a:extLst>
           </p:cNvPr>
@@ -9321,8 +9803,8 @@
         </p:nvSpPr>
         <p:spPr>
           <a:xfrm>
-            <a:off x="609600" y="5918200"/>
-            <a:ext cx="6858000" cy="279400"/>
+            <a:off x="609600" y="5486400"/>
+            <a:ext cx="5207000" cy="279400"/>
           </a:xfrm>
           <a:prstGeom prst="rect">
             <a:avLst/>
@@ -9335,15 +9817,54 @@
           </a:bodyPr>
           <a:lstStyle/>
           <a:p>
-            <a:pPr algn="ctr"/>
-            <a:r>
-              <a:rPr lang="en-US" sz="1400" b="1">
+            <a:r>
+              <a:rPr lang="en-US" sz="1400">
                 <a:solidFill>
                   <a:srgbClr val="5D6D7E"/>
                 </a:solidFill>
                 <a:latin typeface="Calibri" panose="020F0502020204030204" pitchFamily="34" charset="0"/>
               </a:rPr>
-              <a:t>“Joe Smith”: 21 results from all four services</a:t>
+              <a:t>Folder layout (full spec: localStorageFormats.md)</a:t>
+            </a:r>
+          </a:p>
+        </p:txBody>
+      </p:sp>
+      <p:sp>
+        <p:nvSpPr>
+          <p:cNvPr id="9" name="TextBox 8">
+            <a:extLst>
+              <a:ext uri="{FF2B5EF4-FFF2-40B4-BE49-F238E27FC236}">
+                <a16:creationId xmlns:a16="http://schemas.microsoft.com/office/drawing/2014/main" id="{DFA17614-E1EF-9A8B-8ED4-FC0D07BC0436}"/>
+              </a:ext>
+            </a:extLst>
+          </p:cNvPr>
+          <p:cNvSpPr txBox="1"/>
+          <p:nvPr/>
+        </p:nvSpPr>
+        <p:spPr>
+          <a:xfrm>
+            <a:off x="6121400" y="3911600"/>
+            <a:ext cx="5461000" cy="279400"/>
+          </a:xfrm>
+          <a:prstGeom prst="rect">
+            <a:avLst/>
+          </a:prstGeom>
+          <a:noFill/>
+        </p:spPr>
+        <p:txBody>
+          <a:bodyPr vert="horz" wrap="square" lIns="0" tIns="0" rIns="0" bIns="0" rtlCol="0">
+            <a:noAutofit/>
+          </a:bodyPr>
+          <a:lstStyle/>
+          <a:p>
+            <a:r>
+              <a:rPr lang="en-US" sz="1400">
+                <a:solidFill>
+                  <a:srgbClr val="5D6D7E"/>
+                </a:solidFill>
+                <a:latin typeface="Calibri" panose="020F0502020204030204" pitchFamily="34" charset="0"/>
+              </a:rPr>
+              <a:t>metadata.json (shortened)</a:t>
             </a:r>
           </a:p>
         </p:txBody>
@@ -9351,7 +9872,7 @@
     </p:spTree>
     <p:extLst>
       <p:ext uri="{BB962C8B-B14F-4D97-AF65-F5344CB8AC3E}">
-        <p14:creationId xmlns:p14="http://schemas.microsoft.com/office/powerpoint/2010/main" val="2784576497"/>
+        <p14:creationId xmlns:p14="http://schemas.microsoft.com/office/powerpoint/2010/main" val="387521825"/>
       </p:ext>
     </p:extLst>
   </p:cSld>
@@ -9391,7 +9912,7 @@
           <p:cNvPr id="2" name="TextBox 1">
             <a:extLst>
               <a:ext uri="{FF2B5EF4-FFF2-40B4-BE49-F238E27FC236}">
-                <a16:creationId xmlns:a16="http://schemas.microsoft.com/office/drawing/2014/main" id="{BDC932DD-D6B1-86C7-BEE4-6B498DE40353}"/>
+                <a16:creationId xmlns:a16="http://schemas.microsoft.com/office/drawing/2014/main" id="{28EF36EC-2A3C-BFA6-54CD-88C6037BF26C}"/>
               </a:ext>
             </a:extLst>
           </p:cNvPr>
@@ -9421,7 +9942,7 @@
                 </a:solidFill>
                 <a:latin typeface="Cambria" panose="02040503050406030204" pitchFamily="18" charset="0"/>
               </a:rPr>
-              <a:t>Gmail: tried, then waived</a:t>
+              <a:t>Skills for repeatable downloads</a:t>
             </a:r>
           </a:p>
         </p:txBody>
@@ -9431,7 +9952,7 @@
           <p:cNvPr id="3" name="Rectangle: Rounded Corners 2">
             <a:extLst>
               <a:ext uri="{FF2B5EF4-FFF2-40B4-BE49-F238E27FC236}">
-                <a16:creationId xmlns:a16="http://schemas.microsoft.com/office/drawing/2014/main" id="{51D70701-CE3D-ED46-87D8-C45D364AEF16}"/>
+                <a16:creationId xmlns:a16="http://schemas.microsoft.com/office/drawing/2014/main" id="{7F54901D-5594-55AC-680D-2E347AC3FFA8}"/>
               </a:ext>
             </a:extLst>
           </p:cNvPr>
@@ -9440,8 +9961,8 @@
         </p:nvSpPr>
         <p:spPr>
           <a:xfrm>
-            <a:off x="609600" y="1397000"/>
-            <a:ext cx="2540000" cy="1524000"/>
+            <a:off x="609600" y="1270000"/>
+            <a:ext cx="5334000" cy="2413000"/>
           </a:xfrm>
           <a:prstGeom prst="roundRect">
             <a:avLst>
@@ -9498,10 +10019,170 @@
       </p:sp>
       <p:sp>
         <p:nvSpPr>
-          <p:cNvPr id="4" name="Oval 3">
-            <a:extLst>
-              <a:ext uri="{FF2B5EF4-FFF2-40B4-BE49-F238E27FC236}">
-                <a16:creationId xmlns:a16="http://schemas.microsoft.com/office/drawing/2014/main" id="{8C726FA1-1FEA-EFD9-9A3B-A88033D87869}"/>
+          <p:cNvPr id="4" name="TextBox 3">
+            <a:extLst>
+              <a:ext uri="{FF2B5EF4-FFF2-40B4-BE49-F238E27FC236}">
+                <a16:creationId xmlns:a16="http://schemas.microsoft.com/office/drawing/2014/main" id="{D43D956B-39F1-FCB0-9A39-29E9D393E65B}"/>
+              </a:ext>
+            </a:extLst>
+          </p:cNvPr>
+          <p:cNvSpPr txBox="1"/>
+          <p:nvPr/>
+        </p:nvSpPr>
+        <p:spPr>
+          <a:xfrm>
+            <a:off x="863600" y="1524000"/>
+            <a:ext cx="4826000" cy="431800"/>
+          </a:xfrm>
+          <a:prstGeom prst="rect">
+            <a:avLst/>
+          </a:prstGeom>
+          <a:noFill/>
+        </p:spPr>
+        <p:txBody>
+          <a:bodyPr vert="horz" wrap="square" lIns="0" tIns="0" rIns="0" bIns="0" rtlCol="0">
+            <a:noAutofit/>
+          </a:bodyPr>
+          <a:lstStyle/>
+          <a:p>
+            <a:r>
+              <a:rPr lang="en-US" sz="2400" b="1">
+                <a:solidFill>
+                  <a:srgbClr val="1F7A8C"/>
+                </a:solidFill>
+                <a:latin typeface="Courier New" panose="02070309020205020404" pitchFamily="49" charset="0"/>
+              </a:rPr>
+              <a:t>download-notion</a:t>
+            </a:r>
+          </a:p>
+        </p:txBody>
+      </p:sp>
+      <p:sp>
+        <p:nvSpPr>
+          <p:cNvPr id="5" name="TextBox 4">
+            <a:extLst>
+              <a:ext uri="{FF2B5EF4-FFF2-40B4-BE49-F238E27FC236}">
+                <a16:creationId xmlns:a16="http://schemas.microsoft.com/office/drawing/2014/main" id="{0423C0F4-C280-CCFC-AE2A-4F390180042E}"/>
+              </a:ext>
+            </a:extLst>
+          </p:cNvPr>
+          <p:cNvSpPr txBox="1"/>
+          <p:nvPr/>
+        </p:nvSpPr>
+        <p:spPr>
+          <a:xfrm>
+            <a:off x="863600" y="2108200"/>
+            <a:ext cx="4826000" cy="330200"/>
+          </a:xfrm>
+          <a:prstGeom prst="rect">
+            <a:avLst/>
+          </a:prstGeom>
+          <a:noFill/>
+        </p:spPr>
+        <p:txBody>
+          <a:bodyPr vert="horz" wrap="square" lIns="0" tIns="0" rIns="0" bIns="0" rtlCol="0">
+            <a:noAutofit/>
+          </a:bodyPr>
+          <a:lstStyle/>
+          <a:p>
+            <a:r>
+              <a:rPr lang="en-US" sz="1700">
+                <a:solidFill>
+                  <a:srgbClr val="1B2631"/>
+                </a:solidFill>
+                <a:latin typeface="Calibri" panose="020F0502020204030204" pitchFamily="34" charset="0"/>
+              </a:rPr>
+              <a:t>Saves Notion pages to dataExports/notion/</a:t>
+            </a:r>
+          </a:p>
+        </p:txBody>
+      </p:sp>
+      <p:sp>
+        <p:nvSpPr>
+          <p:cNvPr id="6" name="TextBox 5">
+            <a:extLst>
+              <a:ext uri="{FF2B5EF4-FFF2-40B4-BE49-F238E27FC236}">
+                <a16:creationId xmlns:a16="http://schemas.microsoft.com/office/drawing/2014/main" id="{D9C2A5EF-D036-E762-83FA-EC264EAF1BC6}"/>
+              </a:ext>
+            </a:extLst>
+          </p:cNvPr>
+          <p:cNvSpPr txBox="1"/>
+          <p:nvPr/>
+        </p:nvSpPr>
+        <p:spPr>
+          <a:xfrm>
+            <a:off x="863600" y="2667000"/>
+            <a:ext cx="4826000" cy="279400"/>
+          </a:xfrm>
+          <a:prstGeom prst="rect">
+            <a:avLst/>
+          </a:prstGeom>
+          <a:noFill/>
+        </p:spPr>
+        <p:txBody>
+          <a:bodyPr vert="horz" wrap="square" lIns="0" tIns="0" rIns="0" bIns="0" rtlCol="0">
+            <a:noAutofit/>
+          </a:bodyPr>
+          <a:lstStyle/>
+          <a:p>
+            <a:r>
+              <a:rPr lang="en-US" sz="1400">
+                <a:solidFill>
+                  <a:srgbClr val="5D6D7E"/>
+                </a:solidFill>
+                <a:latin typeface="Calibri" panose="020F0502020204030204" pitchFamily="34" charset="0"/>
+              </a:rPr>
+              <a:t>Example request:</a:t>
+            </a:r>
+          </a:p>
+        </p:txBody>
+      </p:sp>
+      <p:sp>
+        <p:nvSpPr>
+          <p:cNvPr id="7" name="TextBox 6">
+            <a:extLst>
+              <a:ext uri="{FF2B5EF4-FFF2-40B4-BE49-F238E27FC236}">
+                <a16:creationId xmlns:a16="http://schemas.microsoft.com/office/drawing/2014/main" id="{1BD78DD0-40A2-5117-8221-E897F1C9AA9B}"/>
+              </a:ext>
+            </a:extLst>
+          </p:cNvPr>
+          <p:cNvSpPr txBox="1"/>
+          <p:nvPr/>
+        </p:nvSpPr>
+        <p:spPr>
+          <a:xfrm>
+            <a:off x="863600" y="2971800"/>
+            <a:ext cx="4826000" cy="330200"/>
+          </a:xfrm>
+          <a:prstGeom prst="rect">
+            <a:avLst/>
+          </a:prstGeom>
+          <a:noFill/>
+        </p:spPr>
+        <p:txBody>
+          <a:bodyPr vert="horz" wrap="square" lIns="0" tIns="0" rIns="0" bIns="0" rtlCol="0">
+            <a:noAutofit/>
+          </a:bodyPr>
+          <a:lstStyle/>
+          <a:p>
+            <a:r>
+              <a:rPr lang="en-US" sz="1700">
+                <a:solidFill>
+                  <a:srgbClr val="1B2631"/>
+                </a:solidFill>
+                <a:latin typeface="Calibri" panose="020F0502020204030204" pitchFamily="34" charset="0"/>
+              </a:rPr>
+              <a:t>“Download the pages under Test Data”</a:t>
+            </a:r>
+          </a:p>
+        </p:txBody>
+      </p:sp>
+      <p:sp>
+        <p:nvSpPr>
+          <p:cNvPr id="8" name="Rectangle: Rounded Corners 7">
+            <a:extLst>
+              <a:ext uri="{FF2B5EF4-FFF2-40B4-BE49-F238E27FC236}">
+                <a16:creationId xmlns:a16="http://schemas.microsoft.com/office/drawing/2014/main" id="{3C300C7B-39B4-C103-F9A6-3101869C31FB}"/>
               </a:ext>
             </a:extLst>
           </p:cNvPr>
@@ -9510,14 +10191,16 @@
         </p:nvSpPr>
         <p:spPr>
           <a:xfrm>
-            <a:off x="1574800" y="1574800"/>
-            <a:ext cx="609600" cy="609600"/>
-          </a:xfrm>
-          <a:prstGeom prst="ellipse">
-            <a:avLst/>
+            <a:off x="6248400" y="1270000"/>
+            <a:ext cx="5334000" cy="2413000"/>
+          </a:xfrm>
+          <a:prstGeom prst="roundRect">
+            <a:avLst>
+              <a:gd name="adj" fmla="val 8000"/>
+            </a:avLst>
           </a:prstGeom>
           <a:solidFill>
-            <a:srgbClr val="2E8B57"/>
+            <a:srgbClr val="ECF2F5"/>
           </a:solidFill>
           <a:ln w="19050" cap="flat" cmpd="sng" algn="ctr">
             <a:noFill/>
@@ -9560,24 +10243,16 @@
           <a:lstStyle/>
           <a:p>
             <a:pPr algn="ctr"/>
-            <a:r>
-              <a:rPr lang="en-US" sz="2200" b="1">
-                <a:solidFill>
-                  <a:srgbClr val="FFFFFF"/>
-                </a:solidFill>
-                <a:latin typeface="Calibri" panose="020F0502020204030204" pitchFamily="34" charset="0"/>
-              </a:rPr>
-              <a:t>✓</a:t>
-            </a:r>
-          </a:p>
-        </p:txBody>
-      </p:sp>
-      <p:sp>
-        <p:nvSpPr>
-          <p:cNvPr id="5" name="TextBox 4">
-            <a:extLst>
-              <a:ext uri="{FF2B5EF4-FFF2-40B4-BE49-F238E27FC236}">
-                <a16:creationId xmlns:a16="http://schemas.microsoft.com/office/drawing/2014/main" id="{3D90E953-EF96-8504-7447-471C4B6CF872}"/>
+            <a:endParaRPr lang="en-US"/>
+          </a:p>
+        </p:txBody>
+      </p:sp>
+      <p:sp>
+        <p:nvSpPr>
+          <p:cNvPr id="9" name="TextBox 8">
+            <a:extLst>
+              <a:ext uri="{FF2B5EF4-FFF2-40B4-BE49-F238E27FC236}">
+                <a16:creationId xmlns:a16="http://schemas.microsoft.com/office/drawing/2014/main" id="{91AC5FEA-4142-92E7-B984-7E275770E81C}"/>
               </a:ext>
             </a:extLst>
           </p:cNvPr>
@@ -9586,8 +10261,8 @@
         </p:nvSpPr>
         <p:spPr>
           <a:xfrm>
-            <a:off x="736600" y="2362200"/>
-            <a:ext cx="2286000" cy="355600"/>
+            <a:off x="6502400" y="1524000"/>
+            <a:ext cx="4826000" cy="431800"/>
           </a:xfrm>
           <a:prstGeom prst="rect">
             <a:avLst/>
@@ -9600,25 +10275,144 @@
           </a:bodyPr>
           <a:lstStyle/>
           <a:p>
-            <a:pPr algn="ctr"/>
-            <a:r>
-              <a:rPr lang="en-US" b="1">
+            <a:r>
+              <a:rPr lang="en-US" sz="2400" b="1">
+                <a:solidFill>
+                  <a:srgbClr val="1F7A8C"/>
+                </a:solidFill>
+                <a:latin typeface="Courier New" panose="02070309020205020404" pitchFamily="49" charset="0"/>
+              </a:rPr>
+              <a:t>download-jira</a:t>
+            </a:r>
+          </a:p>
+        </p:txBody>
+      </p:sp>
+      <p:sp>
+        <p:nvSpPr>
+          <p:cNvPr id="10" name="TextBox 9">
+            <a:extLst>
+              <a:ext uri="{FF2B5EF4-FFF2-40B4-BE49-F238E27FC236}">
+                <a16:creationId xmlns:a16="http://schemas.microsoft.com/office/drawing/2014/main" id="{5EEDB97F-42F9-BE18-0EDA-B67E8DB64904}"/>
+              </a:ext>
+            </a:extLst>
+          </p:cNvPr>
+          <p:cNvSpPr txBox="1"/>
+          <p:nvPr/>
+        </p:nvSpPr>
+        <p:spPr>
+          <a:xfrm>
+            <a:off x="6502400" y="2108200"/>
+            <a:ext cx="4826000" cy="330200"/>
+          </a:xfrm>
+          <a:prstGeom prst="rect">
+            <a:avLst/>
+          </a:prstGeom>
+          <a:noFill/>
+        </p:spPr>
+        <p:txBody>
+          <a:bodyPr vert="horz" wrap="square" lIns="0" tIns="0" rIns="0" bIns="0" rtlCol="0">
+            <a:noAutofit/>
+          </a:bodyPr>
+          <a:lstStyle/>
+          <a:p>
+            <a:r>
+              <a:rPr lang="en-US" sz="1700">
                 <a:solidFill>
                   <a:srgbClr val="1B2631"/>
                 </a:solidFill>
                 <a:latin typeface="Calibri" panose="020F0502020204030204" pitchFamily="34" charset="0"/>
               </a:rPr>
-              <a:t>OAuth client</a:t>
-            </a:r>
-          </a:p>
-        </p:txBody>
-      </p:sp>
-      <p:sp>
-        <p:nvSpPr>
-          <p:cNvPr id="6" name="Rectangle: Rounded Corners 5">
-            <a:extLst>
-              <a:ext uri="{FF2B5EF4-FFF2-40B4-BE49-F238E27FC236}">
-                <a16:creationId xmlns:a16="http://schemas.microsoft.com/office/drawing/2014/main" id="{92E276A1-DA06-BDB4-703B-EB8EF532E373}"/>
+              <a:t>Saves Jira issues to dataExports/jira/</a:t>
+            </a:r>
+          </a:p>
+        </p:txBody>
+      </p:sp>
+      <p:sp>
+        <p:nvSpPr>
+          <p:cNvPr id="11" name="TextBox 10">
+            <a:extLst>
+              <a:ext uri="{FF2B5EF4-FFF2-40B4-BE49-F238E27FC236}">
+                <a16:creationId xmlns:a16="http://schemas.microsoft.com/office/drawing/2014/main" id="{71630340-9EA2-5518-8B20-B630BA49DA29}"/>
+              </a:ext>
+            </a:extLst>
+          </p:cNvPr>
+          <p:cNvSpPr txBox="1"/>
+          <p:nvPr/>
+        </p:nvSpPr>
+        <p:spPr>
+          <a:xfrm>
+            <a:off x="6502400" y="2667000"/>
+            <a:ext cx="4826000" cy="279400"/>
+          </a:xfrm>
+          <a:prstGeom prst="rect">
+            <a:avLst/>
+          </a:prstGeom>
+          <a:noFill/>
+        </p:spPr>
+        <p:txBody>
+          <a:bodyPr vert="horz" wrap="square" lIns="0" tIns="0" rIns="0" bIns="0" rtlCol="0">
+            <a:noAutofit/>
+          </a:bodyPr>
+          <a:lstStyle/>
+          <a:p>
+            <a:r>
+              <a:rPr lang="en-US" sz="1400">
+                <a:solidFill>
+                  <a:srgbClr val="5D6D7E"/>
+                </a:solidFill>
+                <a:latin typeface="Calibri" panose="020F0502020204030204" pitchFamily="34" charset="0"/>
+              </a:rPr>
+              <a:t>Example request:</a:t>
+            </a:r>
+          </a:p>
+        </p:txBody>
+      </p:sp>
+      <p:sp>
+        <p:nvSpPr>
+          <p:cNvPr id="12" name="TextBox 11">
+            <a:extLst>
+              <a:ext uri="{FF2B5EF4-FFF2-40B4-BE49-F238E27FC236}">
+                <a16:creationId xmlns:a16="http://schemas.microsoft.com/office/drawing/2014/main" id="{4FD7EDC7-A855-9599-D6AB-A710E45F58AD}"/>
+              </a:ext>
+            </a:extLst>
+          </p:cNvPr>
+          <p:cNvSpPr txBox="1"/>
+          <p:nvPr/>
+        </p:nvSpPr>
+        <p:spPr>
+          <a:xfrm>
+            <a:off x="6502400" y="2971800"/>
+            <a:ext cx="4826000" cy="330200"/>
+          </a:xfrm>
+          <a:prstGeom prst="rect">
+            <a:avLst/>
+          </a:prstGeom>
+          <a:noFill/>
+        </p:spPr>
+        <p:txBody>
+          <a:bodyPr vert="horz" wrap="square" lIns="0" tIns="0" rIns="0" bIns="0" rtlCol="0">
+            <a:noAutofit/>
+          </a:bodyPr>
+          <a:lstStyle/>
+          <a:p>
+            <a:r>
+              <a:rPr lang="en-US" sz="1700">
+                <a:solidFill>
+                  <a:srgbClr val="1B2631"/>
+                </a:solidFill>
+                <a:latin typeface="Calibri" panose="020F0502020204030204" pitchFamily="34" charset="0"/>
+              </a:rPr>
+              <a:t>“Download all FALCON issues”</a:t>
+            </a:r>
+          </a:p>
+        </p:txBody>
+      </p:sp>
+      <p:sp>
+        <p:nvSpPr>
+          <p:cNvPr id="13" name="Rectangle: Rounded Corners 12">
+            <a:extLst>
+              <a:ext uri="{FF2B5EF4-FFF2-40B4-BE49-F238E27FC236}">
+                <a16:creationId xmlns:a16="http://schemas.microsoft.com/office/drawing/2014/main" id="{6A215696-3684-E65E-D749-A78C498B3383}"/>
               </a:ext>
             </a:extLst>
           </p:cNvPr>
@@ -9627,8 +10421,8 @@
         </p:nvSpPr>
         <p:spPr>
           <a:xfrm>
-            <a:off x="3429000" y="1397000"/>
-            <a:ext cx="2540000" cy="1524000"/>
+            <a:off x="609600" y="4013200"/>
+            <a:ext cx="10972800" cy="1397000"/>
           </a:xfrm>
           <a:prstGeom prst="roundRect">
             <a:avLst>
@@ -9636,7 +10430,7 @@
             </a:avLst>
           </a:prstGeom>
           <a:solidFill>
-            <a:srgbClr val="ECF2F5"/>
+            <a:srgbClr val="0F2A3A"/>
           </a:solidFill>
           <a:ln w="19050" cap="flat" cmpd="sng" algn="ctr">
             <a:noFill/>
@@ -9685,86 +10479,10 @@
       </p:sp>
       <p:sp>
         <p:nvSpPr>
-          <p:cNvPr id="7" name="Oval 6">
-            <a:extLst>
-              <a:ext uri="{FF2B5EF4-FFF2-40B4-BE49-F238E27FC236}">
-                <a16:creationId xmlns:a16="http://schemas.microsoft.com/office/drawing/2014/main" id="{AC00B5F5-79B3-65EF-45DF-C309D659470A}"/>
-              </a:ext>
-            </a:extLst>
-          </p:cNvPr>
-          <p:cNvSpPr/>
-          <p:nvPr/>
-        </p:nvSpPr>
-        <p:spPr>
-          <a:xfrm>
-            <a:off x="4394200" y="1574800"/>
-            <a:ext cx="609600" cy="609600"/>
-          </a:xfrm>
-          <a:prstGeom prst="ellipse">
-            <a:avLst/>
-          </a:prstGeom>
-          <a:solidFill>
-            <a:srgbClr val="2E8B57"/>
-          </a:solidFill>
-          <a:ln w="19050" cap="flat" cmpd="sng" algn="ctr">
-            <a:noFill/>
-            <a:prstDash val="solid"/>
-            <a:miter lim="800000"/>
-          </a:ln>
-          <a:effectLst/>
-          <a:extLst>
-            <a:ext uri="{91240B29-F687-4F45-9708-019B960494DF}">
-              <a14:hiddenLine xmlns:a14="http://schemas.microsoft.com/office/drawing/2010/main" w="19050" cap="flat" cmpd="sng" algn="ctr">
-                <a:solidFill>
-                  <a:schemeClr val="accent1">
-                    <a:shade val="15000"/>
-                  </a:schemeClr>
-                </a:solidFill>
-                <a:prstDash val="solid"/>
-                <a:miter lim="800000"/>
-              </a14:hiddenLine>
-            </a:ext>
-          </a:extLst>
-        </p:spPr>
-        <p:style>
-          <a:lnRef idx="2">
-            <a:schemeClr val="accent1">
-              <a:shade val="15000"/>
-            </a:schemeClr>
-          </a:lnRef>
-          <a:fillRef idx="1">
-            <a:schemeClr val="accent1"/>
-          </a:fillRef>
-          <a:effectRef idx="0">
-            <a:schemeClr val="accent1"/>
-          </a:effectRef>
-          <a:fontRef idx="minor">
-            <a:schemeClr val="lt1"/>
-          </a:fontRef>
-        </p:style>
-        <p:txBody>
-          <a:bodyPr rtlCol="0" anchor="ctr"/>
-          <a:lstStyle/>
-          <a:p>
-            <a:pPr algn="ctr"/>
-            <a:r>
-              <a:rPr lang="en-US" sz="2200" b="1">
-                <a:solidFill>
-                  <a:srgbClr val="FFFFFF"/>
-                </a:solidFill>
-                <a:latin typeface="Calibri" panose="020F0502020204030204" pitchFamily="34" charset="0"/>
-              </a:rPr>
-              <a:t>✓</a:t>
-            </a:r>
-          </a:p>
-        </p:txBody>
-      </p:sp>
-      <p:sp>
-        <p:nvSpPr>
-          <p:cNvPr id="8" name="TextBox 7">
-            <a:extLst>
-              <a:ext uri="{FF2B5EF4-FFF2-40B4-BE49-F238E27FC236}">
-                <a16:creationId xmlns:a16="http://schemas.microsoft.com/office/drawing/2014/main" id="{D4C8662B-8BF2-F973-7AA9-AFCC189E43F5}"/>
+          <p:cNvPr id="14" name="TextBox 13">
+            <a:extLst>
+              <a:ext uri="{FF2B5EF4-FFF2-40B4-BE49-F238E27FC236}">
+                <a16:creationId xmlns:a16="http://schemas.microsoft.com/office/drawing/2014/main" id="{0C07E787-EA8C-886D-3C8C-46118E7ADC03}"/>
               </a:ext>
             </a:extLst>
           </p:cNvPr>
@@ -9773,8 +10491,8 @@
         </p:nvSpPr>
         <p:spPr>
           <a:xfrm>
-            <a:off x="3556000" y="2362200"/>
-            <a:ext cx="2286000" cy="355600"/>
+            <a:off x="914400" y="4241800"/>
+            <a:ext cx="10414000" cy="381000"/>
           </a:xfrm>
           <a:prstGeom prst="rect">
             <a:avLst/>
@@ -9787,171 +10505,24 @@
           </a:bodyPr>
           <a:lstStyle/>
           <a:p>
-            <a:pPr algn="ctr"/>
-            <a:r>
-              <a:rPr lang="en-US" b="1">
-                <a:solidFill>
-                  <a:srgbClr val="1B2631"/>
-                </a:solidFill>
-                <a:latin typeface="Calibri" panose="020F0502020204030204" pitchFamily="34" charset="0"/>
-              </a:rPr>
-              <a:t>Consent screen</a:t>
-            </a:r>
-          </a:p>
-        </p:txBody>
-      </p:sp>
-      <p:sp>
-        <p:nvSpPr>
-          <p:cNvPr id="9" name="Rectangle: Rounded Corners 8">
-            <a:extLst>
-              <a:ext uri="{FF2B5EF4-FFF2-40B4-BE49-F238E27FC236}">
-                <a16:creationId xmlns:a16="http://schemas.microsoft.com/office/drawing/2014/main" id="{D57594C1-8F72-4691-9212-72D6402225E5}"/>
-              </a:ext>
-            </a:extLst>
-          </p:cNvPr>
-          <p:cNvSpPr/>
-          <p:nvPr/>
-        </p:nvSpPr>
-        <p:spPr>
-          <a:xfrm>
-            <a:off x="6248400" y="1397000"/>
-            <a:ext cx="2540000" cy="1524000"/>
-          </a:xfrm>
-          <a:prstGeom prst="roundRect">
-            <a:avLst>
-              <a:gd name="adj" fmla="val 8000"/>
-            </a:avLst>
-          </a:prstGeom>
-          <a:solidFill>
-            <a:srgbClr val="ECF2F5"/>
-          </a:solidFill>
-          <a:ln w="19050" cap="flat" cmpd="sng" algn="ctr">
-            <a:noFill/>
-            <a:prstDash val="solid"/>
-            <a:miter lim="800000"/>
-          </a:ln>
-          <a:effectLst/>
-          <a:extLst>
-            <a:ext uri="{91240B29-F687-4F45-9708-019B960494DF}">
-              <a14:hiddenLine xmlns:a14="http://schemas.microsoft.com/office/drawing/2010/main" w="19050" cap="flat" cmpd="sng" algn="ctr">
-                <a:solidFill>
-                  <a:schemeClr val="accent1">
-                    <a:shade val="15000"/>
-                  </a:schemeClr>
-                </a:solidFill>
-                <a:prstDash val="solid"/>
-                <a:miter lim="800000"/>
-              </a14:hiddenLine>
-            </a:ext>
-          </a:extLst>
-        </p:spPr>
-        <p:style>
-          <a:lnRef idx="2">
-            <a:schemeClr val="accent1">
-              <a:shade val="15000"/>
-            </a:schemeClr>
-          </a:lnRef>
-          <a:fillRef idx="1">
-            <a:schemeClr val="accent1"/>
-          </a:fillRef>
-          <a:effectRef idx="0">
-            <a:schemeClr val="accent1"/>
-          </a:effectRef>
-          <a:fontRef idx="minor">
-            <a:schemeClr val="lt1"/>
-          </a:fontRef>
-        </p:style>
-        <p:txBody>
-          <a:bodyPr rtlCol="0" anchor="ctr"/>
-          <a:lstStyle/>
-          <a:p>
-            <a:pPr algn="ctr"/>
-            <a:endParaRPr lang="en-US"/>
-          </a:p>
-        </p:txBody>
-      </p:sp>
-      <p:sp>
-        <p:nvSpPr>
-          <p:cNvPr id="10" name="Oval 9">
-            <a:extLst>
-              <a:ext uri="{FF2B5EF4-FFF2-40B4-BE49-F238E27FC236}">
-                <a16:creationId xmlns:a16="http://schemas.microsoft.com/office/drawing/2014/main" id="{1F6AC73F-DB4D-5D85-5DFF-7EC95F6A6548}"/>
-              </a:ext>
-            </a:extLst>
-          </p:cNvPr>
-          <p:cNvSpPr/>
-          <p:nvPr/>
-        </p:nvSpPr>
-        <p:spPr>
-          <a:xfrm>
-            <a:off x="7213600" y="1574800"/>
-            <a:ext cx="609600" cy="609600"/>
-          </a:xfrm>
-          <a:prstGeom prst="ellipse">
-            <a:avLst/>
-          </a:prstGeom>
-          <a:solidFill>
-            <a:srgbClr val="2E8B57"/>
-          </a:solidFill>
-          <a:ln w="19050" cap="flat" cmpd="sng" algn="ctr">
-            <a:noFill/>
-            <a:prstDash val="solid"/>
-            <a:miter lim="800000"/>
-          </a:ln>
-          <a:effectLst/>
-          <a:extLst>
-            <a:ext uri="{91240B29-F687-4F45-9708-019B960494DF}">
-              <a14:hiddenLine xmlns:a14="http://schemas.microsoft.com/office/drawing/2010/main" w="19050" cap="flat" cmpd="sng" algn="ctr">
-                <a:solidFill>
-                  <a:schemeClr val="accent1">
-                    <a:shade val="15000"/>
-                  </a:schemeClr>
-                </a:solidFill>
-                <a:prstDash val="solid"/>
-                <a:miter lim="800000"/>
-              </a14:hiddenLine>
-            </a:ext>
-          </a:extLst>
-        </p:spPr>
-        <p:style>
-          <a:lnRef idx="2">
-            <a:schemeClr val="accent1">
-              <a:shade val="15000"/>
-            </a:schemeClr>
-          </a:lnRef>
-          <a:fillRef idx="1">
-            <a:schemeClr val="accent1"/>
-          </a:fillRef>
-          <a:effectRef idx="0">
-            <a:schemeClr val="accent1"/>
-          </a:effectRef>
-          <a:fontRef idx="minor">
-            <a:schemeClr val="lt1"/>
-          </a:fontRef>
-        </p:style>
-        <p:txBody>
-          <a:bodyPr rtlCol="0" anchor="ctr"/>
-          <a:lstStyle/>
-          <a:p>
-            <a:pPr algn="ctr"/>
             <a:r>
               <a:rPr lang="en-US" sz="2200" b="1">
                 <a:solidFill>
-                  <a:srgbClr val="FFFFFF"/>
-                </a:solidFill>
-                <a:latin typeface="Calibri" panose="020F0502020204030204" pitchFamily="34" charset="0"/>
-              </a:rPr>
-              <a:t>✓</a:t>
-            </a:r>
-          </a:p>
-        </p:txBody>
-      </p:sp>
-      <p:sp>
-        <p:nvSpPr>
-          <p:cNvPr id="11" name="TextBox 10">
-            <a:extLst>
-              <a:ext uri="{FF2B5EF4-FFF2-40B4-BE49-F238E27FC236}">
-                <a16:creationId xmlns:a16="http://schemas.microsoft.com/office/drawing/2014/main" id="{62AED7F1-EAAC-D65E-B1DF-1FE8F06412AC}"/>
+                  <a:srgbClr val="F2A541"/>
+                </a:solidFill>
+                <a:latin typeface="Cambria" panose="02040503050406030204" pitchFamily="18" charset="0"/>
+              </a:rPr>
+              <a:t>Tested in a fresh conversation</a:t>
+            </a:r>
+          </a:p>
+        </p:txBody>
+      </p:sp>
+      <p:sp>
+        <p:nvSpPr>
+          <p:cNvPr id="15" name="TextBox 14">
+            <a:extLst>
+              <a:ext uri="{FF2B5EF4-FFF2-40B4-BE49-F238E27FC236}">
+                <a16:creationId xmlns:a16="http://schemas.microsoft.com/office/drawing/2014/main" id="{027C7CB3-5ACD-BB9C-4AF0-AB2226132AAD}"/>
               </a:ext>
             </a:extLst>
           </p:cNvPr>
@@ -9960,8 +10531,8 @@
         </p:nvSpPr>
         <p:spPr>
           <a:xfrm>
-            <a:off x="6375400" y="2362200"/>
-            <a:ext cx="2286000" cy="355600"/>
+            <a:off x="914400" y="4724400"/>
+            <a:ext cx="10414000" cy="558800"/>
           </a:xfrm>
           <a:prstGeom prst="rect">
             <a:avLst/>
@@ -9974,392 +10545,14 @@
           </a:bodyPr>
           <a:lstStyle/>
           <a:p>
-            <a:pPr algn="ctr"/>
-            <a:r>
-              <a:rPr lang="en-US" b="1">
-                <a:solidFill>
-                  <a:srgbClr val="1B2631"/>
+            <a:r>
+              <a:rPr lang="en-US" sz="1700">
+                <a:solidFill>
+                  <a:srgbClr val="FFFFFF"/>
                 </a:solidFill>
                 <a:latin typeface="Calibri" panose="020F0502020204030204" pitchFamily="34" charset="0"/>
               </a:rPr>
-              <a:t>Sign-in</a:t>
-            </a:r>
-          </a:p>
-        </p:txBody>
-      </p:sp>
-      <p:sp>
-        <p:nvSpPr>
-          <p:cNvPr id="12" name="Rectangle: Rounded Corners 11">
-            <a:extLst>
-              <a:ext uri="{FF2B5EF4-FFF2-40B4-BE49-F238E27FC236}">
-                <a16:creationId xmlns:a16="http://schemas.microsoft.com/office/drawing/2014/main" id="{B73BD71F-206F-8665-D401-FB61E1D2C710}"/>
-              </a:ext>
-            </a:extLst>
-          </p:cNvPr>
-          <p:cNvSpPr/>
-          <p:nvPr/>
-        </p:nvSpPr>
-        <p:spPr>
-          <a:xfrm>
-            <a:off x="9067800" y="1397000"/>
-            <a:ext cx="2540000" cy="1524000"/>
-          </a:xfrm>
-          <a:prstGeom prst="roundRect">
-            <a:avLst>
-              <a:gd name="adj" fmla="val 8000"/>
-            </a:avLst>
-          </a:prstGeom>
-          <a:solidFill>
-            <a:srgbClr val="ECF2F5"/>
-          </a:solidFill>
-          <a:ln w="19050" cap="flat" cmpd="sng" algn="ctr">
-            <a:noFill/>
-            <a:prstDash val="solid"/>
-            <a:miter lim="800000"/>
-          </a:ln>
-          <a:effectLst/>
-          <a:extLst>
-            <a:ext uri="{91240B29-F687-4F45-9708-019B960494DF}">
-              <a14:hiddenLine xmlns:a14="http://schemas.microsoft.com/office/drawing/2010/main" w="19050" cap="flat" cmpd="sng" algn="ctr">
-                <a:solidFill>
-                  <a:schemeClr val="accent1">
-                    <a:shade val="15000"/>
-                  </a:schemeClr>
-                </a:solidFill>
-                <a:prstDash val="solid"/>
-                <a:miter lim="800000"/>
-              </a14:hiddenLine>
-            </a:ext>
-          </a:extLst>
-        </p:spPr>
-        <p:style>
-          <a:lnRef idx="2">
-            <a:schemeClr val="accent1">
-              <a:shade val="15000"/>
-            </a:schemeClr>
-          </a:lnRef>
-          <a:fillRef idx="1">
-            <a:schemeClr val="accent1"/>
-          </a:fillRef>
-          <a:effectRef idx="0">
-            <a:schemeClr val="accent1"/>
-          </a:effectRef>
-          <a:fontRef idx="minor">
-            <a:schemeClr val="lt1"/>
-          </a:fontRef>
-        </p:style>
-        <p:txBody>
-          <a:bodyPr rtlCol="0" anchor="ctr"/>
-          <a:lstStyle/>
-          <a:p>
-            <a:pPr algn="ctr"/>
-            <a:endParaRPr lang="en-US"/>
-          </a:p>
-        </p:txBody>
-      </p:sp>
-      <p:sp>
-        <p:nvSpPr>
-          <p:cNvPr id="13" name="Oval 12">
-            <a:extLst>
-              <a:ext uri="{FF2B5EF4-FFF2-40B4-BE49-F238E27FC236}">
-                <a16:creationId xmlns:a16="http://schemas.microsoft.com/office/drawing/2014/main" id="{BDEDEE59-A47F-2EAC-8B29-FF70C3C7CBAC}"/>
-              </a:ext>
-            </a:extLst>
-          </p:cNvPr>
-          <p:cNvSpPr/>
-          <p:nvPr/>
-        </p:nvSpPr>
-        <p:spPr>
-          <a:xfrm>
-            <a:off x="10033000" y="1574800"/>
-            <a:ext cx="609600" cy="609600"/>
-          </a:xfrm>
-          <a:prstGeom prst="ellipse">
-            <a:avLst/>
-          </a:prstGeom>
-          <a:solidFill>
-            <a:srgbClr val="C0392B"/>
-          </a:solidFill>
-          <a:ln w="19050" cap="flat" cmpd="sng" algn="ctr">
-            <a:noFill/>
-            <a:prstDash val="solid"/>
-            <a:miter lim="800000"/>
-          </a:ln>
-          <a:effectLst/>
-          <a:extLst>
-            <a:ext uri="{91240B29-F687-4F45-9708-019B960494DF}">
-              <a14:hiddenLine xmlns:a14="http://schemas.microsoft.com/office/drawing/2010/main" w="19050" cap="flat" cmpd="sng" algn="ctr">
-                <a:solidFill>
-                  <a:schemeClr val="accent1">
-                    <a:shade val="15000"/>
-                  </a:schemeClr>
-                </a:solidFill>
-                <a:prstDash val="solid"/>
-                <a:miter lim="800000"/>
-              </a14:hiddenLine>
-            </a:ext>
-          </a:extLst>
-        </p:spPr>
-        <p:style>
-          <a:lnRef idx="2">
-            <a:schemeClr val="accent1">
-              <a:shade val="15000"/>
-            </a:schemeClr>
-          </a:lnRef>
-          <a:fillRef idx="1">
-            <a:schemeClr val="accent1"/>
-          </a:fillRef>
-          <a:effectRef idx="0">
-            <a:schemeClr val="accent1"/>
-          </a:effectRef>
-          <a:fontRef idx="minor">
-            <a:schemeClr val="lt1"/>
-          </a:fontRef>
-        </p:style>
-        <p:txBody>
-          <a:bodyPr rtlCol="0" anchor="ctr"/>
-          <a:lstStyle/>
-          <a:p>
-            <a:pPr algn="ctr"/>
-            <a:r>
-              <a:rPr lang="en-US" sz="2200" b="1">
-                <a:solidFill>
-                  <a:srgbClr val="FFFFFF"/>
-                </a:solidFill>
-                <a:latin typeface="Calibri" panose="020F0502020204030204" pitchFamily="34" charset="0"/>
-              </a:rPr>
-              <a:t>✗</a:t>
-            </a:r>
-          </a:p>
-        </p:txBody>
-      </p:sp>
-      <p:sp>
-        <p:nvSpPr>
-          <p:cNvPr id="14" name="TextBox 13">
-            <a:extLst>
-              <a:ext uri="{FF2B5EF4-FFF2-40B4-BE49-F238E27FC236}">
-                <a16:creationId xmlns:a16="http://schemas.microsoft.com/office/drawing/2014/main" id="{B4EC3A6B-CC0A-C0E0-30D0-6AEDCC4489C3}"/>
-              </a:ext>
-            </a:extLst>
-          </p:cNvPr>
-          <p:cNvSpPr txBox="1"/>
-          <p:nvPr/>
-        </p:nvSpPr>
-        <p:spPr>
-          <a:xfrm>
-            <a:off x="9194800" y="2362200"/>
-            <a:ext cx="2286000" cy="355600"/>
-          </a:xfrm>
-          <a:prstGeom prst="rect">
-            <a:avLst/>
-          </a:prstGeom>
-          <a:noFill/>
-        </p:spPr>
-        <p:txBody>
-          <a:bodyPr vert="horz" wrap="square" lIns="0" tIns="0" rIns="0" bIns="0" rtlCol="0">
-            <a:noAutofit/>
-          </a:bodyPr>
-          <a:lstStyle/>
-          <a:p>
-            <a:pPr algn="ctr"/>
-            <a:r>
-              <a:rPr lang="en-US" b="1">
-                <a:solidFill>
-                  <a:srgbClr val="1B2631"/>
-                </a:solidFill>
-                <a:latin typeface="Calibri" panose="020F0502020204030204" pitchFamily="34" charset="0"/>
-              </a:rPr>
-              <a:t>Tool calls</a:t>
-            </a:r>
-          </a:p>
-        </p:txBody>
-      </p:sp>
-      <p:sp>
-        <p:nvSpPr>
-          <p:cNvPr id="15" name="TextBox 14">
-            <a:extLst>
-              <a:ext uri="{FF2B5EF4-FFF2-40B4-BE49-F238E27FC236}">
-                <a16:creationId xmlns:a16="http://schemas.microsoft.com/office/drawing/2014/main" id="{6717D2FB-85A7-25E0-87CD-A33DE2D335B2}"/>
-              </a:ext>
-            </a:extLst>
-          </p:cNvPr>
-          <p:cNvSpPr txBox="1"/>
-          <p:nvPr/>
-        </p:nvSpPr>
-        <p:spPr>
-          <a:xfrm>
-            <a:off x="609600" y="3302000"/>
-            <a:ext cx="10972800" cy="330200"/>
-          </a:xfrm>
-          <a:prstGeom prst="rect">
-            <a:avLst/>
-          </a:prstGeom>
-          <a:noFill/>
-        </p:spPr>
-        <p:txBody>
-          <a:bodyPr vert="horz" wrap="square" lIns="0" tIns="0" rIns="0" bIns="0" rtlCol="0">
-            <a:noAutofit/>
-          </a:bodyPr>
-          <a:lstStyle/>
-          <a:p>
-            <a:r>
-              <a:rPr lang="en-US">
-                <a:solidFill>
-                  <a:srgbClr val="1B2631"/>
-                </a:solidFill>
-                <a:latin typeface="Calibri" panose="020F0502020204030204" pitchFamily="34" charset="0"/>
-              </a:rPr>
-              <a:t>We used Google's official Gmail MCP server.</a:t>
-            </a:r>
-          </a:p>
-        </p:txBody>
-      </p:sp>
-      <p:sp>
-        <p:nvSpPr>
-          <p:cNvPr id="16" name="TextBox 15">
-            <a:extLst>
-              <a:ext uri="{FF2B5EF4-FFF2-40B4-BE49-F238E27FC236}">
-                <a16:creationId xmlns:a16="http://schemas.microsoft.com/office/drawing/2014/main" id="{1368B154-0B5E-D749-A3B2-80C71B0F507D}"/>
-              </a:ext>
-            </a:extLst>
-          </p:cNvPr>
-          <p:cNvSpPr txBox="1"/>
-          <p:nvPr/>
-        </p:nvSpPr>
-        <p:spPr>
-          <a:xfrm>
-            <a:off x="609600" y="3708400"/>
-            <a:ext cx="10972800" cy="711200"/>
-          </a:xfrm>
-          <a:prstGeom prst="rect">
-            <a:avLst/>
-          </a:prstGeom>
-          <a:noFill/>
-        </p:spPr>
-        <p:txBody>
-          <a:bodyPr vert="horz" wrap="square" lIns="0" tIns="0" rIns="0" bIns="0" rtlCol="0">
-            <a:noAutofit/>
-          </a:bodyPr>
-          <a:lstStyle/>
-          <a:p>
-            <a:r>
-              <a:rPr lang="en-US">
-                <a:solidFill>
-                  <a:srgbClr val="1B2631"/>
-                </a:solidFill>
-                <a:latin typeface="Calibri" panose="020F0502020204030204" pitchFamily="34" charset="0"/>
-              </a:rPr>
-              <a:t>Every tool call was rejected: the Google Cloud project must be in the Workspace Developer Preview Program.</a:t>
-            </a:r>
-          </a:p>
-        </p:txBody>
-      </p:sp>
-      <p:sp>
-        <p:nvSpPr>
-          <p:cNvPr id="17" name="Rectangle: Rounded Corners 16">
-            <a:extLst>
-              <a:ext uri="{FF2B5EF4-FFF2-40B4-BE49-F238E27FC236}">
-                <a16:creationId xmlns:a16="http://schemas.microsoft.com/office/drawing/2014/main" id="{3EEA04D7-467A-ADF8-C66A-21AE3DA554AB}"/>
-              </a:ext>
-            </a:extLst>
-          </p:cNvPr>
-          <p:cNvSpPr/>
-          <p:nvPr/>
-        </p:nvSpPr>
-        <p:spPr>
-          <a:xfrm>
-            <a:off x="609600" y="4699000"/>
-            <a:ext cx="10972800" cy="812800"/>
-          </a:xfrm>
-          <a:prstGeom prst="roundRect">
-            <a:avLst>
-              <a:gd name="adj" fmla="val 8000"/>
-            </a:avLst>
-          </a:prstGeom>
-          <a:solidFill>
-            <a:srgbClr val="0F2A3A"/>
-          </a:solidFill>
-          <a:ln w="19050" cap="flat" cmpd="sng" algn="ctr">
-            <a:noFill/>
-            <a:prstDash val="solid"/>
-            <a:miter lim="800000"/>
-          </a:ln>
-          <a:effectLst/>
-          <a:extLst>
-            <a:ext uri="{91240B29-F687-4F45-9708-019B960494DF}">
-              <a14:hiddenLine xmlns:a14="http://schemas.microsoft.com/office/drawing/2010/main" w="19050" cap="flat" cmpd="sng" algn="ctr">
-                <a:solidFill>
-                  <a:schemeClr val="accent1">
-                    <a:shade val="15000"/>
-                  </a:schemeClr>
-                </a:solidFill>
-                <a:prstDash val="solid"/>
-                <a:miter lim="800000"/>
-              </a14:hiddenLine>
-            </a:ext>
-          </a:extLst>
-        </p:spPr>
-        <p:style>
-          <a:lnRef idx="2">
-            <a:schemeClr val="accent1">
-              <a:shade val="15000"/>
-            </a:schemeClr>
-          </a:lnRef>
-          <a:fillRef idx="1">
-            <a:schemeClr val="accent1"/>
-          </a:fillRef>
-          <a:effectRef idx="0">
-            <a:schemeClr val="accent1"/>
-          </a:effectRef>
-          <a:fontRef idx="minor">
-            <a:schemeClr val="lt1"/>
-          </a:fontRef>
-        </p:style>
-        <p:txBody>
-          <a:bodyPr rtlCol="0" anchor="ctr"/>
-          <a:lstStyle/>
-          <a:p>
-            <a:pPr algn="ctr"/>
-            <a:endParaRPr lang="en-US"/>
-          </a:p>
-        </p:txBody>
-      </p:sp>
-      <p:sp>
-        <p:nvSpPr>
-          <p:cNvPr id="18" name="TextBox 17">
-            <a:extLst>
-              <a:ext uri="{FF2B5EF4-FFF2-40B4-BE49-F238E27FC236}">
-                <a16:creationId xmlns:a16="http://schemas.microsoft.com/office/drawing/2014/main" id="{D0396520-4F9F-3742-A712-63040A537A21}"/>
-              </a:ext>
-            </a:extLst>
-          </p:cNvPr>
-          <p:cNvSpPr txBox="1"/>
-          <p:nvPr/>
-        </p:nvSpPr>
-        <p:spPr>
-          <a:xfrm>
-            <a:off x="914400" y="4953000"/>
-            <a:ext cx="10414000" cy="355600"/>
-          </a:xfrm>
-          <a:prstGeom prst="rect">
-            <a:avLst/>
-          </a:prstGeom>
-          <a:noFill/>
-        </p:spPr>
-        <p:txBody>
-          <a:bodyPr vert="horz" wrap="square" lIns="0" tIns="0" rIns="0" bIns="0" rtlCol="0">
-            <a:noAutofit/>
-          </a:bodyPr>
-          <a:lstStyle/>
-          <a:p>
-            <a:r>
-              <a:rPr lang="en-US" sz="2000" b="1">
-                <a:solidFill>
-                  <a:srgbClr val="FFFFFF"/>
-                </a:solidFill>
-                <a:latin typeface="Calibri" panose="020F0502020204030204" pitchFamily="34" charset="0"/>
-              </a:rPr>
-              <a:t>The instructor waived Gmail, so we removed it from .mcp.json.</a:t>
+              <a:t>With no earlier context, each skill downloaded 3 new items in the right format and rebuilt index.json.</a:t>
             </a:r>
           </a:p>
         </p:txBody>
@@ -10367,7 +10560,7 @@
     </p:spTree>
     <p:extLst>
       <p:ext uri="{BB962C8B-B14F-4D97-AF65-F5344CB8AC3E}">
-        <p14:creationId xmlns:p14="http://schemas.microsoft.com/office/powerpoint/2010/main" val="2418284707"/>
+        <p14:creationId xmlns:p14="http://schemas.microsoft.com/office/powerpoint/2010/main" val="3455007977"/>
       </p:ext>
     </p:extLst>
   </p:cSld>

</xml_diff>

<commit_message>
Slide 9: add download-github and download-slack skill cards
</commit_message>
<xml_diff>
--- a/presentation/project.pptx
+++ b/presentation/project.pptx
@@ -9961,8 +9961,8 @@
         </p:nvSpPr>
         <p:spPr>
           <a:xfrm>
-            <a:off x="609600" y="1270000"/>
-            <a:ext cx="5334000" cy="2413000"/>
+            <a:off x="609600" y="1219200"/>
+            <a:ext cx="5334000" cy="1676400"/>
           </a:xfrm>
           <a:prstGeom prst="roundRect">
             <a:avLst>
@@ -10031,8 +10031,8 @@
         </p:nvSpPr>
         <p:spPr>
           <a:xfrm>
-            <a:off x="863600" y="1524000"/>
-            <a:ext cx="4826000" cy="431800"/>
+            <a:off x="863600" y="1371600"/>
+            <a:ext cx="4826000" cy="381000"/>
           </a:xfrm>
           <a:prstGeom prst="rect">
             <a:avLst/>
@@ -10071,8 +10071,8 @@
         </p:nvSpPr>
         <p:spPr>
           <a:xfrm>
-            <a:off x="863600" y="2108200"/>
-            <a:ext cx="4826000" cy="330200"/>
+            <a:off x="863600" y="1803400"/>
+            <a:ext cx="4826000" cy="304800"/>
           </a:xfrm>
           <a:prstGeom prst="rect">
             <a:avLst/>
@@ -10111,8 +10111,8 @@
         </p:nvSpPr>
         <p:spPr>
           <a:xfrm>
-            <a:off x="863600" y="2667000"/>
-            <a:ext cx="4826000" cy="279400"/>
+            <a:off x="863600" y="2184400"/>
+            <a:ext cx="4826000" cy="254000"/>
           </a:xfrm>
           <a:prstGeom prst="rect">
             <a:avLst/>
@@ -10151,8 +10151,8 @@
         </p:nvSpPr>
         <p:spPr>
           <a:xfrm>
-            <a:off x="863600" y="2971800"/>
-            <a:ext cx="4826000" cy="330200"/>
+            <a:off x="863600" y="2463800"/>
+            <a:ext cx="4826000" cy="304800"/>
           </a:xfrm>
           <a:prstGeom prst="rect">
             <a:avLst/>
@@ -10191,8 +10191,8 @@
         </p:nvSpPr>
         <p:spPr>
           <a:xfrm>
-            <a:off x="6248400" y="1270000"/>
-            <a:ext cx="5334000" cy="2413000"/>
+            <a:off x="6248400" y="1219200"/>
+            <a:ext cx="5334000" cy="1676400"/>
           </a:xfrm>
           <a:prstGeom prst="roundRect">
             <a:avLst>
@@ -10261,8 +10261,8 @@
         </p:nvSpPr>
         <p:spPr>
           <a:xfrm>
-            <a:off x="6502400" y="1524000"/>
-            <a:ext cx="4826000" cy="431800"/>
+            <a:off x="6502400" y="1371600"/>
+            <a:ext cx="4826000" cy="381000"/>
           </a:xfrm>
           <a:prstGeom prst="rect">
             <a:avLst/>
@@ -10301,8 +10301,8 @@
         </p:nvSpPr>
         <p:spPr>
           <a:xfrm>
-            <a:off x="6502400" y="2108200"/>
-            <a:ext cx="4826000" cy="330200"/>
+            <a:off x="6502400" y="1803400"/>
+            <a:ext cx="4826000" cy="304800"/>
           </a:xfrm>
           <a:prstGeom prst="rect">
             <a:avLst/>
@@ -10341,8 +10341,8 @@
         </p:nvSpPr>
         <p:spPr>
           <a:xfrm>
-            <a:off x="6502400" y="2667000"/>
-            <a:ext cx="4826000" cy="279400"/>
+            <a:off x="6502400" y="2184400"/>
+            <a:ext cx="4826000" cy="254000"/>
           </a:xfrm>
           <a:prstGeom prst="rect">
             <a:avLst/>
@@ -10381,8 +10381,8 @@
         </p:nvSpPr>
         <p:spPr>
           <a:xfrm>
-            <a:off x="6502400" y="2971800"/>
-            <a:ext cx="4826000" cy="330200"/>
+            <a:off x="6502400" y="2463800"/>
+            <a:ext cx="4826000" cy="304800"/>
           </a:xfrm>
           <a:prstGeom prst="rect">
             <a:avLst/>
@@ -10421,8 +10421,8 @@
         </p:nvSpPr>
         <p:spPr>
           <a:xfrm>
-            <a:off x="609600" y="4013200"/>
-            <a:ext cx="10972800" cy="1397000"/>
+            <a:off x="609600" y="4978400"/>
+            <a:ext cx="10972800" cy="1219200"/>
           </a:xfrm>
           <a:prstGeom prst="roundRect">
             <a:avLst>
@@ -10491,7 +10491,7 @@
         </p:nvSpPr>
         <p:spPr>
           <a:xfrm>
-            <a:off x="914400" y="4241800"/>
+            <a:off x="914400" y="5156200"/>
             <a:ext cx="10414000" cy="381000"/>
           </a:xfrm>
           <a:prstGeom prst="rect">
@@ -10531,7 +10531,7 @@
         </p:nvSpPr>
         <p:spPr>
           <a:xfrm>
-            <a:off x="914400" y="4724400"/>
+            <a:off x="914400" y="5613400"/>
             <a:ext cx="10414000" cy="558800"/>
           </a:xfrm>
           <a:prstGeom prst="rect">
@@ -10552,7 +10552,467 @@
                 </a:solidFill>
                 <a:latin typeface="Calibri" panose="020F0502020204030204" pitchFamily="34" charset="0"/>
               </a:rPr>
-              <a:t>With no earlier context, each skill downloaded 3 new items in the right format and rebuilt index.json.</a:t>
+              <a:t>With no earlier context, each skill downloaded new items in the right format and rebuilt index.json.</a:t>
+            </a:r>
+          </a:p>
+        </p:txBody>
+      </p:sp>
+      <p:sp>
+        <p:nvSpPr>
+          <p:cNvPr id="16" name="Rectangle: Rounded Corners 15">
+            <a:extLst>
+              <a:ext uri="{FF2B5EF4-FFF2-40B4-BE49-F238E27FC236}">
+                <a16:creationId xmlns:a16="http://schemas.microsoft.com/office/drawing/2014/main" id="{964798BC-60A8-2A6B-3762-8791AF042940}"/>
+              </a:ext>
+            </a:extLst>
+          </p:cNvPr>
+          <p:cNvSpPr/>
+          <p:nvPr/>
+        </p:nvSpPr>
+        <p:spPr>
+          <a:xfrm>
+            <a:off x="609600" y="3073400"/>
+            <a:ext cx="5334000" cy="1676400"/>
+          </a:xfrm>
+          <a:prstGeom prst="roundRect">
+            <a:avLst>
+              <a:gd name="adj" fmla="val 8000"/>
+            </a:avLst>
+          </a:prstGeom>
+          <a:solidFill>
+            <a:srgbClr val="ECF2F5"/>
+          </a:solidFill>
+          <a:ln w="19050" cap="flat" cmpd="sng" algn="ctr">
+            <a:noFill/>
+            <a:prstDash val="solid"/>
+            <a:miter lim="800000"/>
+          </a:ln>
+          <a:effectLst/>
+          <a:extLst>
+            <a:ext uri="{91240B29-F687-4F45-9708-019B960494DF}">
+              <a14:hiddenLine xmlns:a14="http://schemas.microsoft.com/office/drawing/2010/main" w="19050" cap="flat" cmpd="sng" algn="ctr">
+                <a:solidFill>
+                  <a:schemeClr val="accent1">
+                    <a:shade val="15000"/>
+                  </a:schemeClr>
+                </a:solidFill>
+                <a:prstDash val="solid"/>
+                <a:miter lim="800000"/>
+              </a14:hiddenLine>
+            </a:ext>
+          </a:extLst>
+        </p:spPr>
+        <p:style>
+          <a:lnRef idx="2">
+            <a:schemeClr val="accent1">
+              <a:shade val="15000"/>
+            </a:schemeClr>
+          </a:lnRef>
+          <a:fillRef idx="1">
+            <a:schemeClr val="accent1"/>
+          </a:fillRef>
+          <a:effectRef idx="0">
+            <a:schemeClr val="accent1"/>
+          </a:effectRef>
+          <a:fontRef idx="minor">
+            <a:schemeClr val="lt1"/>
+          </a:fontRef>
+        </p:style>
+        <p:txBody>
+          <a:bodyPr rtlCol="0" anchor="ctr"/>
+          <a:lstStyle/>
+          <a:p>
+            <a:pPr algn="ctr"/>
+            <a:endParaRPr lang="en-US"/>
+          </a:p>
+        </p:txBody>
+      </p:sp>
+      <p:sp>
+        <p:nvSpPr>
+          <p:cNvPr id="17" name="TextBox 16">
+            <a:extLst>
+              <a:ext uri="{FF2B5EF4-FFF2-40B4-BE49-F238E27FC236}">
+                <a16:creationId xmlns:a16="http://schemas.microsoft.com/office/drawing/2014/main" id="{E258A80F-B1CB-375A-EF4F-EC514EC71FD5}"/>
+              </a:ext>
+            </a:extLst>
+          </p:cNvPr>
+          <p:cNvSpPr txBox="1"/>
+          <p:nvPr/>
+        </p:nvSpPr>
+        <p:spPr>
+          <a:xfrm>
+            <a:off x="863600" y="3225800"/>
+            <a:ext cx="4826000" cy="381000"/>
+          </a:xfrm>
+          <a:prstGeom prst="rect">
+            <a:avLst/>
+          </a:prstGeom>
+          <a:noFill/>
+        </p:spPr>
+        <p:txBody>
+          <a:bodyPr vert="horz" wrap="square" lIns="0" tIns="0" rIns="0" bIns="0" rtlCol="0">
+            <a:noAutofit/>
+          </a:bodyPr>
+          <a:lstStyle/>
+          <a:p>
+            <a:r>
+              <a:rPr lang="en-US" sz="2400" b="1">
+                <a:solidFill>
+                  <a:srgbClr val="1F7A8C"/>
+                </a:solidFill>
+                <a:latin typeface="Courier New" panose="02070309020205020404" pitchFamily="49" charset="0"/>
+              </a:rPr>
+              <a:t>download-github</a:t>
+            </a:r>
+          </a:p>
+        </p:txBody>
+      </p:sp>
+      <p:sp>
+        <p:nvSpPr>
+          <p:cNvPr id="18" name="TextBox 17">
+            <a:extLst>
+              <a:ext uri="{FF2B5EF4-FFF2-40B4-BE49-F238E27FC236}">
+                <a16:creationId xmlns:a16="http://schemas.microsoft.com/office/drawing/2014/main" id="{D0E1D3B9-E5EC-F844-5320-75E68D4C6ABE}"/>
+              </a:ext>
+            </a:extLst>
+          </p:cNvPr>
+          <p:cNvSpPr txBox="1"/>
+          <p:nvPr/>
+        </p:nvSpPr>
+        <p:spPr>
+          <a:xfrm>
+            <a:off x="863600" y="3657600"/>
+            <a:ext cx="4826000" cy="304800"/>
+          </a:xfrm>
+          <a:prstGeom prst="rect">
+            <a:avLst/>
+          </a:prstGeom>
+          <a:noFill/>
+        </p:spPr>
+        <p:txBody>
+          <a:bodyPr vert="horz" wrap="square" lIns="0" tIns="0" rIns="0" bIns="0" rtlCol="0">
+            <a:noAutofit/>
+          </a:bodyPr>
+          <a:lstStyle/>
+          <a:p>
+            <a:r>
+              <a:rPr lang="en-US" sz="1700">
+                <a:solidFill>
+                  <a:srgbClr val="1B2631"/>
+                </a:solidFill>
+                <a:latin typeface="Calibri" panose="020F0502020204030204" pitchFamily="34" charset="0"/>
+              </a:rPr>
+              <a:t>Saves GitHub issues to dataExports/github/</a:t>
+            </a:r>
+          </a:p>
+        </p:txBody>
+      </p:sp>
+      <p:sp>
+        <p:nvSpPr>
+          <p:cNvPr id="19" name="TextBox 18">
+            <a:extLst>
+              <a:ext uri="{FF2B5EF4-FFF2-40B4-BE49-F238E27FC236}">
+                <a16:creationId xmlns:a16="http://schemas.microsoft.com/office/drawing/2014/main" id="{90B29EDE-604E-6000-38E1-D76ABF9CD756}"/>
+              </a:ext>
+            </a:extLst>
+          </p:cNvPr>
+          <p:cNvSpPr txBox="1"/>
+          <p:nvPr/>
+        </p:nvSpPr>
+        <p:spPr>
+          <a:xfrm>
+            <a:off x="863600" y="4038600"/>
+            <a:ext cx="4826000" cy="254000"/>
+          </a:xfrm>
+          <a:prstGeom prst="rect">
+            <a:avLst/>
+          </a:prstGeom>
+          <a:noFill/>
+        </p:spPr>
+        <p:txBody>
+          <a:bodyPr vert="horz" wrap="square" lIns="0" tIns="0" rIns="0" bIns="0" rtlCol="0">
+            <a:noAutofit/>
+          </a:bodyPr>
+          <a:lstStyle/>
+          <a:p>
+            <a:r>
+              <a:rPr lang="en-US" sz="1400">
+                <a:solidFill>
+                  <a:srgbClr val="5D6D7E"/>
+                </a:solidFill>
+                <a:latin typeface="Calibri" panose="020F0502020204030204" pitchFamily="34" charset="0"/>
+              </a:rPr>
+              <a:t>Example request:</a:t>
+            </a:r>
+          </a:p>
+        </p:txBody>
+      </p:sp>
+      <p:sp>
+        <p:nvSpPr>
+          <p:cNvPr id="20" name="TextBox 19">
+            <a:extLst>
+              <a:ext uri="{FF2B5EF4-FFF2-40B4-BE49-F238E27FC236}">
+                <a16:creationId xmlns:a16="http://schemas.microsoft.com/office/drawing/2014/main" id="{8CB64BA7-C785-CC93-9591-FB4C6F5E4B53}"/>
+              </a:ext>
+            </a:extLst>
+          </p:cNvPr>
+          <p:cNvSpPr txBox="1"/>
+          <p:nvPr/>
+        </p:nvSpPr>
+        <p:spPr>
+          <a:xfrm>
+            <a:off x="863600" y="4318000"/>
+            <a:ext cx="4826000" cy="304800"/>
+          </a:xfrm>
+          <a:prstGeom prst="rect">
+            <a:avLst/>
+          </a:prstGeom>
+          <a:noFill/>
+        </p:spPr>
+        <p:txBody>
+          <a:bodyPr vert="horz" wrap="square" lIns="0" tIns="0" rIns="0" bIns="0" rtlCol="0">
+            <a:noAutofit/>
+          </a:bodyPr>
+          <a:lstStyle/>
+          <a:p>
+            <a:r>
+              <a:rPr lang="en-US" sz="1700">
+                <a:solidFill>
+                  <a:srgbClr val="1B2631"/>
+                </a:solidFill>
+                <a:latin typeface="Calibri" panose="020F0502020204030204" pitchFamily="34" charset="0"/>
+              </a:rPr>
+              <a:t>“Download the issues in mcp-services-dashboard”</a:t>
+            </a:r>
+          </a:p>
+        </p:txBody>
+      </p:sp>
+      <p:sp>
+        <p:nvSpPr>
+          <p:cNvPr id="21" name="Rectangle: Rounded Corners 20">
+            <a:extLst>
+              <a:ext uri="{FF2B5EF4-FFF2-40B4-BE49-F238E27FC236}">
+                <a16:creationId xmlns:a16="http://schemas.microsoft.com/office/drawing/2014/main" id="{4971CC0F-AD4C-4531-2200-7E624FCA8D8B}"/>
+              </a:ext>
+            </a:extLst>
+          </p:cNvPr>
+          <p:cNvSpPr/>
+          <p:nvPr/>
+        </p:nvSpPr>
+        <p:spPr>
+          <a:xfrm>
+            <a:off x="6248400" y="3073400"/>
+            <a:ext cx="5334000" cy="1676400"/>
+          </a:xfrm>
+          <a:prstGeom prst="roundRect">
+            <a:avLst>
+              <a:gd name="adj" fmla="val 8000"/>
+            </a:avLst>
+          </a:prstGeom>
+          <a:solidFill>
+            <a:srgbClr val="ECF2F5"/>
+          </a:solidFill>
+          <a:ln w="19050" cap="flat" cmpd="sng" algn="ctr">
+            <a:noFill/>
+            <a:prstDash val="solid"/>
+            <a:miter lim="800000"/>
+          </a:ln>
+          <a:effectLst/>
+          <a:extLst>
+            <a:ext uri="{91240B29-F687-4F45-9708-019B960494DF}">
+              <a14:hiddenLine xmlns:a14="http://schemas.microsoft.com/office/drawing/2010/main" w="19050" cap="flat" cmpd="sng" algn="ctr">
+                <a:solidFill>
+                  <a:schemeClr val="accent1">
+                    <a:shade val="15000"/>
+                  </a:schemeClr>
+                </a:solidFill>
+                <a:prstDash val="solid"/>
+                <a:miter lim="800000"/>
+              </a14:hiddenLine>
+            </a:ext>
+          </a:extLst>
+        </p:spPr>
+        <p:style>
+          <a:lnRef idx="2">
+            <a:schemeClr val="accent1">
+              <a:shade val="15000"/>
+            </a:schemeClr>
+          </a:lnRef>
+          <a:fillRef idx="1">
+            <a:schemeClr val="accent1"/>
+          </a:fillRef>
+          <a:effectRef idx="0">
+            <a:schemeClr val="accent1"/>
+          </a:effectRef>
+          <a:fontRef idx="minor">
+            <a:schemeClr val="lt1"/>
+          </a:fontRef>
+        </p:style>
+        <p:txBody>
+          <a:bodyPr rtlCol="0" anchor="ctr"/>
+          <a:lstStyle/>
+          <a:p>
+            <a:pPr algn="ctr"/>
+            <a:endParaRPr lang="en-US"/>
+          </a:p>
+        </p:txBody>
+      </p:sp>
+      <p:sp>
+        <p:nvSpPr>
+          <p:cNvPr id="22" name="TextBox 21">
+            <a:extLst>
+              <a:ext uri="{FF2B5EF4-FFF2-40B4-BE49-F238E27FC236}">
+                <a16:creationId xmlns:a16="http://schemas.microsoft.com/office/drawing/2014/main" id="{8D9EA557-57E5-6F24-C6B5-BED5DB1C3E87}"/>
+              </a:ext>
+            </a:extLst>
+          </p:cNvPr>
+          <p:cNvSpPr txBox="1"/>
+          <p:nvPr/>
+        </p:nvSpPr>
+        <p:spPr>
+          <a:xfrm>
+            <a:off x="6502400" y="3225800"/>
+            <a:ext cx="4826000" cy="381000"/>
+          </a:xfrm>
+          <a:prstGeom prst="rect">
+            <a:avLst/>
+          </a:prstGeom>
+          <a:noFill/>
+        </p:spPr>
+        <p:txBody>
+          <a:bodyPr vert="horz" wrap="square" lIns="0" tIns="0" rIns="0" bIns="0" rtlCol="0">
+            <a:noAutofit/>
+          </a:bodyPr>
+          <a:lstStyle/>
+          <a:p>
+            <a:r>
+              <a:rPr lang="en-US" sz="2400" b="1">
+                <a:solidFill>
+                  <a:srgbClr val="1F7A8C"/>
+                </a:solidFill>
+                <a:latin typeface="Courier New" panose="02070309020205020404" pitchFamily="49" charset="0"/>
+              </a:rPr>
+              <a:t>download-slack</a:t>
+            </a:r>
+          </a:p>
+        </p:txBody>
+      </p:sp>
+      <p:sp>
+        <p:nvSpPr>
+          <p:cNvPr id="23" name="TextBox 22">
+            <a:extLst>
+              <a:ext uri="{FF2B5EF4-FFF2-40B4-BE49-F238E27FC236}">
+                <a16:creationId xmlns:a16="http://schemas.microsoft.com/office/drawing/2014/main" id="{972DB654-5D56-9D12-1135-62B07599BE61}"/>
+              </a:ext>
+            </a:extLst>
+          </p:cNvPr>
+          <p:cNvSpPr txBox="1"/>
+          <p:nvPr/>
+        </p:nvSpPr>
+        <p:spPr>
+          <a:xfrm>
+            <a:off x="6502400" y="3657600"/>
+            <a:ext cx="4826000" cy="304800"/>
+          </a:xfrm>
+          <a:prstGeom prst="rect">
+            <a:avLst/>
+          </a:prstGeom>
+          <a:noFill/>
+        </p:spPr>
+        <p:txBody>
+          <a:bodyPr vert="horz" wrap="square" lIns="0" tIns="0" rIns="0" bIns="0" rtlCol="0">
+            <a:noAutofit/>
+          </a:bodyPr>
+          <a:lstStyle/>
+          <a:p>
+            <a:r>
+              <a:rPr lang="en-US" sz="1700">
+                <a:solidFill>
+                  <a:srgbClr val="1B2631"/>
+                </a:solidFill>
+                <a:latin typeface="Calibri" panose="020F0502020204030204" pitchFamily="34" charset="0"/>
+              </a:rPr>
+              <a:t>Saves Slack messages to dataExports/slack/</a:t>
+            </a:r>
+          </a:p>
+        </p:txBody>
+      </p:sp>
+      <p:sp>
+        <p:nvSpPr>
+          <p:cNvPr id="24" name="TextBox 23">
+            <a:extLst>
+              <a:ext uri="{FF2B5EF4-FFF2-40B4-BE49-F238E27FC236}">
+                <a16:creationId xmlns:a16="http://schemas.microsoft.com/office/drawing/2014/main" id="{015002A0-1DE7-2ED6-F903-F8262E05153B}"/>
+              </a:ext>
+            </a:extLst>
+          </p:cNvPr>
+          <p:cNvSpPr txBox="1"/>
+          <p:nvPr/>
+        </p:nvSpPr>
+        <p:spPr>
+          <a:xfrm>
+            <a:off x="6502400" y="4038600"/>
+            <a:ext cx="4826000" cy="254000"/>
+          </a:xfrm>
+          <a:prstGeom prst="rect">
+            <a:avLst/>
+          </a:prstGeom>
+          <a:noFill/>
+        </p:spPr>
+        <p:txBody>
+          <a:bodyPr vert="horz" wrap="square" lIns="0" tIns="0" rIns="0" bIns="0" rtlCol="0">
+            <a:noAutofit/>
+          </a:bodyPr>
+          <a:lstStyle/>
+          <a:p>
+            <a:r>
+              <a:rPr lang="en-US" sz="1400">
+                <a:solidFill>
+                  <a:srgbClr val="5D6D7E"/>
+                </a:solidFill>
+                <a:latin typeface="Calibri" panose="020F0502020204030204" pitchFamily="34" charset="0"/>
+              </a:rPr>
+              <a:t>Example request:</a:t>
+            </a:r>
+          </a:p>
+        </p:txBody>
+      </p:sp>
+      <p:sp>
+        <p:nvSpPr>
+          <p:cNvPr id="25" name="TextBox 24">
+            <a:extLst>
+              <a:ext uri="{FF2B5EF4-FFF2-40B4-BE49-F238E27FC236}">
+                <a16:creationId xmlns:a16="http://schemas.microsoft.com/office/drawing/2014/main" id="{B238AF4F-5D23-8672-76A7-BA03B10241E4}"/>
+              </a:ext>
+            </a:extLst>
+          </p:cNvPr>
+          <p:cNvSpPr txBox="1"/>
+          <p:nvPr/>
+        </p:nvSpPr>
+        <p:spPr>
+          <a:xfrm>
+            <a:off x="6502400" y="4318000"/>
+            <a:ext cx="4826000" cy="304800"/>
+          </a:xfrm>
+          <a:prstGeom prst="rect">
+            <a:avLst/>
+          </a:prstGeom>
+          <a:noFill/>
+        </p:spPr>
+        <p:txBody>
+          <a:bodyPr vert="horz" wrap="square" lIns="0" tIns="0" rIns="0" bIns="0" rtlCol="0">
+            <a:noAutofit/>
+          </a:bodyPr>
+          <a:lstStyle/>
+          <a:p>
+            <a:r>
+              <a:rPr lang="en-US" sz="1700">
+                <a:solidFill>
+                  <a:srgbClr val="1B2631"/>
+                </a:solidFill>
+                <a:latin typeface="Calibri" panose="020F0502020204030204" pitchFamily="34" charset="0"/>
+              </a:rPr>
+              <a:t>“Download today’s Slack messages”</a:t>
             </a:r>
           </a:p>
         </p:txBody>

</xml_diff>